<commit_message>
feat(api): integra monitoreo publicable y surveyMonkey offline
</commit_message>
<xml_diff>
--- a/api/inst/plantillas/plantilla_16_9.pptx
+++ b/api/inst/plantillas/plantilla_16_9.pptx
@@ -792,7 +792,7 @@
 </file>
 
 <file path=ppt/slideLayouts/slideLayout1.xml><?xml version="1.0" encoding="utf-8"?>
-<p:sldLayout xmlns:a="http://schemas.openxmlformats.org/drawingml/2006/main" xmlns:r="http://schemas.openxmlformats.org/officeDocument/2006/relationships" xmlns:p="http://schemas.openxmlformats.org/presentationml/2006/main" matchingName="Portada" preserve="1" userDrawn="1">
+<p:sldLayout xmlns:a="http://schemas.openxmlformats.org/drawingml/2006/main" xmlns:ns3="http://schemas.microsoft.com/office/drawing/2014/main" xmlns:p="http://schemas.openxmlformats.org/presentationml/2006/main" xmlns:p14="http://schemas.microsoft.com/office/powerpoint/2010/main" xmlns:p15="http://schemas.microsoft.com/office/powerpoint/2012/main" xmlns:r="http://schemas.openxmlformats.org/officeDocument/2006/relationships" matchingName="Portada" preserve="1" userDrawn="1">
   <p:cSld name="Title Slide">
     <p:spTree>
       <p:nvGrpSpPr>
@@ -847,14 +847,14 @@
                 <a:spcPts val="0"/>
               </a:spcAft>
               <a:buClr>
-                <a:srgbClr val="002060"/>
+                <a:srgbClr val="081F5C"/>
               </a:buClr>
               <a:buSzPts val="4000"/>
               <a:buFont typeface="Arial"/>
               <a:buNone/>
-              <a:defRPr sz="2500" b="1">
+              <a:defRPr sz="2400" b="1">
                 <a:solidFill>
-                  <a:srgbClr val="002060"/>
+                  <a:srgbClr val="CA5651"/>
                 </a:solidFill>
                 <a:latin typeface="Arial"/>
                 <a:ea typeface="Arial"/>
@@ -874,7 +874,12 @@
               </a:spcAft>
               <a:buSzPts val="1400"/>
               <a:buNone/>
-              <a:defRPr/>
+              <a:defRPr sz="2400" b="1">
+                <a:latin typeface="Arial"/>
+                <a:solidFill>
+                  <a:srgbClr val="CA5651"/>
+                </a:solidFill>
+              </a:defRPr>
             </a:lvl2pPr>
             <a:lvl3pPr lvl="2" algn="l">
               <a:lnSpc>
@@ -888,7 +893,12 @@
               </a:spcAft>
               <a:buSzPts val="1400"/>
               <a:buNone/>
-              <a:defRPr/>
+              <a:defRPr sz="2400" b="1">
+                <a:latin typeface="Arial"/>
+                <a:solidFill>
+                  <a:srgbClr val="CA5651"/>
+                </a:solidFill>
+              </a:defRPr>
             </a:lvl3pPr>
             <a:lvl4pPr lvl="3" algn="l">
               <a:lnSpc>
@@ -902,7 +912,12 @@
               </a:spcAft>
               <a:buSzPts val="1400"/>
               <a:buNone/>
-              <a:defRPr/>
+              <a:defRPr sz="2400" b="1">
+                <a:latin typeface="Arial"/>
+                <a:solidFill>
+                  <a:srgbClr val="CA5651"/>
+                </a:solidFill>
+              </a:defRPr>
             </a:lvl4pPr>
             <a:lvl5pPr lvl="4" algn="l">
               <a:lnSpc>
@@ -916,7 +931,12 @@
               </a:spcAft>
               <a:buSzPts val="1400"/>
               <a:buNone/>
-              <a:defRPr/>
+              <a:defRPr sz="2400" b="1">
+                <a:latin typeface="Arial"/>
+                <a:solidFill>
+                  <a:srgbClr val="CA5651"/>
+                </a:solidFill>
+              </a:defRPr>
             </a:lvl5pPr>
             <a:lvl6pPr lvl="5" algn="l">
               <a:lnSpc>
@@ -930,7 +950,12 @@
               </a:spcAft>
               <a:buSzPts val="1400"/>
               <a:buNone/>
-              <a:defRPr/>
+              <a:defRPr sz="2400" b="1">
+                <a:latin typeface="Arial"/>
+                <a:solidFill>
+                  <a:srgbClr val="CA5651"/>
+                </a:solidFill>
+              </a:defRPr>
             </a:lvl6pPr>
             <a:lvl7pPr lvl="6" algn="l">
               <a:lnSpc>
@@ -944,7 +969,12 @@
               </a:spcAft>
               <a:buSzPts val="1400"/>
               <a:buNone/>
-              <a:defRPr/>
+              <a:defRPr sz="2400" b="1">
+                <a:latin typeface="Arial"/>
+                <a:solidFill>
+                  <a:srgbClr val="CA5651"/>
+                </a:solidFill>
+              </a:defRPr>
             </a:lvl7pPr>
             <a:lvl8pPr lvl="7" algn="l">
               <a:lnSpc>
@@ -958,7 +988,12 @@
               </a:spcAft>
               <a:buSzPts val="1400"/>
               <a:buNone/>
-              <a:defRPr/>
+              <a:defRPr sz="2400" b="1">
+                <a:latin typeface="Arial"/>
+                <a:solidFill>
+                  <a:srgbClr val="CA5651"/>
+                </a:solidFill>
+              </a:defRPr>
             </a:lvl8pPr>
             <a:lvl9pPr lvl="8" algn="l">
               <a:lnSpc>
@@ -972,15 +1007,30 @@
               </a:spcAft>
               <a:buSzPts val="1400"/>
               <a:buNone/>
-              <a:defRPr/>
+              <a:defRPr sz="2400" b="1">
+                <a:latin typeface="Arial"/>
+                <a:solidFill>
+                  <a:srgbClr val="CA5651"/>
+                </a:solidFill>
+              </a:defRPr>
             </a:lvl9pPr>
           </a:lstStyle>
           <a:p>
             <a:r>
-              <a:rPr lang="es-MX" dirty="0"/>
+              <a:rPr lang="es-MX" dirty="0" sz="2400" b="1">
+                <a:latin typeface="Arial"/>
+                <a:solidFill>
+                  <a:srgbClr val="CA5651"/>
+                </a:solidFill>
+              </a:rPr>
               <a:t>Haz clic para modificar el estilo de título del patrón</a:t>
             </a:r>
-            <a:endParaRPr dirty="0"/>
+            <a:endParaRPr dirty="0" sz="2400" b="1">
+              <a:latin typeface="Arial"/>
+              <a:solidFill>
+                <a:srgbClr val="CA5651"/>
+              </a:solidFill>
+            </a:endParaRPr>
           </a:p>
         </p:txBody>
       </p:sp>
@@ -1023,13 +1073,13 @@
                 <a:spcPts val="0"/>
               </a:spcAft>
               <a:buClr>
-                <a:srgbClr val="002060"/>
+                <a:srgbClr val="081F5C"/>
               </a:buClr>
               <a:buSzPts val="2000"/>
               <a:buNone/>
-              <a:defRPr sz="1800" b="0">
+              <a:defRPr sz="1600" b="1">
                 <a:solidFill>
-                  <a:srgbClr val="002060"/>
+                  <a:srgbClr val="85BB85"/>
                 </a:solidFill>
                 <a:latin typeface="Arial"/>
                 <a:ea typeface="Arial"/>
@@ -1052,7 +1102,12 @@
               </a:buClr>
               <a:buSzPts val="2000"/>
               <a:buNone/>
-              <a:defRPr sz="2000"/>
+              <a:defRPr sz="1600" b="1">
+                <a:latin typeface="Arial"/>
+                <a:solidFill>
+                  <a:srgbClr val="85BB85"/>
+                </a:solidFill>
+              </a:defRPr>
             </a:lvl2pPr>
             <a:lvl3pPr lvl="2" algn="ctr">
               <a:lnSpc>
@@ -1069,7 +1124,12 @@
               </a:buClr>
               <a:buSzPts val="1800"/>
               <a:buNone/>
-              <a:defRPr sz="1800"/>
+              <a:defRPr sz="1600" b="1">
+                <a:latin typeface="Arial"/>
+                <a:solidFill>
+                  <a:srgbClr val="85BB85"/>
+                </a:solidFill>
+              </a:defRPr>
             </a:lvl3pPr>
             <a:lvl4pPr lvl="3" algn="ctr">
               <a:lnSpc>
@@ -1086,7 +1146,12 @@
               </a:buClr>
               <a:buSzPts val="1600"/>
               <a:buNone/>
-              <a:defRPr sz="1600"/>
+              <a:defRPr sz="1600" b="1">
+                <a:latin typeface="Arial"/>
+                <a:solidFill>
+                  <a:srgbClr val="85BB85"/>
+                </a:solidFill>
+              </a:defRPr>
             </a:lvl4pPr>
             <a:lvl5pPr lvl="4" algn="ctr">
               <a:lnSpc>
@@ -1103,7 +1168,12 @@
               </a:buClr>
               <a:buSzPts val="1600"/>
               <a:buNone/>
-              <a:defRPr sz="1600"/>
+              <a:defRPr sz="1600" b="1">
+                <a:latin typeface="Arial"/>
+                <a:solidFill>
+                  <a:srgbClr val="85BB85"/>
+                </a:solidFill>
+              </a:defRPr>
             </a:lvl5pPr>
             <a:lvl6pPr lvl="5" algn="ctr">
               <a:lnSpc>
@@ -1120,7 +1190,12 @@
               </a:buClr>
               <a:buSzPts val="1600"/>
               <a:buNone/>
-              <a:defRPr sz="1600"/>
+              <a:defRPr sz="1600" b="1">
+                <a:latin typeface="Arial"/>
+                <a:solidFill>
+                  <a:srgbClr val="85BB85"/>
+                </a:solidFill>
+              </a:defRPr>
             </a:lvl6pPr>
             <a:lvl7pPr lvl="6" algn="ctr">
               <a:lnSpc>
@@ -1137,7 +1212,12 @@
               </a:buClr>
               <a:buSzPts val="1600"/>
               <a:buNone/>
-              <a:defRPr sz="1600"/>
+              <a:defRPr sz="1600" b="1">
+                <a:latin typeface="Arial"/>
+                <a:solidFill>
+                  <a:srgbClr val="85BB85"/>
+                </a:solidFill>
+              </a:defRPr>
             </a:lvl7pPr>
             <a:lvl8pPr lvl="7" algn="ctr">
               <a:lnSpc>
@@ -1154,7 +1234,12 @@
               </a:buClr>
               <a:buSzPts val="1600"/>
               <a:buNone/>
-              <a:defRPr sz="1600"/>
+              <a:defRPr sz="1600" b="1">
+                <a:latin typeface="Arial"/>
+                <a:solidFill>
+                  <a:srgbClr val="85BB85"/>
+                </a:solidFill>
+              </a:defRPr>
             </a:lvl8pPr>
             <a:lvl9pPr lvl="8" algn="ctr">
               <a:lnSpc>
@@ -1171,15 +1256,30 @@
               </a:buClr>
               <a:buSzPts val="1600"/>
               <a:buNone/>
-              <a:defRPr sz="1600"/>
+              <a:defRPr sz="1600" b="1">
+                <a:latin typeface="Arial"/>
+                <a:solidFill>
+                  <a:srgbClr val="85BB85"/>
+                </a:solidFill>
+              </a:defRPr>
             </a:lvl9pPr>
           </a:lstStyle>
           <a:p>
             <a:r>
-              <a:rPr lang="es-MX" dirty="0"/>
+              <a:rPr lang="es-MX" dirty="0" sz="1600" b="1">
+                <a:latin typeface="Arial"/>
+                <a:solidFill>
+                  <a:srgbClr val="85BB85"/>
+                </a:solidFill>
+              </a:rPr>
               <a:t>Haz clic para editar el estilo de subtítulo del patrón</a:t>
             </a:r>
-            <a:endParaRPr lang="es-ES" dirty="0"/>
+            <a:endParaRPr lang="es-ES" dirty="0" sz="1600" b="1">
+              <a:latin typeface="Arial"/>
+              <a:solidFill>
+                <a:srgbClr val="85BB85"/>
+              </a:solidFill>
+            </a:endParaRPr>
           </a:p>
         </p:txBody>
       </p:sp>
@@ -1254,7 +1354,7 @@
           <a:noFill/>
           <a:ln w="19050" cap="flat" cmpd="sng">
             <a:solidFill>
-              <a:srgbClr val="DA4C4C"/>
+              <a:srgbClr val="CA5651"/>
             </a:solidFill>
             <a:prstDash val="solid"/>
             <a:miter lim="800000"/>
@@ -1268,7 +1368,7 @@
           <p:cNvPr id="8" name="Marcador de fecha 7">
             <a:extLst>
               <a:ext uri="{FF2B5EF4-FFF2-40B4-BE49-F238E27FC236}">
-                <a16:creationId xmlns:a16="http://schemas.microsoft.com/office/drawing/2014/main" id="{8EAA0CDE-8D3A-4141-BE76-3F60022B4BC8}"/>
+                <ns3:creationId id="{8EAA0CDE-8D3A-4141-BE76-3F60022B4BC8}"/>
               </a:ext>
             </a:extLst>
           </p:cNvPr>
@@ -1297,7 +1397,7 @@
             <a:lvl1pPr algn="ctr">
               <a:defRPr lang="es-PE" sz="1800" smtClean="0">
                 <a:solidFill>
-                  <a:srgbClr val="002060"/>
+                  <a:srgbClr val="081F5C"/>
                 </a:solidFill>
               </a:defRPr>
             </a:lvl1pPr>
@@ -1308,7 +1408,7 @@
                 <a:spcPct val="90000"/>
               </a:lnSpc>
               <a:buClr>
-                <a:srgbClr val="002060"/>
+                <a:srgbClr val="081F5C"/>
               </a:buClr>
               <a:buSzPts val="1800"/>
             </a:pPr>
@@ -1319,7 +1419,7 @@
                   <a:spcPct val="90000"/>
                 </a:lnSpc>
                 <a:buClr>
-                  <a:srgbClr val="002060"/>
+                  <a:srgbClr val="081F5C"/>
                 </a:buClr>
                 <a:buSzPts val="1800"/>
               </a:pPr>
@@ -1334,7 +1434,7 @@
           <p:cNvPr id="4" name="Text Placeholder 3">
             <a:extLst>
               <a:ext uri="{FF2B5EF4-FFF2-40B4-BE49-F238E27FC236}">
-                <a16:creationId xmlns:a16="http://schemas.microsoft.com/office/drawing/2014/main" id="{F2FE6A90-009D-6D0B-149C-A6854054CF48}"/>
+                <ns3:creationId id="{F2FE6A90-009D-6D0B-149C-A6854054CF48}"/>
               </a:ext>
             </a:extLst>
           </p:cNvPr>
@@ -1411,7 +1511,7 @@
     </p:spTree>
     <p:extLst>
       <p:ext uri="{BB962C8B-B14F-4D97-AF65-F5344CB8AC3E}">
-        <p14:creationId xmlns:p14="http://schemas.microsoft.com/office/powerpoint/2010/main" val="1185629166"/>
+        <p14:creationId val="1185629166"/>
       </p:ext>
     </p:extLst>
   </p:cSld>
@@ -1420,15 +1520,15 @@
   </p:clrMapOvr>
   <p:extLst>
     <p:ext uri="{DCECCB84-F9BA-43D5-87BE-67443E8EF086}">
-      <p15:sldGuideLst xmlns:p15="http://schemas.microsoft.com/office/powerpoint/2012/main">
+      <p15:sldGuideLst>
         <p15:guide id="1" orient="horz" pos="391">
           <p15:clr>
-            <a:srgbClr val="FBAE40"/>
+            <a:srgbClr val="E4A34C"/>
           </p15:clr>
         </p15:guide>
         <p15:guide id="2" pos="483">
           <p15:clr>
-            <a:srgbClr val="FBAE40"/>
+            <a:srgbClr val="E4A34C"/>
           </p15:clr>
         </p15:guide>
       </p15:sldGuideLst>
@@ -1438,7 +1538,7 @@
 </file>
 
 <file path=ppt/slideLayouts/slideLayout10.xml><?xml version="1.0" encoding="utf-8"?>
-<p:sldLayout xmlns:a="http://schemas.openxmlformats.org/drawingml/2006/main" xmlns:r="http://schemas.openxmlformats.org/officeDocument/2006/relationships" xmlns:p="http://schemas.openxmlformats.org/presentationml/2006/main" preserve="1" userDrawn="1">
+<p:sldLayout xmlns:a="http://schemas.openxmlformats.org/drawingml/2006/main" xmlns:ns2="http://schemas.microsoft.com/office/drawing/2014/main" xmlns:p="http://schemas.openxmlformats.org/presentationml/2006/main" xmlns:p14="http://schemas.microsoft.com/office/powerpoint/2010/main" xmlns:r="http://schemas.openxmlformats.org/officeDocument/2006/relationships" preserve="1" userDrawn="1">
   <p:cSld name="right_grafico_texto">
     <p:spTree>
       <p:nvGrpSpPr>
@@ -1459,7 +1559,7 @@
           <p:cNvPr id="2" name="Title 1">
             <a:extLst>
               <a:ext uri="{FF2B5EF4-FFF2-40B4-BE49-F238E27FC236}">
-                <a16:creationId xmlns:a16="http://schemas.microsoft.com/office/drawing/2014/main" id="{E161B1F1-83C7-C3F7-BF29-A7102FCCB32B}"/>
+                <ns2:creationId id="{E161B1F1-83C7-C3F7-BF29-A7102FCCB32B}"/>
               </a:ext>
             </a:extLst>
           </p:cNvPr>
@@ -1481,10 +1581,20 @@
           <a:lstStyle/>
           <a:p>
             <a:r>
-              <a:rPr lang="en-US" dirty="0"/>
+              <a:rPr lang="en-US" dirty="0" sz="2400" b="1">
+                <a:latin typeface="Arial"/>
+                <a:solidFill>
+                  <a:srgbClr val="CA5651"/>
+                </a:solidFill>
+              </a:rPr>
               <a:t>Click to edit Master title style</a:t>
             </a:r>
-            <a:endParaRPr lang="en-PE" dirty="0"/>
+            <a:endParaRPr lang="en-PE" dirty="0" sz="2400" b="1">
+              <a:latin typeface="Arial"/>
+              <a:solidFill>
+                <a:srgbClr val="CA5651"/>
+              </a:solidFill>
+            </a:endParaRPr>
           </a:p>
         </p:txBody>
       </p:sp>
@@ -1493,7 +1603,7 @@
           <p:cNvPr id="6" name="Google Shape;66;p47">
             <a:extLst>
               <a:ext uri="{FF2B5EF4-FFF2-40B4-BE49-F238E27FC236}">
-                <a16:creationId xmlns:a16="http://schemas.microsoft.com/office/drawing/2014/main" id="{323E205B-F311-E78C-D6A8-0122851FE66D}"/>
+                <ns2:creationId id="{323E205B-F311-E78C-D6A8-0122851FE66D}"/>
               </a:ext>
             </a:extLst>
           </p:cNvPr>
@@ -1526,7 +1636,7 @@
           <p:cNvPr id="8" name="Picture Placeholder 7">
             <a:extLst>
               <a:ext uri="{FF2B5EF4-FFF2-40B4-BE49-F238E27FC236}">
-                <a16:creationId xmlns:a16="http://schemas.microsoft.com/office/drawing/2014/main" id="{0FB415E7-8491-13B2-0A7D-52BF25F1EA60}"/>
+                <ns2:creationId id="{0FB415E7-8491-13B2-0A7D-52BF25F1EA60}"/>
               </a:ext>
             </a:extLst>
           </p:cNvPr>
@@ -1556,7 +1666,7 @@
           <p:cNvPr id="10" name="Text Placeholder 9">
             <a:extLst>
               <a:ext uri="{FF2B5EF4-FFF2-40B4-BE49-F238E27FC236}">
-                <a16:creationId xmlns:a16="http://schemas.microsoft.com/office/drawing/2014/main" id="{F97A4842-2728-8D6A-D2DE-B6E2062C5B64}"/>
+                <ns2:creationId id="{F97A4842-2728-8D6A-D2DE-B6E2062C5B64}"/>
               </a:ext>
             </a:extLst>
           </p:cNvPr>
@@ -1637,7 +1747,7 @@
           <p:cNvPr id="11" name="Text Placeholder 9">
             <a:extLst>
               <a:ext uri="{FF2B5EF4-FFF2-40B4-BE49-F238E27FC236}">
-                <a16:creationId xmlns:a16="http://schemas.microsoft.com/office/drawing/2014/main" id="{6C0D5753-3F06-573C-2A52-4C7432C384AB}"/>
+                <ns2:creationId id="{6C0D5753-3F06-573C-2A52-4C7432C384AB}"/>
               </a:ext>
             </a:extLst>
           </p:cNvPr>
@@ -1718,7 +1828,7 @@
           <p:cNvPr id="5" name="Text Placeholder 4">
             <a:extLst>
               <a:ext uri="{FF2B5EF4-FFF2-40B4-BE49-F238E27FC236}">
-                <a16:creationId xmlns:a16="http://schemas.microsoft.com/office/drawing/2014/main" id="{435BB44E-5E11-7069-DE99-4EBA2B80A9FF}"/>
+                <ns2:creationId id="{435BB44E-5E11-7069-DE99-4EBA2B80A9FF}"/>
               </a:ext>
             </a:extLst>
           </p:cNvPr>
@@ -1779,7 +1889,7 @@
     </p:spTree>
     <p:extLst>
       <p:ext uri="{BB962C8B-B14F-4D97-AF65-F5344CB8AC3E}">
-        <p14:creationId xmlns:p14="http://schemas.microsoft.com/office/powerpoint/2010/main" val="1783954932"/>
+        <p14:creationId val="1783954932"/>
       </p:ext>
     </p:extLst>
   </p:cSld>
@@ -1790,7 +1900,7 @@
 </file>
 
 <file path=ppt/slideLayouts/slideLayout11.xml><?xml version="1.0" encoding="utf-8"?>
-<p:sldLayout xmlns:a="http://schemas.openxmlformats.org/drawingml/2006/main" xmlns:r="http://schemas.openxmlformats.org/officeDocument/2006/relationships" xmlns:p="http://schemas.openxmlformats.org/presentationml/2006/main" preserve="1" userDrawn="1">
+<p:sldLayout xmlns:a="http://schemas.openxmlformats.org/drawingml/2006/main" xmlns:ns2="http://schemas.microsoft.com/office/drawing/2014/main" xmlns:p="http://schemas.openxmlformats.org/presentationml/2006/main" xmlns:p14="http://schemas.microsoft.com/office/powerpoint/2010/main" xmlns:r="http://schemas.openxmlformats.org/officeDocument/2006/relationships" preserve="1" userDrawn="1">
   <p:cSld name="left_grafico_texto">
     <p:spTree>
       <p:nvGrpSpPr>
@@ -1811,7 +1921,7 @@
           <p:cNvPr id="2" name="Title 1">
             <a:extLst>
               <a:ext uri="{FF2B5EF4-FFF2-40B4-BE49-F238E27FC236}">
-                <a16:creationId xmlns:a16="http://schemas.microsoft.com/office/drawing/2014/main" id="{E161B1F1-83C7-C3F7-BF29-A7102FCCB32B}"/>
+                <ns2:creationId id="{E161B1F1-83C7-C3F7-BF29-A7102FCCB32B}"/>
               </a:ext>
             </a:extLst>
           </p:cNvPr>
@@ -1833,10 +1943,20 @@
           <a:lstStyle/>
           <a:p>
             <a:r>
-              <a:rPr lang="en-US" dirty="0"/>
+              <a:rPr lang="en-US" dirty="0" sz="2400" b="1">
+                <a:latin typeface="Arial"/>
+                <a:solidFill>
+                  <a:srgbClr val="CA5651"/>
+                </a:solidFill>
+              </a:rPr>
               <a:t>Click to edit Master title style</a:t>
             </a:r>
-            <a:endParaRPr lang="en-PE" dirty="0"/>
+            <a:endParaRPr lang="en-PE" dirty="0" sz="2400" b="1">
+              <a:latin typeface="Arial"/>
+              <a:solidFill>
+                <a:srgbClr val="CA5651"/>
+              </a:solidFill>
+            </a:endParaRPr>
           </a:p>
         </p:txBody>
       </p:sp>
@@ -1845,7 +1965,7 @@
           <p:cNvPr id="6" name="Google Shape;66;p47">
             <a:extLst>
               <a:ext uri="{FF2B5EF4-FFF2-40B4-BE49-F238E27FC236}">
-                <a16:creationId xmlns:a16="http://schemas.microsoft.com/office/drawing/2014/main" id="{323E205B-F311-E78C-D6A8-0122851FE66D}"/>
+                <ns2:creationId id="{323E205B-F311-E78C-D6A8-0122851FE66D}"/>
               </a:ext>
             </a:extLst>
           </p:cNvPr>
@@ -1878,7 +1998,7 @@
           <p:cNvPr id="8" name="Picture Placeholder 7">
             <a:extLst>
               <a:ext uri="{FF2B5EF4-FFF2-40B4-BE49-F238E27FC236}">
-                <a16:creationId xmlns:a16="http://schemas.microsoft.com/office/drawing/2014/main" id="{0FB415E7-8491-13B2-0A7D-52BF25F1EA60}"/>
+                <ns2:creationId id="{0FB415E7-8491-13B2-0A7D-52BF25F1EA60}"/>
               </a:ext>
             </a:extLst>
           </p:cNvPr>
@@ -1908,7 +2028,7 @@
           <p:cNvPr id="10" name="Text Placeholder 9">
             <a:extLst>
               <a:ext uri="{FF2B5EF4-FFF2-40B4-BE49-F238E27FC236}">
-                <a16:creationId xmlns:a16="http://schemas.microsoft.com/office/drawing/2014/main" id="{F97A4842-2728-8D6A-D2DE-B6E2062C5B64}"/>
+                <ns2:creationId id="{F97A4842-2728-8D6A-D2DE-B6E2062C5B64}"/>
               </a:ext>
             </a:extLst>
           </p:cNvPr>
@@ -1989,7 +2109,7 @@
           <p:cNvPr id="11" name="Text Placeholder 9">
             <a:extLst>
               <a:ext uri="{FF2B5EF4-FFF2-40B4-BE49-F238E27FC236}">
-                <a16:creationId xmlns:a16="http://schemas.microsoft.com/office/drawing/2014/main" id="{6C0D5753-3F06-573C-2A52-4C7432C384AB}"/>
+                <ns2:creationId id="{6C0D5753-3F06-573C-2A52-4C7432C384AB}"/>
               </a:ext>
             </a:extLst>
           </p:cNvPr>
@@ -2070,7 +2190,7 @@
           <p:cNvPr id="5" name="Text Placeholder 4">
             <a:extLst>
               <a:ext uri="{FF2B5EF4-FFF2-40B4-BE49-F238E27FC236}">
-                <a16:creationId xmlns:a16="http://schemas.microsoft.com/office/drawing/2014/main" id="{435BB44E-5E11-7069-DE99-4EBA2B80A9FF}"/>
+                <ns2:creationId id="{435BB44E-5E11-7069-DE99-4EBA2B80A9FF}"/>
               </a:ext>
             </a:extLst>
           </p:cNvPr>
@@ -2131,7 +2251,7 @@
     </p:spTree>
     <p:extLst>
       <p:ext uri="{BB962C8B-B14F-4D97-AF65-F5344CB8AC3E}">
-        <p14:creationId xmlns:p14="http://schemas.microsoft.com/office/powerpoint/2010/main" val="778155013"/>
+        <p14:creationId val="778155013"/>
       </p:ext>
     </p:extLst>
   </p:cSld>
@@ -2142,7 +2262,7 @@
 </file>
 
 <file path=ppt/slideLayouts/slideLayout12.xml><?xml version="1.0" encoding="utf-8"?>
-<p:sldLayout xmlns:a="http://schemas.openxmlformats.org/drawingml/2006/main" xmlns:r="http://schemas.openxmlformats.org/officeDocument/2006/relationships" xmlns:p="http://schemas.openxmlformats.org/presentationml/2006/main" preserve="1" userDrawn="1">
+<p:sldLayout xmlns:a="http://schemas.openxmlformats.org/drawingml/2006/main" xmlns:ns2="http://schemas.microsoft.com/office/drawing/2014/main" xmlns:p="http://schemas.openxmlformats.org/presentationml/2006/main" xmlns:p14="http://schemas.microsoft.com/office/powerpoint/2010/main" xmlns:r="http://schemas.openxmlformats.org/officeDocument/2006/relationships" preserve="1" userDrawn="1">
   <p:cSld name="left_2graficos_texto">
     <p:spTree>
       <p:nvGrpSpPr>
@@ -2163,7 +2283,7 @@
           <p:cNvPr id="2" name="Title 1">
             <a:extLst>
               <a:ext uri="{FF2B5EF4-FFF2-40B4-BE49-F238E27FC236}">
-                <a16:creationId xmlns:a16="http://schemas.microsoft.com/office/drawing/2014/main" id="{E161B1F1-83C7-C3F7-BF29-A7102FCCB32B}"/>
+                <ns2:creationId id="{E161B1F1-83C7-C3F7-BF29-A7102FCCB32B}"/>
               </a:ext>
             </a:extLst>
           </p:cNvPr>
@@ -2185,10 +2305,20 @@
           <a:lstStyle/>
           <a:p>
             <a:r>
-              <a:rPr lang="en-US" dirty="0"/>
+              <a:rPr lang="en-US" dirty="0" sz="2400" b="1">
+                <a:latin typeface="Arial"/>
+                <a:solidFill>
+                  <a:srgbClr val="CA5651"/>
+                </a:solidFill>
+              </a:rPr>
               <a:t>Click to edit Master title style</a:t>
             </a:r>
-            <a:endParaRPr lang="en-PE" dirty="0"/>
+            <a:endParaRPr lang="en-PE" dirty="0" sz="2400" b="1">
+              <a:latin typeface="Arial"/>
+              <a:solidFill>
+                <a:srgbClr val="CA5651"/>
+              </a:solidFill>
+            </a:endParaRPr>
           </a:p>
         </p:txBody>
       </p:sp>
@@ -2197,7 +2327,7 @@
           <p:cNvPr id="6" name="Google Shape;66;p47">
             <a:extLst>
               <a:ext uri="{FF2B5EF4-FFF2-40B4-BE49-F238E27FC236}">
-                <a16:creationId xmlns:a16="http://schemas.microsoft.com/office/drawing/2014/main" id="{323E205B-F311-E78C-D6A8-0122851FE66D}"/>
+                <ns2:creationId id="{323E205B-F311-E78C-D6A8-0122851FE66D}"/>
               </a:ext>
             </a:extLst>
           </p:cNvPr>
@@ -2230,7 +2360,7 @@
           <p:cNvPr id="8" name="Picture Placeholder 7">
             <a:extLst>
               <a:ext uri="{FF2B5EF4-FFF2-40B4-BE49-F238E27FC236}">
-                <a16:creationId xmlns:a16="http://schemas.microsoft.com/office/drawing/2014/main" id="{0FB415E7-8491-13B2-0A7D-52BF25F1EA60}"/>
+                <ns2:creationId id="{0FB415E7-8491-13B2-0A7D-52BF25F1EA60}"/>
               </a:ext>
             </a:extLst>
           </p:cNvPr>
@@ -2260,7 +2390,7 @@
           <p:cNvPr id="10" name="Text Placeholder 9">
             <a:extLst>
               <a:ext uri="{FF2B5EF4-FFF2-40B4-BE49-F238E27FC236}">
-                <a16:creationId xmlns:a16="http://schemas.microsoft.com/office/drawing/2014/main" id="{F97A4842-2728-8D6A-D2DE-B6E2062C5B64}"/>
+                <ns2:creationId id="{F97A4842-2728-8D6A-D2DE-B6E2062C5B64}"/>
               </a:ext>
             </a:extLst>
           </p:cNvPr>
@@ -2341,7 +2471,7 @@
           <p:cNvPr id="11" name="Text Placeholder 9">
             <a:extLst>
               <a:ext uri="{FF2B5EF4-FFF2-40B4-BE49-F238E27FC236}">
-                <a16:creationId xmlns:a16="http://schemas.microsoft.com/office/drawing/2014/main" id="{6C0D5753-3F06-573C-2A52-4C7432C384AB}"/>
+                <ns2:creationId id="{6C0D5753-3F06-573C-2A52-4C7432C384AB}"/>
               </a:ext>
             </a:extLst>
           </p:cNvPr>
@@ -2422,7 +2552,7 @@
           <p:cNvPr id="5" name="Text Placeholder 4">
             <a:extLst>
               <a:ext uri="{FF2B5EF4-FFF2-40B4-BE49-F238E27FC236}">
-                <a16:creationId xmlns:a16="http://schemas.microsoft.com/office/drawing/2014/main" id="{435BB44E-5E11-7069-DE99-4EBA2B80A9FF}"/>
+                <ns2:creationId id="{435BB44E-5E11-7069-DE99-4EBA2B80A9FF}"/>
               </a:ext>
             </a:extLst>
           </p:cNvPr>
@@ -2485,7 +2615,7 @@
           <p:cNvPr id="3" name="Picture Placeholder 7">
             <a:extLst>
               <a:ext uri="{FF2B5EF4-FFF2-40B4-BE49-F238E27FC236}">
-                <a16:creationId xmlns:a16="http://schemas.microsoft.com/office/drawing/2014/main" id="{A131479D-68A2-D884-02BA-6963681FAC31}"/>
+                <ns2:creationId id="{A131479D-68A2-D884-02BA-6963681FAC31}"/>
               </a:ext>
             </a:extLst>
           </p:cNvPr>
@@ -2513,7 +2643,7 @@
     </p:spTree>
     <p:extLst>
       <p:ext uri="{BB962C8B-B14F-4D97-AF65-F5344CB8AC3E}">
-        <p14:creationId xmlns:p14="http://schemas.microsoft.com/office/powerpoint/2010/main" val="2142224359"/>
+        <p14:creationId val="2142224359"/>
       </p:ext>
     </p:extLst>
   </p:cSld>
@@ -2524,7 +2654,7 @@
 </file>
 
 <file path=ppt/slideLayouts/slideLayout13.xml><?xml version="1.0" encoding="utf-8"?>
-<p:sldLayout xmlns:a="http://schemas.openxmlformats.org/drawingml/2006/main" xmlns:r="http://schemas.openxmlformats.org/officeDocument/2006/relationships" xmlns:p="http://schemas.openxmlformats.org/presentationml/2006/main" preserve="1" userDrawn="1">
+<p:sldLayout xmlns:a="http://schemas.openxmlformats.org/drawingml/2006/main" xmlns:ns2="http://schemas.microsoft.com/office/drawing/2014/main" xmlns:p="http://schemas.openxmlformats.org/presentationml/2006/main" xmlns:p14="http://schemas.microsoft.com/office/powerpoint/2010/main" xmlns:r="http://schemas.openxmlformats.org/officeDocument/2006/relationships" preserve="1" userDrawn="1">
   <p:cSld name="right_2graficos_texto">
     <p:spTree>
       <p:nvGrpSpPr>
@@ -2545,7 +2675,7 @@
           <p:cNvPr id="2" name="Title 1">
             <a:extLst>
               <a:ext uri="{FF2B5EF4-FFF2-40B4-BE49-F238E27FC236}">
-                <a16:creationId xmlns:a16="http://schemas.microsoft.com/office/drawing/2014/main" id="{E161B1F1-83C7-C3F7-BF29-A7102FCCB32B}"/>
+                <ns2:creationId id="{E161B1F1-83C7-C3F7-BF29-A7102FCCB32B}"/>
               </a:ext>
             </a:extLst>
           </p:cNvPr>
@@ -2567,10 +2697,20 @@
           <a:lstStyle/>
           <a:p>
             <a:r>
-              <a:rPr lang="en-US" dirty="0"/>
+              <a:rPr lang="en-US" dirty="0" sz="2400" b="1">
+                <a:latin typeface="Arial"/>
+                <a:solidFill>
+                  <a:srgbClr val="CA5651"/>
+                </a:solidFill>
+              </a:rPr>
               <a:t>Click to edit Master title style</a:t>
             </a:r>
-            <a:endParaRPr lang="en-PE" dirty="0"/>
+            <a:endParaRPr lang="en-PE" dirty="0" sz="2400" b="1">
+              <a:latin typeface="Arial"/>
+              <a:solidFill>
+                <a:srgbClr val="CA5651"/>
+              </a:solidFill>
+            </a:endParaRPr>
           </a:p>
         </p:txBody>
       </p:sp>
@@ -2579,7 +2719,7 @@
           <p:cNvPr id="6" name="Google Shape;66;p47">
             <a:extLst>
               <a:ext uri="{FF2B5EF4-FFF2-40B4-BE49-F238E27FC236}">
-                <a16:creationId xmlns:a16="http://schemas.microsoft.com/office/drawing/2014/main" id="{323E205B-F311-E78C-D6A8-0122851FE66D}"/>
+                <ns2:creationId id="{323E205B-F311-E78C-D6A8-0122851FE66D}"/>
               </a:ext>
             </a:extLst>
           </p:cNvPr>
@@ -2612,7 +2752,7 @@
           <p:cNvPr id="8" name="Picture Placeholder 7">
             <a:extLst>
               <a:ext uri="{FF2B5EF4-FFF2-40B4-BE49-F238E27FC236}">
-                <a16:creationId xmlns:a16="http://schemas.microsoft.com/office/drawing/2014/main" id="{0FB415E7-8491-13B2-0A7D-52BF25F1EA60}"/>
+                <ns2:creationId id="{0FB415E7-8491-13B2-0A7D-52BF25F1EA60}"/>
               </a:ext>
             </a:extLst>
           </p:cNvPr>
@@ -2642,7 +2782,7 @@
           <p:cNvPr id="10" name="Text Placeholder 9">
             <a:extLst>
               <a:ext uri="{FF2B5EF4-FFF2-40B4-BE49-F238E27FC236}">
-                <a16:creationId xmlns:a16="http://schemas.microsoft.com/office/drawing/2014/main" id="{F97A4842-2728-8D6A-D2DE-B6E2062C5B64}"/>
+                <ns2:creationId id="{F97A4842-2728-8D6A-D2DE-B6E2062C5B64}"/>
               </a:ext>
             </a:extLst>
           </p:cNvPr>
@@ -2723,7 +2863,7 @@
           <p:cNvPr id="11" name="Text Placeholder 9">
             <a:extLst>
               <a:ext uri="{FF2B5EF4-FFF2-40B4-BE49-F238E27FC236}">
-                <a16:creationId xmlns:a16="http://schemas.microsoft.com/office/drawing/2014/main" id="{6C0D5753-3F06-573C-2A52-4C7432C384AB}"/>
+                <ns2:creationId id="{6C0D5753-3F06-573C-2A52-4C7432C384AB}"/>
               </a:ext>
             </a:extLst>
           </p:cNvPr>
@@ -2804,7 +2944,7 @@
           <p:cNvPr id="5" name="Text Placeholder 4">
             <a:extLst>
               <a:ext uri="{FF2B5EF4-FFF2-40B4-BE49-F238E27FC236}">
-                <a16:creationId xmlns:a16="http://schemas.microsoft.com/office/drawing/2014/main" id="{435BB44E-5E11-7069-DE99-4EBA2B80A9FF}"/>
+                <ns2:creationId id="{435BB44E-5E11-7069-DE99-4EBA2B80A9FF}"/>
               </a:ext>
             </a:extLst>
           </p:cNvPr>
@@ -2867,7 +3007,7 @@
           <p:cNvPr id="3" name="Picture Placeholder 7">
             <a:extLst>
               <a:ext uri="{FF2B5EF4-FFF2-40B4-BE49-F238E27FC236}">
-                <a16:creationId xmlns:a16="http://schemas.microsoft.com/office/drawing/2014/main" id="{AC1445B0-35E6-144B-ABE2-439E7DA6759A}"/>
+                <ns2:creationId id="{AC1445B0-35E6-144B-ABE2-439E7DA6759A}"/>
               </a:ext>
             </a:extLst>
           </p:cNvPr>
@@ -2895,7 +3035,7 @@
     </p:spTree>
     <p:extLst>
       <p:ext uri="{BB962C8B-B14F-4D97-AF65-F5344CB8AC3E}">
-        <p14:creationId xmlns:p14="http://schemas.microsoft.com/office/powerpoint/2010/main" val="3212213227"/>
+        <p14:creationId val="3212213227"/>
       </p:ext>
     </p:extLst>
   </p:cSld>
@@ -2906,7 +3046,7 @@
 </file>
 
 <file path=ppt/slideLayouts/slideLayout14.xml><?xml version="1.0" encoding="utf-8"?>
-<p:sldLayout xmlns:a="http://schemas.openxmlformats.org/drawingml/2006/main" xmlns:r="http://schemas.openxmlformats.org/officeDocument/2006/relationships" xmlns:p="http://schemas.openxmlformats.org/presentationml/2006/main" showMasterSp="0" matchingName="Contraportada" preserve="1">
+<p:sldLayout xmlns:a="http://schemas.openxmlformats.org/drawingml/2006/main" xmlns:p="http://schemas.openxmlformats.org/presentationml/2006/main" xmlns:p14="http://schemas.microsoft.com/office/powerpoint/2010/main" xmlns:p15="http://schemas.microsoft.com/office/powerpoint/2012/main" xmlns:r="http://schemas.openxmlformats.org/officeDocument/2006/relationships" showMasterSp="0" matchingName="Contraportada" preserve="1">
   <p:cSld name="Contraportada">
     <p:spTree>
       <p:nvGrpSpPr>
@@ -3033,7 +3173,7 @@
               </a:pathLst>
             </a:custGeom>
             <a:solidFill>
-              <a:srgbClr val="002060"/>
+              <a:srgbClr val="081F5C"/>
             </a:solidFill>
             <a:ln>
               <a:noFill/>
@@ -3137,7 +3277,7 @@
               </a:pathLst>
             </a:custGeom>
             <a:solidFill>
-              <a:srgbClr val="002060"/>
+              <a:srgbClr val="081F5C"/>
             </a:solidFill>
             <a:ln>
               <a:noFill/>
@@ -3282,7 +3422,7 @@
               </a:pathLst>
             </a:custGeom>
             <a:solidFill>
-              <a:srgbClr val="002060"/>
+              <a:srgbClr val="081F5C"/>
             </a:solidFill>
             <a:ln>
               <a:noFill/>
@@ -3382,7 +3522,7 @@
               </a:pathLst>
             </a:custGeom>
             <a:solidFill>
-              <a:srgbClr val="002060"/>
+              <a:srgbClr val="081F5C"/>
             </a:solidFill>
             <a:ln>
               <a:noFill/>
@@ -3469,7 +3609,7 @@
               </a:pathLst>
             </a:custGeom>
             <a:solidFill>
-              <a:srgbClr val="002060"/>
+              <a:srgbClr val="081F5C"/>
             </a:solidFill>
             <a:ln>
               <a:noFill/>
@@ -3556,7 +3696,7 @@
               </a:pathLst>
             </a:custGeom>
             <a:solidFill>
-              <a:srgbClr val="002060"/>
+              <a:srgbClr val="081F5C"/>
             </a:solidFill>
             <a:ln>
               <a:noFill/>
@@ -3657,7 +3797,7 @@
               </a:pathLst>
             </a:custGeom>
             <a:solidFill>
-              <a:srgbClr val="002060"/>
+              <a:srgbClr val="081F5C"/>
             </a:solidFill>
             <a:ln>
               <a:noFill/>
@@ -3746,7 +3886,7 @@
               </a:pathLst>
             </a:custGeom>
             <a:solidFill>
-              <a:srgbClr val="002060"/>
+              <a:srgbClr val="081F5C"/>
             </a:solidFill>
             <a:ln>
               <a:noFill/>
@@ -3834,7 +3974,7 @@
               </a:pathLst>
             </a:custGeom>
             <a:solidFill>
-              <a:srgbClr val="002060"/>
+              <a:srgbClr val="081F5C"/>
             </a:solidFill>
             <a:ln>
               <a:noFill/>
@@ -3923,7 +4063,7 @@
               </a:pathLst>
             </a:custGeom>
             <a:solidFill>
-              <a:srgbClr val="002060"/>
+              <a:srgbClr val="081F5C"/>
             </a:solidFill>
             <a:ln>
               <a:noFill/>
@@ -4009,7 +4149,7 @@
               </a:pathLst>
             </a:custGeom>
             <a:solidFill>
-              <a:srgbClr val="002060"/>
+              <a:srgbClr val="081F5C"/>
             </a:solidFill>
             <a:ln>
               <a:noFill/>
@@ -4100,7 +4240,7 @@
               </a:pathLst>
             </a:custGeom>
             <a:solidFill>
-              <a:srgbClr val="002060"/>
+              <a:srgbClr val="081F5C"/>
             </a:solidFill>
             <a:ln>
               <a:noFill/>
@@ -4189,7 +4329,7 @@
               </a:pathLst>
             </a:custGeom>
             <a:solidFill>
-              <a:srgbClr val="002060"/>
+              <a:srgbClr val="081F5C"/>
             </a:solidFill>
             <a:ln>
               <a:noFill/>
@@ -4275,7 +4415,7 @@
               </a:pathLst>
             </a:custGeom>
             <a:solidFill>
-              <a:srgbClr val="002060"/>
+              <a:srgbClr val="081F5C"/>
             </a:solidFill>
             <a:ln>
               <a:noFill/>
@@ -4358,7 +4498,7 @@
               </a:pathLst>
             </a:custGeom>
             <a:solidFill>
-              <a:srgbClr val="002060"/>
+              <a:srgbClr val="081F5C"/>
             </a:solidFill>
             <a:ln>
               <a:noFill/>
@@ -4444,7 +4584,7 @@
               </a:pathLst>
             </a:custGeom>
             <a:solidFill>
-              <a:srgbClr val="002060"/>
+              <a:srgbClr val="081F5C"/>
             </a:solidFill>
             <a:ln>
               <a:noFill/>
@@ -4530,7 +4670,7 @@
               </a:pathLst>
             </a:custGeom>
             <a:solidFill>
-              <a:srgbClr val="002060"/>
+              <a:srgbClr val="081F5C"/>
             </a:solidFill>
             <a:ln>
               <a:noFill/>
@@ -4608,7 +4748,7 @@
               </a:pathLst>
             </a:custGeom>
             <a:solidFill>
-              <a:srgbClr val="002060"/>
+              <a:srgbClr val="081F5C"/>
             </a:solidFill>
             <a:ln>
               <a:noFill/>
@@ -4712,7 +4852,7 @@
               </a:pathLst>
             </a:custGeom>
             <a:solidFill>
-              <a:srgbClr val="002060"/>
+              <a:srgbClr val="081F5C"/>
             </a:solidFill>
             <a:ln>
               <a:noFill/>
@@ -4798,7 +4938,7 @@
               </a:pathLst>
             </a:custGeom>
             <a:solidFill>
-              <a:srgbClr val="002060"/>
+              <a:srgbClr val="081F5C"/>
             </a:solidFill>
             <a:ln>
               <a:noFill/>
@@ -4879,7 +5019,7 @@
               </a:pathLst>
             </a:custGeom>
             <a:solidFill>
-              <a:srgbClr val="002060"/>
+              <a:srgbClr val="081F5C"/>
             </a:solidFill>
             <a:ln>
               <a:noFill/>
@@ -4968,7 +5108,7 @@
               </a:pathLst>
             </a:custGeom>
             <a:solidFill>
-              <a:srgbClr val="002060"/>
+              <a:srgbClr val="081F5C"/>
             </a:solidFill>
             <a:ln>
               <a:noFill/>
@@ -5057,7 +5197,7 @@
               </a:pathLst>
             </a:custGeom>
             <a:solidFill>
-              <a:srgbClr val="002060"/>
+              <a:srgbClr val="081F5C"/>
             </a:solidFill>
             <a:ln>
               <a:noFill/>
@@ -5161,7 +5301,7 @@
               </a:pathLst>
             </a:custGeom>
             <a:solidFill>
-              <a:srgbClr val="002060"/>
+              <a:srgbClr val="081F5C"/>
             </a:solidFill>
             <a:ln>
               <a:noFill/>
@@ -5252,7 +5392,7 @@
               </a:pathLst>
             </a:custGeom>
             <a:solidFill>
-              <a:srgbClr val="002060"/>
+              <a:srgbClr val="081F5C"/>
             </a:solidFill>
             <a:ln>
               <a:noFill/>
@@ -5336,7 +5476,7 @@
               <a:buNone/>
               <a:defRPr sz="1200">
                 <a:solidFill>
-                  <a:srgbClr val="002060"/>
+                  <a:srgbClr val="081F5C"/>
                 </a:solidFill>
                 <a:latin typeface="Arial"/>
                 <a:ea typeface="Arial"/>
@@ -5504,7 +5644,7 @@
               <a:buNone/>
               <a:defRPr sz="1200">
                 <a:solidFill>
-                  <a:srgbClr val="002060"/>
+                  <a:srgbClr val="081F5C"/>
                 </a:solidFill>
                 <a:latin typeface="Arial"/>
                 <a:ea typeface="Arial"/>
@@ -5676,7 +5816,7 @@
               <a:buNone/>
               <a:defRPr sz="1200" b="0" i="0" u="none" strike="noStrike" cap="none">
                 <a:solidFill>
-                  <a:srgbClr val="002060"/>
+                  <a:srgbClr val="081F5C"/>
                 </a:solidFill>
                 <a:latin typeface="Arial"/>
                 <a:ea typeface="Arial"/>
@@ -5702,7 +5842,7 @@
               <a:buNone/>
               <a:defRPr sz="1200" b="0" i="0" u="none" strike="noStrike" cap="none">
                 <a:solidFill>
-                  <a:srgbClr val="002060"/>
+                  <a:srgbClr val="081F5C"/>
                 </a:solidFill>
                 <a:latin typeface="Arial"/>
                 <a:ea typeface="Arial"/>
@@ -5728,7 +5868,7 @@
               <a:buNone/>
               <a:defRPr sz="1200" b="0" i="0" u="none" strike="noStrike" cap="none">
                 <a:solidFill>
-                  <a:srgbClr val="002060"/>
+                  <a:srgbClr val="081F5C"/>
                 </a:solidFill>
                 <a:latin typeface="Arial"/>
                 <a:ea typeface="Arial"/>
@@ -5754,7 +5894,7 @@
               <a:buNone/>
               <a:defRPr sz="1200" b="0" i="0" u="none" strike="noStrike" cap="none">
                 <a:solidFill>
-                  <a:srgbClr val="002060"/>
+                  <a:srgbClr val="081F5C"/>
                 </a:solidFill>
                 <a:latin typeface="Arial"/>
                 <a:ea typeface="Arial"/>
@@ -5780,7 +5920,7 @@
               <a:buNone/>
               <a:defRPr sz="1200" b="0" i="0" u="none" strike="noStrike" cap="none">
                 <a:solidFill>
-                  <a:srgbClr val="002060"/>
+                  <a:srgbClr val="081F5C"/>
                 </a:solidFill>
                 <a:latin typeface="Arial"/>
                 <a:ea typeface="Arial"/>
@@ -5806,7 +5946,7 @@
               <a:buNone/>
               <a:defRPr sz="1200" b="0" i="0" u="none" strike="noStrike" cap="none">
                 <a:solidFill>
-                  <a:srgbClr val="002060"/>
+                  <a:srgbClr val="081F5C"/>
                 </a:solidFill>
                 <a:latin typeface="Arial"/>
                 <a:ea typeface="Arial"/>
@@ -5832,7 +5972,7 @@
               <a:buNone/>
               <a:defRPr sz="1200" b="0" i="0" u="none" strike="noStrike" cap="none">
                 <a:solidFill>
-                  <a:srgbClr val="002060"/>
+                  <a:srgbClr val="081F5C"/>
                 </a:solidFill>
                 <a:latin typeface="Arial"/>
                 <a:ea typeface="Arial"/>
@@ -5858,7 +5998,7 @@
               <a:buNone/>
               <a:defRPr sz="1200" b="0" i="0" u="none" strike="noStrike" cap="none">
                 <a:solidFill>
-                  <a:srgbClr val="002060"/>
+                  <a:srgbClr val="081F5C"/>
                 </a:solidFill>
                 <a:latin typeface="Arial"/>
                 <a:ea typeface="Arial"/>
@@ -5884,7 +6024,7 @@
               <a:buNone/>
               <a:defRPr sz="1200" b="0" i="0" u="none" strike="noStrike" cap="none">
                 <a:solidFill>
-                  <a:srgbClr val="002060"/>
+                  <a:srgbClr val="081F5C"/>
                 </a:solidFill>
                 <a:latin typeface="Arial"/>
                 <a:ea typeface="Arial"/>
@@ -5928,7 +6068,7 @@
           <a:noFill/>
           <a:ln w="57150" cap="flat" cmpd="sng">
             <a:solidFill>
-              <a:srgbClr val="DA4C4C"/>
+              <a:srgbClr val="CA5651"/>
             </a:solidFill>
             <a:prstDash val="solid"/>
             <a:miter lim="800000"/>
@@ -5940,7 +6080,7 @@
     </p:spTree>
     <p:extLst>
       <p:ext uri="{BB962C8B-B14F-4D97-AF65-F5344CB8AC3E}">
-        <p14:creationId xmlns:p14="http://schemas.microsoft.com/office/powerpoint/2010/main" val="808851633"/>
+        <p14:creationId val="808851633"/>
       </p:ext>
     </p:extLst>
   </p:cSld>
@@ -5949,15 +6089,15 @@
   </p:clrMapOvr>
   <p:extLst>
     <p:ext uri="{DCECCB84-F9BA-43D5-87BE-67443E8EF086}">
-      <p15:sldGuideLst xmlns:p15="http://schemas.microsoft.com/office/powerpoint/2012/main">
+      <p15:sldGuideLst>
         <p15:guide id="1" orient="horz" pos="4088">
           <p15:clr>
-            <a:srgbClr val="FBAE40"/>
+            <a:srgbClr val="E4A34C"/>
           </p15:clr>
         </p15:guide>
         <p15:guide id="2" pos="7446">
           <p15:clr>
-            <a:srgbClr val="FBAE40"/>
+            <a:srgbClr val="E4A34C"/>
           </p15:clr>
         </p15:guide>
       </p15:sldGuideLst>
@@ -5967,7 +6107,7 @@
 </file>
 
 <file path=ppt/slideLayouts/slideLayout15.xml><?xml version="1.0" encoding="utf-8"?>
-<p:sldLayout xmlns:a="http://schemas.openxmlformats.org/drawingml/2006/main" xmlns:r="http://schemas.openxmlformats.org/officeDocument/2006/relationships" xmlns:p="http://schemas.openxmlformats.org/presentationml/2006/main" matchingName="3_Índice" preserve="1" userDrawn="1">
+<p:sldLayout xmlns:a="http://schemas.openxmlformats.org/drawingml/2006/main" xmlns:ns2="http://schemas.microsoft.com/office/drawing/2014/main" xmlns:p="http://schemas.openxmlformats.org/presentationml/2006/main" xmlns:p14="http://schemas.microsoft.com/office/powerpoint/2010/main" xmlns:p15="http://schemas.microsoft.com/office/powerpoint/2012/main" xmlns:r="http://schemas.openxmlformats.org/officeDocument/2006/relationships" matchingName="3_Índice" preserve="1" userDrawn="1">
   <p:cSld name="Indice">
     <p:bg>
       <p:bgPr>
@@ -5996,7 +6136,7 @@
           <p:cNvPr id="88" name="Grupo 87">
             <a:extLst>
               <a:ext uri="{FF2B5EF4-FFF2-40B4-BE49-F238E27FC236}">
-                <a16:creationId xmlns:a16="http://schemas.microsoft.com/office/drawing/2014/main" id="{C8DC7646-E791-9F27-BA79-8929004D514B}"/>
+                <ns2:creationId id="{C8DC7646-E791-9F27-BA79-8929004D514B}"/>
               </a:ext>
             </a:extLst>
           </p:cNvPr>
@@ -6016,7 +6156,7 @@
             <p:cNvPr id="85" name="Grupo 84">
               <a:extLst>
                 <a:ext uri="{FF2B5EF4-FFF2-40B4-BE49-F238E27FC236}">
-                  <a16:creationId xmlns:a16="http://schemas.microsoft.com/office/drawing/2014/main" id="{8EB232BD-112B-5AB4-5630-4141328FD263}"/>
+                  <ns2:creationId id="{8EB232BD-112B-5AB4-5630-4141328FD263}"/>
                 </a:ext>
               </a:extLst>
             </p:cNvPr>
@@ -6036,7 +6176,7 @@
               <p:cNvPr id="84" name="Grupo 83">
                 <a:extLst>
                   <a:ext uri="{FF2B5EF4-FFF2-40B4-BE49-F238E27FC236}">
-                    <a16:creationId xmlns:a16="http://schemas.microsoft.com/office/drawing/2014/main" id="{B5F24069-AAA5-AE58-1308-4351580F56DD}"/>
+                    <ns2:creationId id="{B5F24069-AAA5-AE58-1308-4351580F56DD}"/>
                   </a:ext>
                 </a:extLst>
               </p:cNvPr>
@@ -6056,7 +6196,7 @@
                 <p:cNvPr id="74" name="Rectángulo 73">
                   <a:extLst>
                     <a:ext uri="{FF2B5EF4-FFF2-40B4-BE49-F238E27FC236}">
-                      <a16:creationId xmlns:a16="http://schemas.microsoft.com/office/drawing/2014/main" id="{4DAEADB5-BD80-B4E0-C93E-F551DF1C267A}"/>
+                      <ns2:creationId id="{4DAEADB5-BD80-B4E0-C93E-F551DF1C267A}"/>
                     </a:ext>
                   </a:extLst>
                 </p:cNvPr>
@@ -6110,7 +6250,7 @@
                 <p:cNvPr id="83" name="Grupo 82">
                   <a:extLst>
                     <a:ext uri="{FF2B5EF4-FFF2-40B4-BE49-F238E27FC236}">
-                      <a16:creationId xmlns:a16="http://schemas.microsoft.com/office/drawing/2014/main" id="{0F389C32-6385-A385-B044-AF13FCBBF525}"/>
+                      <ns2:creationId id="{0F389C32-6385-A385-B044-AF13FCBBF525}"/>
                     </a:ext>
                   </a:extLst>
                 </p:cNvPr>
@@ -6130,7 +6270,7 @@
                   <p:cNvPr id="78" name="Grupo 77">
                     <a:extLst>
                       <a:ext uri="{FF2B5EF4-FFF2-40B4-BE49-F238E27FC236}">
-                        <a16:creationId xmlns:a16="http://schemas.microsoft.com/office/drawing/2014/main" id="{85CC3AB5-5C01-EFBA-25B6-2F16CAD812EF}"/>
+                        <ns2:creationId id="{85CC3AB5-5C01-EFBA-25B6-2F16CAD812EF}"/>
                       </a:ext>
                     </a:extLst>
                   </p:cNvPr>
@@ -6288,7 +6428,7 @@
                       </a:pathLst>
                     </a:custGeom>
                     <a:solidFill>
-                      <a:srgbClr val="6D95D1"/>
+                      <a:srgbClr val="7594CC"/>
                     </a:solidFill>
                     <a:ln>
                       <a:noFill/>
@@ -6740,7 +6880,7 @@
                   <p:cNvPr id="77" name="Grupo 76">
                     <a:extLst>
                       <a:ext uri="{FF2B5EF4-FFF2-40B4-BE49-F238E27FC236}">
-                        <a16:creationId xmlns:a16="http://schemas.microsoft.com/office/drawing/2014/main" id="{7585FE78-9191-1F4E-E077-18CBBD6214A8}"/>
+                        <ns2:creationId id="{7585FE78-9191-1F4E-E077-18CBBD6214A8}"/>
                       </a:ext>
                     </a:extLst>
                   </p:cNvPr>
@@ -6898,7 +7038,7 @@
                       </a:pathLst>
                     </a:custGeom>
                     <a:solidFill>
-                      <a:srgbClr val="F09F34"/>
+                      <a:srgbClr val="E4A34C"/>
                     </a:solidFill>
                     <a:ln>
                       <a:noFill/>
@@ -7484,7 +7624,7 @@
                   <p:cNvPr id="76" name="Grupo 75">
                     <a:extLst>
                       <a:ext uri="{FF2B5EF4-FFF2-40B4-BE49-F238E27FC236}">
-                        <a16:creationId xmlns:a16="http://schemas.microsoft.com/office/drawing/2014/main" id="{68430AA9-969E-B49C-1E01-7021AE3D77D9}"/>
+                        <ns2:creationId id="{68430AA9-969E-B49C-1E01-7021AE3D77D9}"/>
                       </a:ext>
                     </a:extLst>
                   </p:cNvPr>
@@ -7642,7 +7782,7 @@
                       </a:pathLst>
                     </a:custGeom>
                     <a:solidFill>
-                      <a:srgbClr val="9987D9"/>
+                      <a:srgbClr val="9688D3"/>
                     </a:solidFill>
                     <a:ln>
                       <a:noFill/>
@@ -8408,7 +8548,7 @@
                   <p:cNvPr id="75" name="Grupo 74">
                     <a:extLst>
                       <a:ext uri="{FF2B5EF4-FFF2-40B4-BE49-F238E27FC236}">
-                        <a16:creationId xmlns:a16="http://schemas.microsoft.com/office/drawing/2014/main" id="{5502EE12-F1AA-52B5-F2D6-9E9780236EE6}"/>
+                        <ns2:creationId id="{5502EE12-F1AA-52B5-F2D6-9E9780236EE6}"/>
                       </a:ext>
                     </a:extLst>
                   </p:cNvPr>
@@ -8566,7 +8706,7 @@
                       </a:pathLst>
                     </a:custGeom>
                     <a:solidFill>
-                      <a:srgbClr val="F5D142"/>
+                      <a:srgbClr val="EFD25E"/>
                     </a:solidFill>
                     <a:ln>
                       <a:noFill/>
@@ -9079,7 +9219,7 @@
                   <p:cNvPr id="82" name="Grupo 81">
                     <a:extLst>
                       <a:ext uri="{FF2B5EF4-FFF2-40B4-BE49-F238E27FC236}">
-                        <a16:creationId xmlns:a16="http://schemas.microsoft.com/office/drawing/2014/main" id="{75F81D91-57EA-7CD4-76C4-C2E056786758}"/>
+                        <ns2:creationId id="{75F81D91-57EA-7CD4-76C4-C2E056786758}"/>
                       </a:ext>
                     </a:extLst>
                   </p:cNvPr>
@@ -9099,7 +9239,7 @@
                     <p:cNvPr id="67" name="Google Shape;162;p4">
                       <a:extLst>
                         <a:ext uri="{FF2B5EF4-FFF2-40B4-BE49-F238E27FC236}">
-                          <a16:creationId xmlns:a16="http://schemas.microsoft.com/office/drawing/2014/main" id="{8C053564-E291-7036-9849-E3D5EAAB9F97}"/>
+                          <ns2:creationId id="{8C053564-E291-7036-9849-E3D5EAAB9F97}"/>
                         </a:ext>
                       </a:extLst>
                     </p:cNvPr>
@@ -9115,7 +9255,7 @@
                       <a:avLst/>
                     </a:prstGeom>
                     <a:solidFill>
-                      <a:srgbClr val="E8E8E8"/>
+                      <a:srgbClr val="D8D8D8"/>
                     </a:solidFill>
                     <a:ln>
                       <a:noFill/>
@@ -9138,7 +9278,7 @@
                           <a:spcPts val="0"/>
                         </a:spcAft>
                         <a:buClr>
-                          <a:srgbClr val="002060"/>
+                          <a:srgbClr val="081F5C"/>
                         </a:buClr>
                         <a:buSzPts val="1867"/>
                         <a:buFont typeface="Arial"/>
@@ -9147,7 +9287,7 @@
                       <a:r>
                         <a:rPr lang="es-ES" sz="1867" b="0" i="0" u="none" strike="noStrike" cap="none">
                           <a:solidFill>
-                            <a:srgbClr val="002060"/>
+                            <a:srgbClr val="081F5C"/>
                           </a:solidFill>
                           <a:latin typeface="Arial"/>
                           <a:ea typeface="Arial"/>
@@ -9165,7 +9305,7 @@
                     <p:cNvPr id="68" name="Google Shape;163;p4">
                       <a:extLst>
                         <a:ext uri="{FF2B5EF4-FFF2-40B4-BE49-F238E27FC236}">
-                          <a16:creationId xmlns:a16="http://schemas.microsoft.com/office/drawing/2014/main" id="{BAA31CF6-DA67-A9AD-C346-F155E1114D4A}"/>
+                          <ns2:creationId id="{BAA31CF6-DA67-A9AD-C346-F155E1114D4A}"/>
                         </a:ext>
                       </a:extLst>
                     </p:cNvPr>
@@ -9181,7 +9321,7 @@
                       <a:avLst/>
                     </a:prstGeom>
                     <a:solidFill>
-                      <a:srgbClr val="DA4C4C"/>
+                      <a:srgbClr val="CA5651"/>
                     </a:solidFill>
                     <a:ln>
                       <a:noFill/>
@@ -9239,7 +9379,7 @@
                     <p:cNvPr id="69" name="Google Shape;164;p4">
                       <a:extLst>
                         <a:ext uri="{FF2B5EF4-FFF2-40B4-BE49-F238E27FC236}">
-                          <a16:creationId xmlns:a16="http://schemas.microsoft.com/office/drawing/2014/main" id="{925F0D0F-F8C0-6958-4120-B4EC17533519}"/>
+                          <ns2:creationId id="{925F0D0F-F8C0-6958-4120-B4EC17533519}"/>
                         </a:ext>
                       </a:extLst>
                     </p:cNvPr>
@@ -9255,7 +9395,7 @@
                       <a:avLst/>
                     </a:prstGeom>
                     <a:solidFill>
-                      <a:srgbClr val="E8E8E8"/>
+                      <a:srgbClr val="D8D8D8"/>
                     </a:solidFill>
                     <a:ln>
                       <a:noFill/>
@@ -9278,7 +9418,7 @@
                           <a:spcPts val="0"/>
                         </a:spcAft>
                         <a:buClr>
-                          <a:srgbClr val="002060"/>
+                          <a:srgbClr val="081F5C"/>
                         </a:buClr>
                         <a:buSzPts val="1867"/>
                         <a:buFont typeface="Arial"/>
@@ -9287,7 +9427,7 @@
                       <a:r>
                         <a:rPr lang="es-ES" sz="1867" b="0" i="0" u="none" strike="noStrike" cap="none">
                           <a:solidFill>
-                            <a:srgbClr val="002060"/>
+                            <a:srgbClr val="081F5C"/>
                           </a:solidFill>
                           <a:latin typeface="Arial"/>
                           <a:ea typeface="Arial"/>
@@ -9305,7 +9445,7 @@
                     <p:cNvPr id="70" name="Google Shape;165;p4">
                       <a:extLst>
                         <a:ext uri="{FF2B5EF4-FFF2-40B4-BE49-F238E27FC236}">
-                          <a16:creationId xmlns:a16="http://schemas.microsoft.com/office/drawing/2014/main" id="{13620749-211E-E705-DB7B-40035A9C9C41}"/>
+                          <ns2:creationId id="{13620749-211E-E705-DB7B-40035A9C9C41}"/>
                         </a:ext>
                       </a:extLst>
                     </p:cNvPr>
@@ -9321,7 +9461,7 @@
                       <a:avLst/>
                     </a:prstGeom>
                     <a:solidFill>
-                      <a:srgbClr val="DA4C4C"/>
+                      <a:srgbClr val="CA5651"/>
                     </a:solidFill>
                     <a:ln>
                       <a:noFill/>
@@ -9379,7 +9519,7 @@
                     <p:cNvPr id="71" name="Google Shape;166;p4">
                       <a:extLst>
                         <a:ext uri="{FF2B5EF4-FFF2-40B4-BE49-F238E27FC236}">
-                          <a16:creationId xmlns:a16="http://schemas.microsoft.com/office/drawing/2014/main" id="{2D300DB7-733E-CB48-25EF-CAA6E364E71D}"/>
+                          <ns2:creationId id="{2D300DB7-733E-CB48-25EF-CAA6E364E71D}"/>
                         </a:ext>
                       </a:extLst>
                     </p:cNvPr>
@@ -9395,7 +9535,7 @@
                       <a:avLst/>
                     </a:prstGeom>
                     <a:solidFill>
-                      <a:srgbClr val="E8E8E8"/>
+                      <a:srgbClr val="D8D8D8"/>
                     </a:solidFill>
                     <a:ln>
                       <a:noFill/>
@@ -9418,7 +9558,7 @@
                           <a:spcPts val="0"/>
                         </a:spcAft>
                         <a:buClr>
-                          <a:srgbClr val="002060"/>
+                          <a:srgbClr val="081F5C"/>
                         </a:buClr>
                         <a:buSzPts val="1867"/>
                         <a:buFont typeface="Arial"/>
@@ -9427,7 +9567,7 @@
                       <a:r>
                         <a:rPr lang="es-ES" sz="1867" b="0" i="0" u="none" strike="noStrike" cap="none">
                           <a:solidFill>
-                            <a:srgbClr val="002060"/>
+                            <a:srgbClr val="081F5C"/>
                           </a:solidFill>
                           <a:latin typeface="Arial"/>
                           <a:ea typeface="Arial"/>
@@ -9438,7 +9578,7 @@
                       </a:r>
                       <a:endParaRPr sz="1867" b="0" i="0" u="none" strike="noStrike" cap="none">
                         <a:solidFill>
-                          <a:srgbClr val="002060"/>
+                          <a:srgbClr val="081F5C"/>
                         </a:solidFill>
                         <a:latin typeface="Arial"/>
                         <a:ea typeface="Arial"/>
@@ -9453,7 +9593,7 @@
                     <p:cNvPr id="72" name="Google Shape;167;p4">
                       <a:extLst>
                         <a:ext uri="{FF2B5EF4-FFF2-40B4-BE49-F238E27FC236}">
-                          <a16:creationId xmlns:a16="http://schemas.microsoft.com/office/drawing/2014/main" id="{367D4370-DE9A-7F18-B999-D2DCB824E429}"/>
+                          <ns2:creationId id="{367D4370-DE9A-7F18-B999-D2DCB824E429}"/>
                         </a:ext>
                       </a:extLst>
                     </p:cNvPr>
@@ -9469,7 +9609,7 @@
                       <a:avLst/>
                     </a:prstGeom>
                     <a:solidFill>
-                      <a:srgbClr val="DA4C4C"/>
+                      <a:srgbClr val="CA5651"/>
                     </a:solidFill>
                     <a:ln>
                       <a:noFill/>
@@ -9527,7 +9667,7 @@
                     <p:cNvPr id="81" name="Grupo 80">
                       <a:extLst>
                         <a:ext uri="{FF2B5EF4-FFF2-40B4-BE49-F238E27FC236}">
-                          <a16:creationId xmlns:a16="http://schemas.microsoft.com/office/drawing/2014/main" id="{C639CC98-357F-6D21-C80A-5E483FD61429}"/>
+                          <ns2:creationId id="{C639CC98-357F-6D21-C80A-5E483FD61429}"/>
                         </a:ext>
                       </a:extLst>
                     </p:cNvPr>
@@ -9547,7 +9687,7 @@
                       <p:cNvPr id="22" name="Google Shape;161;p4">
                         <a:extLst>
                           <a:ext uri="{FF2B5EF4-FFF2-40B4-BE49-F238E27FC236}">
-                            <a16:creationId xmlns:a16="http://schemas.microsoft.com/office/drawing/2014/main" id="{5D3A8B80-3C98-7987-D2A1-3DEBB8BD3851}"/>
+                            <ns2:creationId id="{5D3A8B80-3C98-7987-D2A1-3DEBB8BD3851}"/>
                           </a:ext>
                         </a:extLst>
                       </p:cNvPr>
@@ -9563,7 +9703,7 @@
                         <a:avLst/>
                       </a:prstGeom>
                       <a:solidFill>
-                        <a:srgbClr val="E8E8E8"/>
+                        <a:srgbClr val="D8D8D8"/>
                       </a:solidFill>
                       <a:ln>
                         <a:noFill/>
@@ -9614,7 +9754,7 @@
                             <a:spcPts val="0"/>
                           </a:spcAft>
                           <a:buClr>
-                            <a:srgbClr val="002060"/>
+                            <a:srgbClr val="081F5C"/>
                           </a:buClr>
                           <a:buSzPts val="1867"/>
                           <a:buFont typeface="Arial"/>
@@ -9623,7 +9763,7 @@
                         <a:r>
                           <a:rPr lang="es-ES" sz="1867" b="0" i="0" u="none" strike="noStrike" cap="none" dirty="0">
                             <a:solidFill>
-                              <a:srgbClr val="002060"/>
+                              <a:srgbClr val="081F5C"/>
                             </a:solidFill>
                             <a:latin typeface="Arial"/>
                             <a:ea typeface="Arial"/>
@@ -9669,7 +9809,7 @@
                       <p:cNvPr id="80" name="Grupo 79">
                         <a:extLst>
                           <a:ext uri="{FF2B5EF4-FFF2-40B4-BE49-F238E27FC236}">
-                            <a16:creationId xmlns:a16="http://schemas.microsoft.com/office/drawing/2014/main" id="{5D13158C-D07C-3379-A7BD-71B1BE8EC342}"/>
+                            <ns2:creationId id="{5D13158C-D07C-3379-A7BD-71B1BE8EC342}"/>
                           </a:ext>
                         </a:extLst>
                       </p:cNvPr>
@@ -9689,7 +9829,7 @@
                         <p:cNvPr id="79" name="Grupo 78">
                           <a:extLst>
                             <a:ext uri="{FF2B5EF4-FFF2-40B4-BE49-F238E27FC236}">
-                              <a16:creationId xmlns:a16="http://schemas.microsoft.com/office/drawing/2014/main" id="{AC0525B5-4474-C729-3271-78E63E434CFD}"/>
+                              <ns2:creationId id="{AC0525B5-4474-C729-3271-78E63E434CFD}"/>
                             </a:ext>
                           </a:extLst>
                         </p:cNvPr>
@@ -9847,7 +9987,7 @@
                             </a:pathLst>
                           </a:custGeom>
                           <a:solidFill>
-                            <a:srgbClr val="74BD80"/>
+                            <a:srgbClr val="85BB85"/>
                           </a:solidFill>
                           <a:ln>
                             <a:noFill/>
@@ -10696,7 +10836,7 @@
                         <p:cNvPr id="73" name="Google Shape;168;p4">
                           <a:extLst>
                             <a:ext uri="{FF2B5EF4-FFF2-40B4-BE49-F238E27FC236}">
-                              <a16:creationId xmlns:a16="http://schemas.microsoft.com/office/drawing/2014/main" id="{42D39793-A0E3-06ED-A437-DB70F67EAEC2}"/>
+                              <ns2:creationId id="{42D39793-A0E3-06ED-A437-DB70F67EAEC2}"/>
                             </a:ext>
                           </a:extLst>
                         </p:cNvPr>
@@ -10712,7 +10852,7 @@
                           <a:avLst/>
                         </a:prstGeom>
                         <a:solidFill>
-                          <a:srgbClr val="DA4C4C"/>
+                          <a:srgbClr val="CA5651"/>
                         </a:solidFill>
                         <a:ln>
                           <a:noFill/>
@@ -10803,7 +10943,7 @@
             <p:cNvPr id="87" name="Rectángulo 86">
               <a:extLst>
                 <a:ext uri="{FF2B5EF4-FFF2-40B4-BE49-F238E27FC236}">
-                  <a16:creationId xmlns:a16="http://schemas.microsoft.com/office/drawing/2014/main" id="{44F8ED50-9949-206B-8011-088F0FCF9B7F}"/>
+                  <ns2:creationId id="{44F8ED50-9949-206B-8011-088F0FCF9B7F}"/>
                 </a:ext>
               </a:extLst>
             </p:cNvPr>
@@ -10834,7 +10974,7 @@
                   <a:spcPct val="90000"/>
                 </a:lnSpc>
                 <a:buClr>
-                  <a:srgbClr val="002060"/>
+                  <a:srgbClr val="081F5C"/>
                 </a:buClr>
                 <a:buSzPct val="100000"/>
                 <a:buNone/>
@@ -10842,7 +10982,7 @@
               <a:r>
                 <a:rPr lang="es-PE" sz="3600" b="1" dirty="0">
                   <a:solidFill>
-                    <a:srgbClr val="002060"/>
+                    <a:srgbClr val="081F5C"/>
                   </a:solidFill>
                   <a:latin typeface="Arial"/>
                   <a:cs typeface="Arial"/>
@@ -10856,7 +10996,7 @@
     </p:spTree>
     <p:extLst>
       <p:ext uri="{BB962C8B-B14F-4D97-AF65-F5344CB8AC3E}">
-        <p14:creationId xmlns:p14="http://schemas.microsoft.com/office/powerpoint/2010/main" val="2515642923"/>
+        <p14:creationId val="2515642923"/>
       </p:ext>
     </p:extLst>
   </p:cSld>
@@ -10865,15 +11005,15 @@
   </p:clrMapOvr>
   <p:extLst>
     <p:ext uri="{DCECCB84-F9BA-43D5-87BE-67443E8EF086}">
-      <p15:sldGuideLst xmlns:p15="http://schemas.microsoft.com/office/powerpoint/2012/main">
+      <p15:sldGuideLst>
         <p15:guide id="1" orient="horz" pos="4088">
           <p15:clr>
-            <a:srgbClr val="FBAE40"/>
+            <a:srgbClr val="E4A34C"/>
           </p15:clr>
         </p15:guide>
         <p15:guide id="2" pos="7446">
           <p15:clr>
-            <a:srgbClr val="FBAE40"/>
+            <a:srgbClr val="E4A34C"/>
           </p15:clr>
         </p15:guide>
       </p15:sldGuideLst>
@@ -10883,7 +11023,7 @@
 </file>
 
 <file path=ppt/slideLayouts/slideLayout16.xml><?xml version="1.0" encoding="utf-8"?>
-<p:sldLayout xmlns:a="http://schemas.openxmlformats.org/drawingml/2006/main" xmlns:r="http://schemas.openxmlformats.org/officeDocument/2006/relationships" xmlns:p="http://schemas.openxmlformats.org/presentationml/2006/main" preserve="1" userDrawn="1">
+<p:sldLayout xmlns:a="http://schemas.openxmlformats.org/drawingml/2006/main" xmlns:ns2="http://schemas.microsoft.com/office/drawing/2014/main" xmlns:p="http://schemas.openxmlformats.org/presentationml/2006/main" xmlns:p14="http://schemas.microsoft.com/office/powerpoint/2010/main" xmlns:r="http://schemas.openxmlformats.org/officeDocument/2006/relationships" preserve="1" userDrawn="1">
   <p:cSld name="Objetivos_Secciones">
     <p:spTree>
       <p:nvGrpSpPr>
@@ -10904,7 +11044,7 @@
           <p:cNvPr id="2" name="Título 1">
             <a:extLst>
               <a:ext uri="{FF2B5EF4-FFF2-40B4-BE49-F238E27FC236}">
-                <a16:creationId xmlns:a16="http://schemas.microsoft.com/office/drawing/2014/main" id="{F3496E21-1CC1-1562-B8EF-F13A853214C5}"/>
+                <ns2:creationId id="{F3496E21-1CC1-1562-B8EF-F13A853214C5}"/>
               </a:ext>
             </a:extLst>
           </p:cNvPr>
@@ -10927,11 +11067,21 @@
           </a:bodyPr>
           <a:lstStyle>
             <a:lvl1pPr>
-              <a:defRPr sz="2400"/>
+              <a:defRPr sz="2400" b="1">
+                <a:latin typeface="Arial"/>
+                <a:solidFill>
+                  <a:srgbClr val="CA5651"/>
+                </a:solidFill>
+              </a:defRPr>
             </a:lvl1pPr>
           </a:lstStyle>
           <a:p>
-            <a:endParaRPr lang="es-PE" dirty="0"/>
+            <a:endParaRPr lang="es-PE" dirty="0" sz="2400" b="1">
+              <a:latin typeface="Arial"/>
+              <a:solidFill>
+                <a:srgbClr val="CA5651"/>
+              </a:solidFill>
+            </a:endParaRPr>
           </a:p>
         </p:txBody>
       </p:sp>
@@ -10940,7 +11090,7 @@
           <p:cNvPr id="3" name="Marcador de contenido 2">
             <a:extLst>
               <a:ext uri="{FF2B5EF4-FFF2-40B4-BE49-F238E27FC236}">
-                <a16:creationId xmlns:a16="http://schemas.microsoft.com/office/drawing/2014/main" id="{42B474CF-1676-A4EF-9FE6-8FD3FDBC9F9D}"/>
+                <ns2:creationId id="{42B474CF-1676-A4EF-9FE6-8FD3FDBC9F9D}"/>
               </a:ext>
             </a:extLst>
           </p:cNvPr>
@@ -11033,7 +11183,7 @@
           <p:cNvPr id="5" name="Marcador de fecha 4">
             <a:extLst>
               <a:ext uri="{FF2B5EF4-FFF2-40B4-BE49-F238E27FC236}">
-                <a16:creationId xmlns:a16="http://schemas.microsoft.com/office/drawing/2014/main" id="{85802C2C-2392-652E-671F-B5DE27A596DB}"/>
+                <ns2:creationId id="{85802C2C-2392-652E-671F-B5DE27A596DB}"/>
               </a:ext>
             </a:extLst>
           </p:cNvPr>
@@ -11062,7 +11212,7 @@
           <p:cNvPr id="6" name="Marcador de pie de página 5">
             <a:extLst>
               <a:ext uri="{FF2B5EF4-FFF2-40B4-BE49-F238E27FC236}">
-                <a16:creationId xmlns:a16="http://schemas.microsoft.com/office/drawing/2014/main" id="{D124750E-54F6-9473-05C9-240E1231DA91}"/>
+                <ns2:creationId id="{D124750E-54F6-9473-05C9-240E1231DA91}"/>
               </a:ext>
             </a:extLst>
           </p:cNvPr>
@@ -11087,7 +11237,7 @@
           <p:cNvPr id="7" name="Marcador de número de diapositiva 6">
             <a:extLst>
               <a:ext uri="{FF2B5EF4-FFF2-40B4-BE49-F238E27FC236}">
-                <a16:creationId xmlns:a16="http://schemas.microsoft.com/office/drawing/2014/main" id="{83D48AE0-5959-BCF9-366A-905A170F7C10}"/>
+                <ns2:creationId id="{83D48AE0-5959-BCF9-366A-905A170F7C10}"/>
               </a:ext>
             </a:extLst>
           </p:cNvPr>
@@ -11116,7 +11266,7 @@
           <p:cNvPr id="32" name="Google Shape;66;p47">
             <a:extLst>
               <a:ext uri="{FF2B5EF4-FFF2-40B4-BE49-F238E27FC236}">
-                <a16:creationId xmlns:a16="http://schemas.microsoft.com/office/drawing/2014/main" id="{F63067B3-DFE3-B1BF-80C5-536AAE2A10CA}"/>
+                <ns2:creationId id="{F63067B3-DFE3-B1BF-80C5-536AAE2A10CA}"/>
               </a:ext>
             </a:extLst>
           </p:cNvPr>
@@ -11149,7 +11299,7 @@
           <p:cNvPr id="16" name="Google Shape;72;p48">
             <a:extLst>
               <a:ext uri="{FF2B5EF4-FFF2-40B4-BE49-F238E27FC236}">
-                <a16:creationId xmlns:a16="http://schemas.microsoft.com/office/drawing/2014/main" id="{75249170-6132-C248-A55A-C653C9BA7545}"/>
+                <ns2:creationId id="{75249170-6132-C248-A55A-C653C9BA7545}"/>
               </a:ext>
             </a:extLst>
           </p:cNvPr>
@@ -11167,7 +11317,7 @@
           <a:noFill/>
           <a:ln w="38100" cap="flat" cmpd="sng">
             <a:solidFill>
-              <a:srgbClr val="DA4C4C"/>
+              <a:srgbClr val="CA5651"/>
             </a:solidFill>
             <a:prstDash val="dot"/>
             <a:miter lim="800000"/>
@@ -11181,7 +11331,7 @@
           <p:cNvPr id="17" name="Google Shape;73;p48">
             <a:extLst>
               <a:ext uri="{FF2B5EF4-FFF2-40B4-BE49-F238E27FC236}">
-                <a16:creationId xmlns:a16="http://schemas.microsoft.com/office/drawing/2014/main" id="{07FF0BA0-0FAB-E2CC-A14D-E3FCA236548A}"/>
+                <ns2:creationId id="{07FF0BA0-0FAB-E2CC-A14D-E3FCA236548A}"/>
               </a:ext>
             </a:extLst>
           </p:cNvPr>
@@ -11199,7 +11349,7 @@
           <a:noFill/>
           <a:ln w="38100" cap="flat" cmpd="sng">
             <a:solidFill>
-              <a:srgbClr val="DA4C4C"/>
+              <a:srgbClr val="CA5651"/>
             </a:solidFill>
             <a:prstDash val="dot"/>
             <a:miter lim="800000"/>
@@ -11213,7 +11363,7 @@
           <p:cNvPr id="18" name="Google Shape;74;p48">
             <a:extLst>
               <a:ext uri="{FF2B5EF4-FFF2-40B4-BE49-F238E27FC236}">
-                <a16:creationId xmlns:a16="http://schemas.microsoft.com/office/drawing/2014/main" id="{D16943E3-BE7E-2557-CD49-E965872D3141}"/>
+                <ns2:creationId id="{D16943E3-BE7E-2557-CD49-E965872D3141}"/>
               </a:ext>
             </a:extLst>
           </p:cNvPr>
@@ -11234,7 +11384,7 @@
           <a:noFill/>
           <a:ln w="38100" cap="flat" cmpd="sng">
             <a:solidFill>
-              <a:srgbClr val="DA4C4C"/>
+              <a:srgbClr val="CA5651"/>
             </a:solidFill>
             <a:prstDash val="dot"/>
             <a:miter lim="800000"/>
@@ -11282,7 +11432,7 @@
           <p:cNvPr id="19" name="Google Shape;75;p48">
             <a:extLst>
               <a:ext uri="{FF2B5EF4-FFF2-40B4-BE49-F238E27FC236}">
-                <a16:creationId xmlns:a16="http://schemas.microsoft.com/office/drawing/2014/main" id="{19C29BE4-E3A8-9C44-4DD5-BBE0888F6762}"/>
+                <ns2:creationId id="{19C29BE4-E3A8-9C44-4DD5-BBE0888F6762}"/>
               </a:ext>
             </a:extLst>
           </p:cNvPr>
@@ -11303,7 +11453,7 @@
           <a:noFill/>
           <a:ln w="38100" cap="flat" cmpd="sng">
             <a:solidFill>
-              <a:srgbClr val="DA4C4C"/>
+              <a:srgbClr val="CA5651"/>
             </a:solidFill>
             <a:prstDash val="dot"/>
             <a:miter lim="800000"/>
@@ -11351,7 +11501,7 @@
           <p:cNvPr id="20" name="Google Shape;76;p48">
             <a:extLst>
               <a:ext uri="{FF2B5EF4-FFF2-40B4-BE49-F238E27FC236}">
-                <a16:creationId xmlns:a16="http://schemas.microsoft.com/office/drawing/2014/main" id="{02DC3559-CE35-33AC-E48D-2320876FDC8E}"/>
+                <ns2:creationId id="{02DC3559-CE35-33AC-E48D-2320876FDC8E}"/>
               </a:ext>
             </a:extLst>
           </p:cNvPr>
@@ -11369,7 +11519,7 @@
           <a:noFill/>
           <a:ln w="38100" cap="flat" cmpd="sng">
             <a:solidFill>
-              <a:srgbClr val="DA4C4C"/>
+              <a:srgbClr val="CA5651"/>
             </a:solidFill>
             <a:prstDash val="dot"/>
             <a:miter lim="800000"/>
@@ -11383,7 +11533,7 @@
           <p:cNvPr id="12" name="Marcador de texto 11">
             <a:extLst>
               <a:ext uri="{FF2B5EF4-FFF2-40B4-BE49-F238E27FC236}">
-                <a16:creationId xmlns:a16="http://schemas.microsoft.com/office/drawing/2014/main" id="{19C0EB30-EE04-65A5-B77F-F1F99FE302AC}"/>
+                <ns2:creationId id="{19C0EB30-EE04-65A5-B77F-F1F99FE302AC}"/>
               </a:ext>
             </a:extLst>
           </p:cNvPr>
@@ -11408,35 +11558,35 @@
             <a:lvl1pPr algn="just">
               <a:defRPr sz="2000" b="0">
                 <a:solidFill>
-                  <a:srgbClr val="002060"/>
+                  <a:srgbClr val="081F5C"/>
                 </a:solidFill>
               </a:defRPr>
             </a:lvl1pPr>
             <a:lvl2pPr algn="just">
               <a:defRPr sz="2000" b="0">
                 <a:solidFill>
-                  <a:srgbClr val="002060"/>
+                  <a:srgbClr val="081F5C"/>
                 </a:solidFill>
               </a:defRPr>
             </a:lvl2pPr>
             <a:lvl3pPr algn="just">
               <a:defRPr sz="2000" b="0">
                 <a:solidFill>
-                  <a:srgbClr val="002060"/>
+                  <a:srgbClr val="081F5C"/>
                 </a:solidFill>
               </a:defRPr>
             </a:lvl3pPr>
             <a:lvl4pPr algn="just">
               <a:defRPr sz="2000" b="0">
                 <a:solidFill>
-                  <a:srgbClr val="002060"/>
+                  <a:srgbClr val="081F5C"/>
                 </a:solidFill>
               </a:defRPr>
             </a:lvl4pPr>
             <a:lvl5pPr algn="just">
               <a:defRPr sz="2000" b="0">
                 <a:solidFill>
-                  <a:srgbClr val="002060"/>
+                  <a:srgbClr val="081F5C"/>
                 </a:solidFill>
               </a:defRPr>
             </a:lvl5pPr>
@@ -11453,7 +11603,7 @@
     </p:spTree>
     <p:extLst>
       <p:ext uri="{BB962C8B-B14F-4D97-AF65-F5344CB8AC3E}">
-        <p14:creationId xmlns:p14="http://schemas.microsoft.com/office/powerpoint/2010/main" val="3946334935"/>
+        <p14:creationId val="3946334935"/>
       </p:ext>
     </p:extLst>
   </p:cSld>
@@ -11464,7 +11614,7 @@
 </file>
 
 <file path=ppt/slideLayouts/slideLayout17.xml><?xml version="1.0" encoding="utf-8"?>
-<p:sldLayout xmlns:a="http://schemas.openxmlformats.org/drawingml/2006/main" xmlns:r="http://schemas.openxmlformats.org/officeDocument/2006/relationships" xmlns:p="http://schemas.openxmlformats.org/presentationml/2006/main" matchingName="diseño contenido 3" preserve="1">
+<p:sldLayout xmlns:a="http://schemas.openxmlformats.org/drawingml/2006/main" xmlns:p="http://schemas.openxmlformats.org/presentationml/2006/main" xmlns:p14="http://schemas.microsoft.com/office/powerpoint/2010/main" matchingName="diseño contenido 3" preserve="1">
   <p:cSld name="General Objective">
     <p:spTree>
       <p:nvGrpSpPr>
@@ -12196,7 +12346,12 @@
               </a:buClr>
               <a:buSzPts val="2800"/>
               <a:buNone/>
-              <a:defRPr/>
+              <a:defRPr sz="1400" b="0">
+                <a:latin typeface="Arial"/>
+                <a:solidFill>
+                  <a:srgbClr val="081F5C"/>
+                </a:solidFill>
+              </a:defRPr>
             </a:lvl1pPr>
             <a:lvl2pPr marL="914400" lvl="1" indent="-342900" algn="l">
               <a:lnSpc>
@@ -12213,7 +12368,12 @@
               </a:buClr>
               <a:buSzPts val="1800"/>
               <a:buChar char="•"/>
-              <a:defRPr/>
+              <a:defRPr sz="1400" b="0">
+                <a:latin typeface="Arial"/>
+                <a:solidFill>
+                  <a:srgbClr val="081F5C"/>
+                </a:solidFill>
+              </a:defRPr>
             </a:lvl2pPr>
             <a:lvl3pPr marL="1371600" lvl="2" indent="-342900" algn="l">
               <a:lnSpc>
@@ -12230,7 +12390,12 @@
               </a:buClr>
               <a:buSzPts val="1800"/>
               <a:buChar char="•"/>
-              <a:defRPr/>
+              <a:defRPr sz="1400" b="0">
+                <a:latin typeface="Arial"/>
+                <a:solidFill>
+                  <a:srgbClr val="081F5C"/>
+                </a:solidFill>
+              </a:defRPr>
             </a:lvl3pPr>
             <a:lvl4pPr marL="1828800" lvl="3" indent="-342900" algn="l">
               <a:lnSpc>
@@ -12247,7 +12412,12 @@
               </a:buClr>
               <a:buSzPts val="1800"/>
               <a:buChar char="•"/>
-              <a:defRPr/>
+              <a:defRPr sz="1400" b="0">
+                <a:latin typeface="Arial"/>
+                <a:solidFill>
+                  <a:srgbClr val="081F5C"/>
+                </a:solidFill>
+              </a:defRPr>
             </a:lvl4pPr>
             <a:lvl5pPr marL="2286000" lvl="4" indent="-342900" algn="l">
               <a:lnSpc>
@@ -12264,7 +12434,12 @@
               </a:buClr>
               <a:buSzPts val="1800"/>
               <a:buChar char="•"/>
-              <a:defRPr/>
+              <a:defRPr sz="1400" b="0">
+                <a:latin typeface="Arial"/>
+                <a:solidFill>
+                  <a:srgbClr val="081F5C"/>
+                </a:solidFill>
+              </a:defRPr>
             </a:lvl5pPr>
             <a:lvl6pPr marL="2743200" lvl="5" indent="-342900" algn="l">
               <a:lnSpc>
@@ -12281,7 +12456,12 @@
               </a:buClr>
               <a:buSzPts val="1800"/>
               <a:buChar char="•"/>
-              <a:defRPr/>
+              <a:defRPr sz="1400" b="0">
+                <a:latin typeface="Arial"/>
+                <a:solidFill>
+                  <a:srgbClr val="081F5C"/>
+                </a:solidFill>
+              </a:defRPr>
             </a:lvl6pPr>
             <a:lvl7pPr marL="3200400" lvl="6" indent="-342900" algn="l">
               <a:lnSpc>
@@ -12298,7 +12478,12 @@
               </a:buClr>
               <a:buSzPts val="1800"/>
               <a:buChar char="•"/>
-              <a:defRPr/>
+              <a:defRPr sz="1400" b="0">
+                <a:latin typeface="Arial"/>
+                <a:solidFill>
+                  <a:srgbClr val="081F5C"/>
+                </a:solidFill>
+              </a:defRPr>
             </a:lvl7pPr>
             <a:lvl8pPr marL="3657600" lvl="7" indent="-342900" algn="l">
               <a:lnSpc>
@@ -12315,7 +12500,12 @@
               </a:buClr>
               <a:buSzPts val="1800"/>
               <a:buChar char="•"/>
-              <a:defRPr/>
+              <a:defRPr sz="1400" b="0">
+                <a:latin typeface="Arial"/>
+                <a:solidFill>
+                  <a:srgbClr val="081F5C"/>
+                </a:solidFill>
+              </a:defRPr>
             </a:lvl8pPr>
             <a:lvl9pPr marL="4114800" lvl="8" indent="-342900" algn="l">
               <a:lnSpc>
@@ -12332,13 +12522,27 @@
               </a:buClr>
               <a:buSzPts val="1800"/>
               <a:buChar char="•"/>
-              <a:defRPr/>
+              <a:defRPr sz="1400" b="0">
+                <a:latin typeface="Arial"/>
+                <a:solidFill>
+                  <a:srgbClr val="081F5C"/>
+                </a:solidFill>
+              </a:defRPr>
             </a:lvl9pPr>
           </a:lstStyle>
           <a:p>
-            <a:pPr lvl="0"/>
-            <a:r>
-              <a:rPr lang="es-MX"/>
+            <a:pPr lvl="0" algn="just">
+              <a:lnSpc>
+                <a:spcPct val="100000"/>
+              </a:lnSpc>
+            </a:pPr>
+            <a:r>
+              <a:rPr lang="es-MX" sz="1400" b="0">
+                <a:latin typeface="Arial"/>
+                <a:solidFill>
+                  <a:srgbClr val="081F5C"/>
+                </a:solidFill>
+              </a:rPr>
               <a:t>Haga clic para modificar los estilos de texto del patrón</a:t>
             </a:r>
           </a:p>
@@ -12361,7 +12565,7 @@
           <a:noFill/>
           <a:ln w="38100" cap="flat" cmpd="sng">
             <a:solidFill>
-              <a:srgbClr val="DA4C4C"/>
+              <a:srgbClr val="CA5651"/>
             </a:solidFill>
             <a:prstDash val="dot"/>
             <a:miter lim="800000"/>
@@ -12387,7 +12591,7 @@
           <a:noFill/>
           <a:ln w="38100" cap="flat" cmpd="sng">
             <a:solidFill>
-              <a:srgbClr val="DA4C4C"/>
+              <a:srgbClr val="CA5651"/>
             </a:solidFill>
             <a:prstDash val="dot"/>
             <a:miter lim="800000"/>
@@ -12416,7 +12620,7 @@
           <a:noFill/>
           <a:ln w="38100" cap="flat" cmpd="sng">
             <a:solidFill>
-              <a:srgbClr val="DA4C4C"/>
+              <a:srgbClr val="CA5651"/>
             </a:solidFill>
             <a:prstDash val="dot"/>
             <a:miter lim="800000"/>
@@ -12479,7 +12683,7 @@
           <a:noFill/>
           <a:ln w="38100" cap="flat" cmpd="sng">
             <a:solidFill>
-              <a:srgbClr val="DA4C4C"/>
+              <a:srgbClr val="CA5651"/>
             </a:solidFill>
             <a:prstDash val="dot"/>
             <a:miter lim="800000"/>
@@ -12539,7 +12743,7 @@
           <a:noFill/>
           <a:ln w="38100" cap="flat" cmpd="sng">
             <a:solidFill>
-              <a:srgbClr val="DA4C4C"/>
+              <a:srgbClr val="CA5651"/>
             </a:solidFill>
             <a:prstDash val="dot"/>
             <a:miter lim="800000"/>
@@ -12565,7 +12769,7 @@
           <a:noFill/>
           <a:ln w="25400" cap="flat" cmpd="sng">
             <a:solidFill>
-              <a:srgbClr val="8DA9DB"/>
+              <a:srgbClr val="7594CC"/>
             </a:solidFill>
             <a:prstDash val="dot"/>
             <a:miter lim="800000"/>
@@ -12618,7 +12822,12 @@
               <a:buSzPts val="2500"/>
               <a:buFont typeface="Calibri"/>
               <a:buNone/>
-              <a:defRPr sz="2500" u="none"/>
+              <a:defRPr sz="2400" u="none" b="1">
+                <a:latin typeface="Arial"/>
+                <a:solidFill>
+                  <a:srgbClr val="CA5651"/>
+                </a:solidFill>
+              </a:defRPr>
             </a:lvl1pPr>
             <a:lvl2pPr lvl="1" algn="l">
               <a:lnSpc>
@@ -12632,7 +12841,12 @@
               </a:spcAft>
               <a:buSzPts val="1400"/>
               <a:buNone/>
-              <a:defRPr/>
+              <a:defRPr sz="2400" b="1">
+                <a:latin typeface="Arial"/>
+                <a:solidFill>
+                  <a:srgbClr val="CA5651"/>
+                </a:solidFill>
+              </a:defRPr>
             </a:lvl2pPr>
             <a:lvl3pPr lvl="2" algn="l">
               <a:lnSpc>
@@ -12646,7 +12860,12 @@
               </a:spcAft>
               <a:buSzPts val="1400"/>
               <a:buNone/>
-              <a:defRPr/>
+              <a:defRPr sz="2400" b="1">
+                <a:latin typeface="Arial"/>
+                <a:solidFill>
+                  <a:srgbClr val="CA5651"/>
+                </a:solidFill>
+              </a:defRPr>
             </a:lvl3pPr>
             <a:lvl4pPr lvl="3" algn="l">
               <a:lnSpc>
@@ -12660,7 +12879,12 @@
               </a:spcAft>
               <a:buSzPts val="1400"/>
               <a:buNone/>
-              <a:defRPr/>
+              <a:defRPr sz="2400" b="1">
+                <a:latin typeface="Arial"/>
+                <a:solidFill>
+                  <a:srgbClr val="CA5651"/>
+                </a:solidFill>
+              </a:defRPr>
             </a:lvl4pPr>
             <a:lvl5pPr lvl="4" algn="l">
               <a:lnSpc>
@@ -12674,7 +12898,12 @@
               </a:spcAft>
               <a:buSzPts val="1400"/>
               <a:buNone/>
-              <a:defRPr/>
+              <a:defRPr sz="2400" b="1">
+                <a:latin typeface="Arial"/>
+                <a:solidFill>
+                  <a:srgbClr val="CA5651"/>
+                </a:solidFill>
+              </a:defRPr>
             </a:lvl5pPr>
             <a:lvl6pPr lvl="5" algn="l">
               <a:lnSpc>
@@ -12688,7 +12917,12 @@
               </a:spcAft>
               <a:buSzPts val="1400"/>
               <a:buNone/>
-              <a:defRPr/>
+              <a:defRPr sz="2400" b="1">
+                <a:latin typeface="Arial"/>
+                <a:solidFill>
+                  <a:srgbClr val="CA5651"/>
+                </a:solidFill>
+              </a:defRPr>
             </a:lvl6pPr>
             <a:lvl7pPr lvl="6" algn="l">
               <a:lnSpc>
@@ -12702,7 +12936,12 @@
               </a:spcAft>
               <a:buSzPts val="1400"/>
               <a:buNone/>
-              <a:defRPr/>
+              <a:defRPr sz="2400" b="1">
+                <a:latin typeface="Arial"/>
+                <a:solidFill>
+                  <a:srgbClr val="CA5651"/>
+                </a:solidFill>
+              </a:defRPr>
             </a:lvl7pPr>
             <a:lvl8pPr lvl="7" algn="l">
               <a:lnSpc>
@@ -12716,7 +12955,12 @@
               </a:spcAft>
               <a:buSzPts val="1400"/>
               <a:buNone/>
-              <a:defRPr/>
+              <a:defRPr sz="2400" b="1">
+                <a:latin typeface="Arial"/>
+                <a:solidFill>
+                  <a:srgbClr val="CA5651"/>
+                </a:solidFill>
+              </a:defRPr>
             </a:lvl8pPr>
             <a:lvl9pPr lvl="8" algn="l">
               <a:lnSpc>
@@ -12730,15 +12974,30 @@
               </a:spcAft>
               <a:buSzPts val="1400"/>
               <a:buNone/>
-              <a:defRPr/>
+              <a:defRPr sz="2400" b="1">
+                <a:latin typeface="Arial"/>
+                <a:solidFill>
+                  <a:srgbClr val="CA5651"/>
+                </a:solidFill>
+              </a:defRPr>
             </a:lvl9pPr>
           </a:lstStyle>
           <a:p>
             <a:r>
-              <a:rPr lang="es-MX"/>
+              <a:rPr lang="es-MX" sz="2400" b="1">
+                <a:latin typeface="Arial"/>
+                <a:solidFill>
+                  <a:srgbClr val="CA5651"/>
+                </a:solidFill>
+              </a:rPr>
               <a:t>Haz clic para modificar el estilo de título del patrón</a:t>
             </a:r>
-            <a:endParaRPr/>
+            <a:endParaRPr sz="2400" b="1">
+              <a:latin typeface="Arial"/>
+              <a:solidFill>
+                <a:srgbClr val="CA5651"/>
+              </a:solidFill>
+            </a:endParaRPr>
           </a:p>
         </p:txBody>
       </p:sp>
@@ -12785,10 +13044,11 @@
               </a:buClr>
               <a:buSzPts val="3000"/>
               <a:buNone/>
-              <a:defRPr sz="3000">
+              <a:defRPr sz="1400" b="0">
                 <a:solidFill>
-                  <a:srgbClr val="666666"/>
+                  <a:srgbClr val="081F5C"/>
                 </a:solidFill>
+                <a:latin typeface="Arial"/>
               </a:defRPr>
             </a:lvl1pPr>
             <a:lvl2pPr marL="914400" lvl="1" indent="-342900" algn="l">
@@ -12806,7 +13066,12 @@
               </a:buClr>
               <a:buSzPts val="1800"/>
               <a:buChar char="•"/>
-              <a:defRPr/>
+              <a:defRPr sz="1400" b="0">
+                <a:latin typeface="Arial"/>
+                <a:solidFill>
+                  <a:srgbClr val="081F5C"/>
+                </a:solidFill>
+              </a:defRPr>
             </a:lvl2pPr>
             <a:lvl3pPr marL="1371600" lvl="2" indent="-342900" algn="l">
               <a:lnSpc>
@@ -12823,7 +13088,12 @@
               </a:buClr>
               <a:buSzPts val="1800"/>
               <a:buChar char="•"/>
-              <a:defRPr/>
+              <a:defRPr sz="1400" b="0">
+                <a:latin typeface="Arial"/>
+                <a:solidFill>
+                  <a:srgbClr val="081F5C"/>
+                </a:solidFill>
+              </a:defRPr>
             </a:lvl3pPr>
             <a:lvl4pPr marL="1828800" lvl="3" indent="-342900" algn="l">
               <a:lnSpc>
@@ -12840,7 +13110,12 @@
               </a:buClr>
               <a:buSzPts val="1800"/>
               <a:buChar char="•"/>
-              <a:defRPr/>
+              <a:defRPr sz="1400" b="0">
+                <a:latin typeface="Arial"/>
+                <a:solidFill>
+                  <a:srgbClr val="081F5C"/>
+                </a:solidFill>
+              </a:defRPr>
             </a:lvl4pPr>
             <a:lvl5pPr marL="2286000" lvl="4" indent="-342900" algn="l">
               <a:lnSpc>
@@ -12857,7 +13132,12 @@
               </a:buClr>
               <a:buSzPts val="1800"/>
               <a:buChar char="•"/>
-              <a:defRPr/>
+              <a:defRPr sz="1400" b="0">
+                <a:latin typeface="Arial"/>
+                <a:solidFill>
+                  <a:srgbClr val="081F5C"/>
+                </a:solidFill>
+              </a:defRPr>
             </a:lvl5pPr>
             <a:lvl6pPr marL="2743200" lvl="5" indent="-342900" algn="l">
               <a:lnSpc>
@@ -12874,7 +13154,12 @@
               </a:buClr>
               <a:buSzPts val="1800"/>
               <a:buChar char="•"/>
-              <a:defRPr/>
+              <a:defRPr sz="1400" b="0">
+                <a:latin typeface="Arial"/>
+                <a:solidFill>
+                  <a:srgbClr val="081F5C"/>
+                </a:solidFill>
+              </a:defRPr>
             </a:lvl6pPr>
             <a:lvl7pPr marL="3200400" lvl="6" indent="-342900" algn="l">
               <a:lnSpc>
@@ -12891,7 +13176,12 @@
               </a:buClr>
               <a:buSzPts val="1800"/>
               <a:buChar char="•"/>
-              <a:defRPr/>
+              <a:defRPr sz="1400" b="0">
+                <a:latin typeface="Arial"/>
+                <a:solidFill>
+                  <a:srgbClr val="081F5C"/>
+                </a:solidFill>
+              </a:defRPr>
             </a:lvl7pPr>
             <a:lvl8pPr marL="3657600" lvl="7" indent="-342900" algn="l">
               <a:lnSpc>
@@ -12908,7 +13198,12 @@
               </a:buClr>
               <a:buSzPts val="1800"/>
               <a:buChar char="•"/>
-              <a:defRPr/>
+              <a:defRPr sz="1400" b="0">
+                <a:latin typeface="Arial"/>
+                <a:solidFill>
+                  <a:srgbClr val="081F5C"/>
+                </a:solidFill>
+              </a:defRPr>
             </a:lvl8pPr>
             <a:lvl9pPr marL="4114800" lvl="8" indent="-342900" algn="l">
               <a:lnSpc>
@@ -12925,13 +13220,27 @@
               </a:buClr>
               <a:buSzPts val="1800"/>
               <a:buChar char="•"/>
-              <a:defRPr/>
+              <a:defRPr sz="1400" b="0">
+                <a:latin typeface="Arial"/>
+                <a:solidFill>
+                  <a:srgbClr val="081F5C"/>
+                </a:solidFill>
+              </a:defRPr>
             </a:lvl9pPr>
           </a:lstStyle>
           <a:p>
-            <a:pPr lvl="0"/>
-            <a:r>
-              <a:rPr lang="es-MX"/>
+            <a:pPr lvl="0" algn="just">
+              <a:lnSpc>
+                <a:spcPct val="100000"/>
+              </a:lnSpc>
+            </a:pPr>
+            <a:r>
+              <a:rPr lang="es-MX" sz="1400" b="0">
+                <a:latin typeface="Arial"/>
+                <a:solidFill>
+                  <a:srgbClr val="081F5C"/>
+                </a:solidFill>
+              </a:rPr>
               <a:t>Haga clic para modificar los estilos de texto del patrón</a:t>
             </a:r>
           </a:p>
@@ -12940,7 +13249,7 @@
     </p:spTree>
     <p:extLst>
       <p:ext uri="{BB962C8B-B14F-4D97-AF65-F5344CB8AC3E}">
-        <p14:creationId xmlns:p14="http://schemas.microsoft.com/office/powerpoint/2010/main" val="2275540259"/>
+        <p14:creationId val="2275540259"/>
       </p:ext>
     </p:extLst>
   </p:cSld>
@@ -12951,7 +13260,7 @@
 </file>
 
 <file path=ppt/slideLayouts/slideLayout18.xml><?xml version="1.0" encoding="utf-8"?>
-<p:sldLayout xmlns:a="http://schemas.openxmlformats.org/drawingml/2006/main" xmlns:r="http://schemas.openxmlformats.org/officeDocument/2006/relationships" xmlns:p="http://schemas.openxmlformats.org/presentationml/2006/main" preserve="1" userDrawn="1">
+<p:sldLayout xmlns:a="http://schemas.openxmlformats.org/drawingml/2006/main" xmlns:ns2="http://schemas.microsoft.com/office/drawing/2014/main" xmlns:p="http://schemas.openxmlformats.org/presentationml/2006/main" xmlns:p14="http://schemas.microsoft.com/office/powerpoint/2010/main" xmlns:r="http://schemas.openxmlformats.org/officeDocument/2006/relationships" preserve="1" userDrawn="1">
   <p:cSld name="Comparison">
     <p:spTree>
       <p:nvGrpSpPr>
@@ -12972,7 +13281,7 @@
           <p:cNvPr id="21" name="Google Shape;83;p50">
             <a:extLst>
               <a:ext uri="{FF2B5EF4-FFF2-40B4-BE49-F238E27FC236}">
-                <a16:creationId xmlns:a16="http://schemas.microsoft.com/office/drawing/2014/main" id="{68C69994-8571-CF4D-63D7-22A19CC07C6D}"/>
+                <ns2:creationId id="{68C69994-8571-CF4D-63D7-22A19CC07C6D}"/>
               </a:ext>
             </a:extLst>
           </p:cNvPr>
@@ -13005,7 +13314,7 @@
           <p:cNvPr id="7" name="Picture Placeholder 6">
             <a:extLst>
               <a:ext uri="{FF2B5EF4-FFF2-40B4-BE49-F238E27FC236}">
-                <a16:creationId xmlns:a16="http://schemas.microsoft.com/office/drawing/2014/main" id="{61DE5BAB-AAF2-6FE6-0DA4-29396849529B}"/>
+                <ns2:creationId id="{61DE5BAB-AAF2-6FE6-0DA4-29396849529B}"/>
               </a:ext>
             </a:extLst>
           </p:cNvPr>
@@ -13033,7 +13342,7 @@
     </p:spTree>
     <p:extLst>
       <p:ext uri="{BB962C8B-B14F-4D97-AF65-F5344CB8AC3E}">
-        <p14:creationId xmlns:p14="http://schemas.microsoft.com/office/powerpoint/2010/main" val="2321386189"/>
+        <p14:creationId val="2321386189"/>
       </p:ext>
     </p:extLst>
   </p:cSld>
@@ -13044,7 +13353,7 @@
 </file>
 
 <file path=ppt/slideLayouts/slideLayout19.xml><?xml version="1.0" encoding="utf-8"?>
-<p:sldLayout xmlns:a="http://schemas.openxmlformats.org/drawingml/2006/main" xmlns:r="http://schemas.openxmlformats.org/officeDocument/2006/relationships" xmlns:p="http://schemas.openxmlformats.org/presentationml/2006/main" matchingName="Dos objetos" userDrawn="1">
+<p:sldLayout xmlns:a="http://schemas.openxmlformats.org/drawingml/2006/main" xmlns:ns3="http://schemas.microsoft.com/office/drawing/2014/main" xmlns:p="http://schemas.openxmlformats.org/presentationml/2006/main" xmlns:p14="http://schemas.microsoft.com/office/powerpoint/2010/main" xmlns:p15="http://schemas.microsoft.com/office/powerpoint/2012/main" xmlns:r="http://schemas.openxmlformats.org/officeDocument/2006/relationships" matchingName="Dos objetos" userDrawn="1">
   <p:cSld name="poblacion_2">
     <p:spTree>
       <p:nvGrpSpPr>
@@ -13126,14 +13435,14 @@
                 <a:spcPts val="0"/>
               </a:spcAft>
               <a:buClr>
-                <a:srgbClr val="DA4C4C"/>
+                <a:srgbClr val="CA5651"/>
               </a:buClr>
               <a:buSzPts val="2400"/>
               <a:buFont typeface="Arial"/>
               <a:buNone/>
               <a:defRPr sz="2400" b="1" cap="none">
                 <a:solidFill>
-                  <a:srgbClr val="DA4C4C"/>
+                  <a:srgbClr val="CA5651"/>
                 </a:solidFill>
                 <a:latin typeface="Arial"/>
                 <a:ea typeface="Arial"/>
@@ -13153,7 +13462,12 @@
               </a:spcAft>
               <a:buSzPts val="1400"/>
               <a:buNone/>
-              <a:defRPr/>
+              <a:defRPr sz="2400" b="1">
+                <a:latin typeface="Arial"/>
+                <a:solidFill>
+                  <a:srgbClr val="CA5651"/>
+                </a:solidFill>
+              </a:defRPr>
             </a:lvl2pPr>
             <a:lvl3pPr lvl="2" algn="l">
               <a:lnSpc>
@@ -13167,7 +13481,12 @@
               </a:spcAft>
               <a:buSzPts val="1400"/>
               <a:buNone/>
-              <a:defRPr/>
+              <a:defRPr sz="2400" b="1">
+                <a:latin typeface="Arial"/>
+                <a:solidFill>
+                  <a:srgbClr val="CA5651"/>
+                </a:solidFill>
+              </a:defRPr>
             </a:lvl3pPr>
             <a:lvl4pPr lvl="3" algn="l">
               <a:lnSpc>
@@ -13181,7 +13500,12 @@
               </a:spcAft>
               <a:buSzPts val="1400"/>
               <a:buNone/>
-              <a:defRPr/>
+              <a:defRPr sz="2400" b="1">
+                <a:latin typeface="Arial"/>
+                <a:solidFill>
+                  <a:srgbClr val="CA5651"/>
+                </a:solidFill>
+              </a:defRPr>
             </a:lvl4pPr>
             <a:lvl5pPr lvl="4" algn="l">
               <a:lnSpc>
@@ -13195,7 +13519,12 @@
               </a:spcAft>
               <a:buSzPts val="1400"/>
               <a:buNone/>
-              <a:defRPr/>
+              <a:defRPr sz="2400" b="1">
+                <a:latin typeface="Arial"/>
+                <a:solidFill>
+                  <a:srgbClr val="CA5651"/>
+                </a:solidFill>
+              </a:defRPr>
             </a:lvl5pPr>
             <a:lvl6pPr lvl="5" algn="l">
               <a:lnSpc>
@@ -13209,7 +13538,12 @@
               </a:spcAft>
               <a:buSzPts val="1400"/>
               <a:buNone/>
-              <a:defRPr/>
+              <a:defRPr sz="2400" b="1">
+                <a:latin typeface="Arial"/>
+                <a:solidFill>
+                  <a:srgbClr val="CA5651"/>
+                </a:solidFill>
+              </a:defRPr>
             </a:lvl6pPr>
             <a:lvl7pPr lvl="6" algn="l">
               <a:lnSpc>
@@ -13223,7 +13557,12 @@
               </a:spcAft>
               <a:buSzPts val="1400"/>
               <a:buNone/>
-              <a:defRPr/>
+              <a:defRPr sz="2400" b="1">
+                <a:latin typeface="Arial"/>
+                <a:solidFill>
+                  <a:srgbClr val="CA5651"/>
+                </a:solidFill>
+              </a:defRPr>
             </a:lvl7pPr>
             <a:lvl8pPr lvl="7" algn="l">
               <a:lnSpc>
@@ -13237,7 +13576,12 @@
               </a:spcAft>
               <a:buSzPts val="1400"/>
               <a:buNone/>
-              <a:defRPr/>
+              <a:defRPr sz="2400" b="1">
+                <a:latin typeface="Arial"/>
+                <a:solidFill>
+                  <a:srgbClr val="CA5651"/>
+                </a:solidFill>
+              </a:defRPr>
             </a:lvl8pPr>
             <a:lvl9pPr lvl="8" algn="l">
               <a:lnSpc>
@@ -13251,15 +13595,30 @@
               </a:spcAft>
               <a:buSzPts val="1400"/>
               <a:buNone/>
-              <a:defRPr/>
+              <a:defRPr sz="2400" b="1">
+                <a:latin typeface="Arial"/>
+                <a:solidFill>
+                  <a:srgbClr val="CA5651"/>
+                </a:solidFill>
+              </a:defRPr>
             </a:lvl9pPr>
           </a:lstStyle>
           <a:p>
             <a:r>
-              <a:rPr lang="es-MX"/>
+              <a:rPr lang="es-MX" sz="2400" b="1">
+                <a:latin typeface="Arial"/>
+                <a:solidFill>
+                  <a:srgbClr val="CA5651"/>
+                </a:solidFill>
+              </a:rPr>
               <a:t>Haz clic para modificar el estilo de título del patrón</a:t>
             </a:r>
-            <a:endParaRPr dirty="0"/>
+            <a:endParaRPr dirty="0" sz="2400" b="1">
+              <a:latin typeface="Arial"/>
+              <a:solidFill>
+                <a:srgbClr val="CA5651"/>
+              </a:solidFill>
+            </a:endParaRPr>
           </a:p>
         </p:txBody>
       </p:sp>
@@ -13268,7 +13627,7 @@
           <p:cNvPr id="2" name="Place holder 1">
             <a:extLst>
               <a:ext uri="{FF2B5EF4-FFF2-40B4-BE49-F238E27FC236}">
-                <a16:creationId xmlns:a16="http://schemas.microsoft.com/office/drawing/2014/main" id="{2D673E48-04D3-F5BF-45EB-9E91DBD21B82}"/>
+                <ns3:creationId id="{2D673E48-04D3-F5BF-45EB-9E91DBD21B82}"/>
               </a:ext>
             </a:extLst>
           </p:cNvPr>
@@ -13367,7 +13726,7 @@
           <p:cNvPr id="5" name="Place holder 2">
             <a:extLst>
               <a:ext uri="{FF2B5EF4-FFF2-40B4-BE49-F238E27FC236}">
-                <a16:creationId xmlns:a16="http://schemas.microsoft.com/office/drawing/2014/main" id="{79837775-7BC6-2849-10D0-C24A5339D1C6}"/>
+                <ns3:creationId id="{79837775-7BC6-2849-10D0-C24A5339D1C6}"/>
               </a:ext>
             </a:extLst>
           </p:cNvPr>
@@ -13466,7 +13825,7 @@
           <p:cNvPr id="7" name="Content Placeholder 5">
             <a:extLst>
               <a:ext uri="{FF2B5EF4-FFF2-40B4-BE49-F238E27FC236}">
-                <a16:creationId xmlns:a16="http://schemas.microsoft.com/office/drawing/2014/main" id="{83AD1074-19AE-D0A2-2BA6-5761413F4BAC}"/>
+                <ns3:creationId id="{83AD1074-19AE-D0A2-2BA6-5761413F4BAC}"/>
               </a:ext>
             </a:extLst>
           </p:cNvPr>
@@ -13527,7 +13886,7 @@
     </p:spTree>
     <p:extLst>
       <p:ext uri="{BB962C8B-B14F-4D97-AF65-F5344CB8AC3E}">
-        <p14:creationId xmlns:p14="http://schemas.microsoft.com/office/powerpoint/2010/main" val="1059164739"/>
+        <p14:creationId val="1059164739"/>
       </p:ext>
     </p:extLst>
   </p:cSld>
@@ -13536,15 +13895,15 @@
   </p:clrMapOvr>
   <p:extLst>
     <p:ext uri="{DCECCB84-F9BA-43D5-87BE-67443E8EF086}">
-      <p15:sldGuideLst xmlns:p15="http://schemas.microsoft.com/office/powerpoint/2012/main">
+      <p15:sldGuideLst>
         <p15:guide id="1" orient="horz" pos="4088">
           <p15:clr>
-            <a:srgbClr val="FBAE40"/>
+            <a:srgbClr val="E4A34C"/>
           </p15:clr>
         </p15:guide>
         <p15:guide id="2" pos="7446">
           <p15:clr>
-            <a:srgbClr val="FBAE40"/>
+            <a:srgbClr val="E4A34C"/>
           </p15:clr>
         </p15:guide>
       </p15:sldGuideLst>
@@ -13554,7 +13913,7 @@
 </file>
 
 <file path=ppt/slideLayouts/slideLayout2.xml><?xml version="1.0" encoding="utf-8"?>
-<p:sldLayout xmlns:a="http://schemas.openxmlformats.org/drawingml/2006/main" xmlns:r="http://schemas.openxmlformats.org/officeDocument/2006/relationships" xmlns:p="http://schemas.openxmlformats.org/presentationml/2006/main" matchingName="Blank slide" preserve="1" userDrawn="1">
+<p:sldLayout xmlns:a="http://schemas.openxmlformats.org/drawingml/2006/main" xmlns:ns3="http://schemas.microsoft.com/office/drawing/2014/main" xmlns:p="http://schemas.openxmlformats.org/presentationml/2006/main" xmlns:p14="http://schemas.microsoft.com/office/powerpoint/2010/main" xmlns:r="http://schemas.openxmlformats.org/officeDocument/2006/relationships" matchingName="Blank slide" preserve="1" userDrawn="1">
   <p:cSld name="Section Header">
     <p:spTree>
       <p:nvGrpSpPr>
@@ -13614,7 +13973,7 @@
           <a:noFill/>
           <a:ln w="25400" cap="flat" cmpd="sng">
             <a:solidFill>
-              <a:srgbClr val="DA4C4C"/>
+              <a:srgbClr val="CA5651"/>
             </a:solidFill>
             <a:prstDash val="dot"/>
             <a:miter lim="800000"/>
@@ -13662,14 +14021,14 @@
                 <a:spcPts val="0"/>
               </a:spcAft>
               <a:buClr>
-                <a:srgbClr val="DA4C4C"/>
+                <a:srgbClr val="CA5651"/>
               </a:buClr>
               <a:buSzPts val="4400"/>
               <a:buFont typeface="Arial"/>
               <a:buNone/>
-              <a:defRPr sz="4000" b="1" cap="none">
+              <a:defRPr sz="2400" b="1" cap="none">
                 <a:solidFill>
-                  <a:srgbClr val="DA4C4C"/>
+                  <a:srgbClr val="CA5651"/>
                 </a:solidFill>
                 <a:latin typeface="Arial"/>
                 <a:ea typeface="Arial"/>
@@ -13689,7 +14048,12 @@
               </a:spcAft>
               <a:buSzPts val="1400"/>
               <a:buNone/>
-              <a:defRPr/>
+              <a:defRPr sz="2400" b="1">
+                <a:latin typeface="Arial"/>
+                <a:solidFill>
+                  <a:srgbClr val="CA5651"/>
+                </a:solidFill>
+              </a:defRPr>
             </a:lvl2pPr>
             <a:lvl3pPr lvl="2" algn="l">
               <a:lnSpc>
@@ -13703,7 +14067,12 @@
               </a:spcAft>
               <a:buSzPts val="1400"/>
               <a:buNone/>
-              <a:defRPr/>
+              <a:defRPr sz="2400" b="1">
+                <a:latin typeface="Arial"/>
+                <a:solidFill>
+                  <a:srgbClr val="CA5651"/>
+                </a:solidFill>
+              </a:defRPr>
             </a:lvl3pPr>
             <a:lvl4pPr lvl="3" algn="l">
               <a:lnSpc>
@@ -13717,7 +14086,12 @@
               </a:spcAft>
               <a:buSzPts val="1400"/>
               <a:buNone/>
-              <a:defRPr/>
+              <a:defRPr sz="2400" b="1">
+                <a:latin typeface="Arial"/>
+                <a:solidFill>
+                  <a:srgbClr val="CA5651"/>
+                </a:solidFill>
+              </a:defRPr>
             </a:lvl4pPr>
             <a:lvl5pPr lvl="4" algn="l">
               <a:lnSpc>
@@ -13731,7 +14105,12 @@
               </a:spcAft>
               <a:buSzPts val="1400"/>
               <a:buNone/>
-              <a:defRPr/>
+              <a:defRPr sz="2400" b="1">
+                <a:latin typeface="Arial"/>
+                <a:solidFill>
+                  <a:srgbClr val="CA5651"/>
+                </a:solidFill>
+              </a:defRPr>
             </a:lvl5pPr>
             <a:lvl6pPr lvl="5" algn="l">
               <a:lnSpc>
@@ -13745,7 +14124,12 @@
               </a:spcAft>
               <a:buSzPts val="1400"/>
               <a:buNone/>
-              <a:defRPr/>
+              <a:defRPr sz="2400" b="1">
+                <a:latin typeface="Arial"/>
+                <a:solidFill>
+                  <a:srgbClr val="CA5651"/>
+                </a:solidFill>
+              </a:defRPr>
             </a:lvl6pPr>
             <a:lvl7pPr lvl="6" algn="l">
               <a:lnSpc>
@@ -13759,7 +14143,12 @@
               </a:spcAft>
               <a:buSzPts val="1400"/>
               <a:buNone/>
-              <a:defRPr/>
+              <a:defRPr sz="2400" b="1">
+                <a:latin typeface="Arial"/>
+                <a:solidFill>
+                  <a:srgbClr val="CA5651"/>
+                </a:solidFill>
+              </a:defRPr>
             </a:lvl7pPr>
             <a:lvl8pPr lvl="7" algn="l">
               <a:lnSpc>
@@ -13773,7 +14162,12 @@
               </a:spcAft>
               <a:buSzPts val="1400"/>
               <a:buNone/>
-              <a:defRPr/>
+              <a:defRPr sz="2400" b="1">
+                <a:latin typeface="Arial"/>
+                <a:solidFill>
+                  <a:srgbClr val="CA5651"/>
+                </a:solidFill>
+              </a:defRPr>
             </a:lvl8pPr>
             <a:lvl9pPr lvl="8" algn="l">
               <a:lnSpc>
@@ -13787,15 +14181,30 @@
               </a:spcAft>
               <a:buSzPts val="1400"/>
               <a:buNone/>
-              <a:defRPr/>
+              <a:defRPr sz="2400" b="1">
+                <a:latin typeface="Arial"/>
+                <a:solidFill>
+                  <a:srgbClr val="CA5651"/>
+                </a:solidFill>
+              </a:defRPr>
             </a:lvl9pPr>
           </a:lstStyle>
           <a:p>
             <a:r>
-              <a:rPr lang="es-MX" dirty="0"/>
+              <a:rPr lang="es-MX" dirty="0" sz="2400" b="1">
+                <a:latin typeface="Arial"/>
+                <a:solidFill>
+                  <a:srgbClr val="CA5651"/>
+                </a:solidFill>
+              </a:rPr>
               <a:t>Haz clic para modificar el estilo de título del patrón</a:t>
             </a:r>
-            <a:endParaRPr dirty="0"/>
+            <a:endParaRPr dirty="0" sz="2400" b="1">
+              <a:latin typeface="Arial"/>
+              <a:solidFill>
+                <a:srgbClr val="CA5651"/>
+              </a:solidFill>
+            </a:endParaRPr>
           </a:p>
         </p:txBody>
       </p:sp>
@@ -14032,7 +14441,7 @@
           <a:noFill/>
           <a:ln w="25400" cap="flat" cmpd="sng">
             <a:solidFill>
-              <a:srgbClr val="8DA9DB"/>
+              <a:srgbClr val="7594CC"/>
             </a:solidFill>
             <a:prstDash val="dot"/>
             <a:miter lim="800000"/>
@@ -14073,7 +14482,7 @@
           <p:cNvPr id="2" name="Google Shape;66;p47">
             <a:extLst>
               <a:ext uri="{FF2B5EF4-FFF2-40B4-BE49-F238E27FC236}">
-                <a16:creationId xmlns:a16="http://schemas.microsoft.com/office/drawing/2014/main" id="{0CFD2EB8-0056-44C4-CBCA-C1E801F8F1A9}"/>
+                <ns3:creationId id="{0CFD2EB8-0056-44C4-CBCA-C1E801F8F1A9}"/>
               </a:ext>
             </a:extLst>
           </p:cNvPr>
@@ -14104,7 +14513,7 @@
     </p:spTree>
     <p:extLst>
       <p:ext uri="{BB962C8B-B14F-4D97-AF65-F5344CB8AC3E}">
-        <p14:creationId xmlns:p14="http://schemas.microsoft.com/office/powerpoint/2010/main" val="1161499325"/>
+        <p14:creationId val="1161499325"/>
       </p:ext>
     </p:extLst>
   </p:cSld>
@@ -14115,7 +14524,7 @@
 </file>
 
 <file path=ppt/slideLayouts/slideLayout20.xml><?xml version="1.0" encoding="utf-8"?>
-<p:sldLayout xmlns:a="http://schemas.openxmlformats.org/drawingml/2006/main" xmlns:r="http://schemas.openxmlformats.org/officeDocument/2006/relationships" xmlns:p="http://schemas.openxmlformats.org/presentationml/2006/main" matchingName="Dos objetos" preserve="1" userDrawn="1">
+<p:sldLayout xmlns:a="http://schemas.openxmlformats.org/drawingml/2006/main" xmlns:ns3="http://schemas.microsoft.com/office/drawing/2014/main" xmlns:p="http://schemas.openxmlformats.org/presentationml/2006/main" xmlns:p14="http://schemas.microsoft.com/office/powerpoint/2010/main" xmlns:p15="http://schemas.microsoft.com/office/powerpoint/2012/main" xmlns:r="http://schemas.openxmlformats.org/officeDocument/2006/relationships" matchingName="Dos objetos" preserve="1" userDrawn="1">
   <p:cSld name="poblacion_4">
     <p:spTree>
       <p:nvGrpSpPr>
@@ -14197,14 +14606,14 @@
                 <a:spcPts val="0"/>
               </a:spcAft>
               <a:buClr>
-                <a:srgbClr val="DA4C4C"/>
+                <a:srgbClr val="CA5651"/>
               </a:buClr>
               <a:buSzPts val="2400"/>
               <a:buFont typeface="Arial"/>
               <a:buNone/>
               <a:defRPr sz="2400" b="1" cap="none">
                 <a:solidFill>
-                  <a:srgbClr val="DA4C4C"/>
+                  <a:srgbClr val="CA5651"/>
                 </a:solidFill>
                 <a:latin typeface="Arial"/>
                 <a:ea typeface="Arial"/>
@@ -14224,7 +14633,12 @@
               </a:spcAft>
               <a:buSzPts val="1400"/>
               <a:buNone/>
-              <a:defRPr/>
+              <a:defRPr sz="2400" b="1">
+                <a:latin typeface="Arial"/>
+                <a:solidFill>
+                  <a:srgbClr val="CA5651"/>
+                </a:solidFill>
+              </a:defRPr>
             </a:lvl2pPr>
             <a:lvl3pPr lvl="2" algn="l">
               <a:lnSpc>
@@ -14238,7 +14652,12 @@
               </a:spcAft>
               <a:buSzPts val="1400"/>
               <a:buNone/>
-              <a:defRPr/>
+              <a:defRPr sz="2400" b="1">
+                <a:latin typeface="Arial"/>
+                <a:solidFill>
+                  <a:srgbClr val="CA5651"/>
+                </a:solidFill>
+              </a:defRPr>
             </a:lvl3pPr>
             <a:lvl4pPr lvl="3" algn="l">
               <a:lnSpc>
@@ -14252,7 +14671,12 @@
               </a:spcAft>
               <a:buSzPts val="1400"/>
               <a:buNone/>
-              <a:defRPr/>
+              <a:defRPr sz="2400" b="1">
+                <a:latin typeface="Arial"/>
+                <a:solidFill>
+                  <a:srgbClr val="CA5651"/>
+                </a:solidFill>
+              </a:defRPr>
             </a:lvl4pPr>
             <a:lvl5pPr lvl="4" algn="l">
               <a:lnSpc>
@@ -14266,7 +14690,12 @@
               </a:spcAft>
               <a:buSzPts val="1400"/>
               <a:buNone/>
-              <a:defRPr/>
+              <a:defRPr sz="2400" b="1">
+                <a:latin typeface="Arial"/>
+                <a:solidFill>
+                  <a:srgbClr val="CA5651"/>
+                </a:solidFill>
+              </a:defRPr>
             </a:lvl5pPr>
             <a:lvl6pPr lvl="5" algn="l">
               <a:lnSpc>
@@ -14280,7 +14709,12 @@
               </a:spcAft>
               <a:buSzPts val="1400"/>
               <a:buNone/>
-              <a:defRPr/>
+              <a:defRPr sz="2400" b="1">
+                <a:latin typeface="Arial"/>
+                <a:solidFill>
+                  <a:srgbClr val="CA5651"/>
+                </a:solidFill>
+              </a:defRPr>
             </a:lvl6pPr>
             <a:lvl7pPr lvl="6" algn="l">
               <a:lnSpc>
@@ -14294,7 +14728,12 @@
               </a:spcAft>
               <a:buSzPts val="1400"/>
               <a:buNone/>
-              <a:defRPr/>
+              <a:defRPr sz="2400" b="1">
+                <a:latin typeface="Arial"/>
+                <a:solidFill>
+                  <a:srgbClr val="CA5651"/>
+                </a:solidFill>
+              </a:defRPr>
             </a:lvl7pPr>
             <a:lvl8pPr lvl="7" algn="l">
               <a:lnSpc>
@@ -14308,7 +14747,12 @@
               </a:spcAft>
               <a:buSzPts val="1400"/>
               <a:buNone/>
-              <a:defRPr/>
+              <a:defRPr sz="2400" b="1">
+                <a:latin typeface="Arial"/>
+                <a:solidFill>
+                  <a:srgbClr val="CA5651"/>
+                </a:solidFill>
+              </a:defRPr>
             </a:lvl8pPr>
             <a:lvl9pPr lvl="8" algn="l">
               <a:lnSpc>
@@ -14322,15 +14766,30 @@
               </a:spcAft>
               <a:buSzPts val="1400"/>
               <a:buNone/>
-              <a:defRPr/>
+              <a:defRPr sz="2400" b="1">
+                <a:latin typeface="Arial"/>
+                <a:solidFill>
+                  <a:srgbClr val="CA5651"/>
+                </a:solidFill>
+              </a:defRPr>
             </a:lvl9pPr>
           </a:lstStyle>
           <a:p>
             <a:r>
-              <a:rPr lang="es-MX"/>
+              <a:rPr lang="es-MX" sz="2400" b="1">
+                <a:latin typeface="Arial"/>
+                <a:solidFill>
+                  <a:srgbClr val="CA5651"/>
+                </a:solidFill>
+              </a:rPr>
               <a:t>Haz clic para modificar el estilo de título del patrón</a:t>
             </a:r>
-            <a:endParaRPr dirty="0"/>
+            <a:endParaRPr dirty="0" sz="2400" b="1">
+              <a:latin typeface="Arial"/>
+              <a:solidFill>
+                <a:srgbClr val="CA5651"/>
+              </a:solidFill>
+            </a:endParaRPr>
           </a:p>
         </p:txBody>
       </p:sp>
@@ -14339,7 +14798,7 @@
           <p:cNvPr id="6" name="Picture Placeholder 5">
             <a:extLst>
               <a:ext uri="{FF2B5EF4-FFF2-40B4-BE49-F238E27FC236}">
-                <a16:creationId xmlns:a16="http://schemas.microsoft.com/office/drawing/2014/main" id="{EB977788-EA90-94F5-A207-15EBBD7FEAB5}"/>
+                <ns3:creationId id="{EB977788-EA90-94F5-A207-15EBBD7FEAB5}"/>
               </a:ext>
             </a:extLst>
           </p:cNvPr>
@@ -14372,7 +14831,7 @@
           <p:cNvPr id="7" name="Picture Placeholder 5">
             <a:extLst>
               <a:ext uri="{FF2B5EF4-FFF2-40B4-BE49-F238E27FC236}">
-                <a16:creationId xmlns:a16="http://schemas.microsoft.com/office/drawing/2014/main" id="{0519FE1F-4FD7-A2A0-81FB-8DCD6F26C4FB}"/>
+                <ns3:creationId id="{0519FE1F-4FD7-A2A0-81FB-8DCD6F26C4FB}"/>
               </a:ext>
             </a:extLst>
           </p:cNvPr>
@@ -14402,7 +14861,7 @@
           <p:cNvPr id="8" name="Picture Placeholder 5">
             <a:extLst>
               <a:ext uri="{FF2B5EF4-FFF2-40B4-BE49-F238E27FC236}">
-                <a16:creationId xmlns:a16="http://schemas.microsoft.com/office/drawing/2014/main" id="{358A77CA-4946-E677-D51B-A8CE149E91B8}"/>
+                <ns3:creationId id="{358A77CA-4946-E677-D51B-A8CE149E91B8}"/>
               </a:ext>
             </a:extLst>
           </p:cNvPr>
@@ -14435,7 +14894,7 @@
           <p:cNvPr id="9" name="Picture Placeholder 5">
             <a:extLst>
               <a:ext uri="{FF2B5EF4-FFF2-40B4-BE49-F238E27FC236}">
-                <a16:creationId xmlns:a16="http://schemas.microsoft.com/office/drawing/2014/main" id="{BCB5FD43-B8F1-2FB4-7780-90EF06D911E6}"/>
+                <ns3:creationId id="{BCB5FD43-B8F1-2FB4-7780-90EF06D911E6}"/>
               </a:ext>
             </a:extLst>
           </p:cNvPr>
@@ -14465,7 +14924,7 @@
           <p:cNvPr id="2" name="Text Placeholder 9">
             <a:extLst>
               <a:ext uri="{FF2B5EF4-FFF2-40B4-BE49-F238E27FC236}">
-                <a16:creationId xmlns:a16="http://schemas.microsoft.com/office/drawing/2014/main" id="{0C929747-7B86-54B8-A590-1398C659B7EC}"/>
+                <ns3:creationId id="{0C929747-7B86-54B8-A590-1398C659B7EC}"/>
               </a:ext>
             </a:extLst>
           </p:cNvPr>
@@ -14546,7 +15005,7 @@
           <p:cNvPr id="15" name="Content Placeholder 5">
             <a:extLst>
               <a:ext uri="{FF2B5EF4-FFF2-40B4-BE49-F238E27FC236}">
-                <a16:creationId xmlns:a16="http://schemas.microsoft.com/office/drawing/2014/main" id="{90549C15-2749-16D6-FCA5-952FD115553E}"/>
+                <ns3:creationId id="{90549C15-2749-16D6-FCA5-952FD115553E}"/>
               </a:ext>
             </a:extLst>
           </p:cNvPr>
@@ -14607,7 +15066,7 @@
     </p:spTree>
     <p:extLst>
       <p:ext uri="{BB962C8B-B14F-4D97-AF65-F5344CB8AC3E}">
-        <p14:creationId xmlns:p14="http://schemas.microsoft.com/office/powerpoint/2010/main" val="1490820941"/>
+        <p14:creationId val="1490820941"/>
       </p:ext>
     </p:extLst>
   </p:cSld>
@@ -14616,15 +15075,15 @@
   </p:clrMapOvr>
   <p:extLst>
     <p:ext uri="{DCECCB84-F9BA-43D5-87BE-67443E8EF086}">
-      <p15:sldGuideLst xmlns:p15="http://schemas.microsoft.com/office/powerpoint/2012/main">
+      <p15:sldGuideLst>
         <p15:guide id="1" orient="horz" pos="4088">
           <p15:clr>
-            <a:srgbClr val="FBAE40"/>
+            <a:srgbClr val="E4A34C"/>
           </p15:clr>
         </p15:guide>
         <p15:guide id="2" pos="7446">
           <p15:clr>
-            <a:srgbClr val="FBAE40"/>
+            <a:srgbClr val="E4A34C"/>
           </p15:clr>
         </p15:guide>
       </p15:sldGuideLst>
@@ -14634,7 +15093,7 @@
 </file>
 
 <file path=ppt/slideLayouts/slideLayout21.xml><?xml version="1.0" encoding="utf-8"?>
-<p:sldLayout xmlns:a="http://schemas.openxmlformats.org/drawingml/2006/main" xmlns:r="http://schemas.openxmlformats.org/officeDocument/2006/relationships" xmlns:p="http://schemas.openxmlformats.org/presentationml/2006/main" matchingName="Dos objetos" preserve="1" userDrawn="1">
+<p:sldLayout xmlns:a="http://schemas.openxmlformats.org/drawingml/2006/main" xmlns:ns3="http://schemas.microsoft.com/office/drawing/2014/main" xmlns:p="http://schemas.openxmlformats.org/presentationml/2006/main" xmlns:p14="http://schemas.microsoft.com/office/powerpoint/2010/main" xmlns:p15="http://schemas.microsoft.com/office/powerpoint/2012/main" xmlns:r="http://schemas.openxmlformats.org/officeDocument/2006/relationships" matchingName="Dos objetos" preserve="1" userDrawn="1">
   <p:cSld name="poblacion_5">
     <p:spTree>
       <p:nvGrpSpPr>
@@ -14716,14 +15175,14 @@
                 <a:spcPts val="0"/>
               </a:spcAft>
               <a:buClr>
-                <a:srgbClr val="DA4C4C"/>
+                <a:srgbClr val="CA5651"/>
               </a:buClr>
               <a:buSzPts val="2400"/>
               <a:buFont typeface="Arial"/>
               <a:buNone/>
               <a:defRPr sz="2400" b="1" cap="none">
                 <a:solidFill>
-                  <a:srgbClr val="DA4C4C"/>
+                  <a:srgbClr val="CA5651"/>
                 </a:solidFill>
                 <a:latin typeface="Arial"/>
                 <a:ea typeface="Arial"/>
@@ -14743,7 +15202,12 @@
               </a:spcAft>
               <a:buSzPts val="1400"/>
               <a:buNone/>
-              <a:defRPr/>
+              <a:defRPr sz="2400" b="1">
+                <a:latin typeface="Arial"/>
+                <a:solidFill>
+                  <a:srgbClr val="CA5651"/>
+                </a:solidFill>
+              </a:defRPr>
             </a:lvl2pPr>
             <a:lvl3pPr lvl="2" algn="l">
               <a:lnSpc>
@@ -14757,7 +15221,12 @@
               </a:spcAft>
               <a:buSzPts val="1400"/>
               <a:buNone/>
-              <a:defRPr/>
+              <a:defRPr sz="2400" b="1">
+                <a:latin typeface="Arial"/>
+                <a:solidFill>
+                  <a:srgbClr val="CA5651"/>
+                </a:solidFill>
+              </a:defRPr>
             </a:lvl3pPr>
             <a:lvl4pPr lvl="3" algn="l">
               <a:lnSpc>
@@ -14771,7 +15240,12 @@
               </a:spcAft>
               <a:buSzPts val="1400"/>
               <a:buNone/>
-              <a:defRPr/>
+              <a:defRPr sz="2400" b="1">
+                <a:latin typeface="Arial"/>
+                <a:solidFill>
+                  <a:srgbClr val="CA5651"/>
+                </a:solidFill>
+              </a:defRPr>
             </a:lvl4pPr>
             <a:lvl5pPr lvl="4" algn="l">
               <a:lnSpc>
@@ -14785,7 +15259,12 @@
               </a:spcAft>
               <a:buSzPts val="1400"/>
               <a:buNone/>
-              <a:defRPr/>
+              <a:defRPr sz="2400" b="1">
+                <a:latin typeface="Arial"/>
+                <a:solidFill>
+                  <a:srgbClr val="CA5651"/>
+                </a:solidFill>
+              </a:defRPr>
             </a:lvl5pPr>
             <a:lvl6pPr lvl="5" algn="l">
               <a:lnSpc>
@@ -14799,7 +15278,12 @@
               </a:spcAft>
               <a:buSzPts val="1400"/>
               <a:buNone/>
-              <a:defRPr/>
+              <a:defRPr sz="2400" b="1">
+                <a:latin typeface="Arial"/>
+                <a:solidFill>
+                  <a:srgbClr val="CA5651"/>
+                </a:solidFill>
+              </a:defRPr>
             </a:lvl6pPr>
             <a:lvl7pPr lvl="6" algn="l">
               <a:lnSpc>
@@ -14813,7 +15297,12 @@
               </a:spcAft>
               <a:buSzPts val="1400"/>
               <a:buNone/>
-              <a:defRPr/>
+              <a:defRPr sz="2400" b="1">
+                <a:latin typeface="Arial"/>
+                <a:solidFill>
+                  <a:srgbClr val="CA5651"/>
+                </a:solidFill>
+              </a:defRPr>
             </a:lvl7pPr>
             <a:lvl8pPr lvl="7" algn="l">
               <a:lnSpc>
@@ -14827,7 +15316,12 @@
               </a:spcAft>
               <a:buSzPts val="1400"/>
               <a:buNone/>
-              <a:defRPr/>
+              <a:defRPr sz="2400" b="1">
+                <a:latin typeface="Arial"/>
+                <a:solidFill>
+                  <a:srgbClr val="CA5651"/>
+                </a:solidFill>
+              </a:defRPr>
             </a:lvl8pPr>
             <a:lvl9pPr lvl="8" algn="l">
               <a:lnSpc>
@@ -14841,15 +15335,30 @@
               </a:spcAft>
               <a:buSzPts val="1400"/>
               <a:buNone/>
-              <a:defRPr/>
+              <a:defRPr sz="2400" b="1">
+                <a:latin typeface="Arial"/>
+                <a:solidFill>
+                  <a:srgbClr val="CA5651"/>
+                </a:solidFill>
+              </a:defRPr>
             </a:lvl9pPr>
           </a:lstStyle>
           <a:p>
             <a:r>
-              <a:rPr lang="es-MX"/>
+              <a:rPr lang="es-MX" sz="2400" b="1">
+                <a:latin typeface="Arial"/>
+                <a:solidFill>
+                  <a:srgbClr val="CA5651"/>
+                </a:solidFill>
+              </a:rPr>
               <a:t>Haz clic para modificar el estilo de título del patrón</a:t>
             </a:r>
-            <a:endParaRPr dirty="0"/>
+            <a:endParaRPr dirty="0" sz="2400" b="1">
+              <a:latin typeface="Arial"/>
+              <a:solidFill>
+                <a:srgbClr val="CA5651"/>
+              </a:solidFill>
+            </a:endParaRPr>
           </a:p>
         </p:txBody>
       </p:sp>
@@ -14858,7 +15367,7 @@
           <p:cNvPr id="6" name="Picture Placeholder 5">
             <a:extLst>
               <a:ext uri="{FF2B5EF4-FFF2-40B4-BE49-F238E27FC236}">
-                <a16:creationId xmlns:a16="http://schemas.microsoft.com/office/drawing/2014/main" id="{EB977788-EA90-94F5-A207-15EBBD7FEAB5}"/>
+                <ns3:creationId id="{EB977788-EA90-94F5-A207-15EBBD7FEAB5}"/>
               </a:ext>
             </a:extLst>
           </p:cNvPr>
@@ -14891,7 +15400,7 @@
           <p:cNvPr id="7" name="Picture Placeholder 5">
             <a:extLst>
               <a:ext uri="{FF2B5EF4-FFF2-40B4-BE49-F238E27FC236}">
-                <a16:creationId xmlns:a16="http://schemas.microsoft.com/office/drawing/2014/main" id="{0519FE1F-4FD7-A2A0-81FB-8DCD6F26C4FB}"/>
+                <ns3:creationId id="{0519FE1F-4FD7-A2A0-81FB-8DCD6F26C4FB}"/>
               </a:ext>
             </a:extLst>
           </p:cNvPr>
@@ -14921,7 +15430,7 @@
           <p:cNvPr id="8" name="Picture Placeholder 5">
             <a:extLst>
               <a:ext uri="{FF2B5EF4-FFF2-40B4-BE49-F238E27FC236}">
-                <a16:creationId xmlns:a16="http://schemas.microsoft.com/office/drawing/2014/main" id="{358A77CA-4946-E677-D51B-A8CE149E91B8}"/>
+                <ns3:creationId id="{358A77CA-4946-E677-D51B-A8CE149E91B8}"/>
               </a:ext>
             </a:extLst>
           </p:cNvPr>
@@ -14954,7 +15463,7 @@
           <p:cNvPr id="9" name="Picture Placeholder 5">
             <a:extLst>
               <a:ext uri="{FF2B5EF4-FFF2-40B4-BE49-F238E27FC236}">
-                <a16:creationId xmlns:a16="http://schemas.microsoft.com/office/drawing/2014/main" id="{BCB5FD43-B8F1-2FB4-7780-90EF06D911E6}"/>
+                <ns3:creationId id="{BCB5FD43-B8F1-2FB4-7780-90EF06D911E6}"/>
               </a:ext>
             </a:extLst>
           </p:cNvPr>
@@ -14984,7 +15493,7 @@
           <p:cNvPr id="2" name="Text Placeholder 9">
             <a:extLst>
               <a:ext uri="{FF2B5EF4-FFF2-40B4-BE49-F238E27FC236}">
-                <a16:creationId xmlns:a16="http://schemas.microsoft.com/office/drawing/2014/main" id="{0C929747-7B86-54B8-A590-1398C659B7EC}"/>
+                <ns3:creationId id="{0C929747-7B86-54B8-A590-1398C659B7EC}"/>
               </a:ext>
             </a:extLst>
           </p:cNvPr>
@@ -15065,7 +15574,7 @@
           <p:cNvPr id="3" name="Picture Placeholder 5">
             <a:extLst>
               <a:ext uri="{FF2B5EF4-FFF2-40B4-BE49-F238E27FC236}">
-                <a16:creationId xmlns:a16="http://schemas.microsoft.com/office/drawing/2014/main" id="{FF13B1B5-6F5F-20EC-604A-862023AA30E4}"/>
+                <ns3:creationId id="{FF13B1B5-6F5F-20EC-604A-862023AA30E4}"/>
               </a:ext>
             </a:extLst>
           </p:cNvPr>
@@ -15098,7 +15607,7 @@
           <p:cNvPr id="5" name="Content Placeholder 5">
             <a:extLst>
               <a:ext uri="{FF2B5EF4-FFF2-40B4-BE49-F238E27FC236}">
-                <a16:creationId xmlns:a16="http://schemas.microsoft.com/office/drawing/2014/main" id="{9BEDF34F-2A23-8AB4-5FA9-9E69BEAAC3CF}"/>
+                <ns3:creationId id="{9BEDF34F-2A23-8AB4-5FA9-9E69BEAAC3CF}"/>
               </a:ext>
             </a:extLst>
           </p:cNvPr>
@@ -15159,7 +15668,7 @@
     </p:spTree>
     <p:extLst>
       <p:ext uri="{BB962C8B-B14F-4D97-AF65-F5344CB8AC3E}">
-        <p14:creationId xmlns:p14="http://schemas.microsoft.com/office/powerpoint/2010/main" val="3365683856"/>
+        <p14:creationId val="3365683856"/>
       </p:ext>
     </p:extLst>
   </p:cSld>
@@ -15168,15 +15677,15 @@
   </p:clrMapOvr>
   <p:extLst>
     <p:ext uri="{DCECCB84-F9BA-43D5-87BE-67443E8EF086}">
-      <p15:sldGuideLst xmlns:p15="http://schemas.microsoft.com/office/powerpoint/2012/main">
+      <p15:sldGuideLst>
         <p15:guide id="1" orient="horz" pos="4088">
           <p15:clr>
-            <a:srgbClr val="FBAE40"/>
+            <a:srgbClr val="E4A34C"/>
           </p15:clr>
         </p15:guide>
         <p15:guide id="2" pos="7446">
           <p15:clr>
-            <a:srgbClr val="FBAE40"/>
+            <a:srgbClr val="E4A34C"/>
           </p15:clr>
         </p15:guide>
       </p15:sldGuideLst>
@@ -15186,7 +15695,7 @@
 </file>
 
 <file path=ppt/slideLayouts/slideLayout22.xml><?xml version="1.0" encoding="utf-8"?>
-<p:sldLayout xmlns:a="http://schemas.openxmlformats.org/drawingml/2006/main" xmlns:r="http://schemas.openxmlformats.org/officeDocument/2006/relationships" xmlns:p="http://schemas.openxmlformats.org/presentationml/2006/main" matchingName="Dos objetos" preserve="1" userDrawn="1">
+<p:sldLayout xmlns:a="http://schemas.openxmlformats.org/drawingml/2006/main" xmlns:ns3="http://schemas.microsoft.com/office/drawing/2014/main" xmlns:p="http://schemas.openxmlformats.org/presentationml/2006/main" xmlns:p14="http://schemas.microsoft.com/office/powerpoint/2010/main" xmlns:p15="http://schemas.microsoft.com/office/powerpoint/2012/main" xmlns:r="http://schemas.openxmlformats.org/officeDocument/2006/relationships" matchingName="Dos objetos" preserve="1" userDrawn="1">
   <p:cSld name="poblacion_6">
     <p:spTree>
       <p:nvGrpSpPr>
@@ -15268,14 +15777,14 @@
                 <a:spcPts val="0"/>
               </a:spcAft>
               <a:buClr>
-                <a:srgbClr val="DA4C4C"/>
+                <a:srgbClr val="CA5651"/>
               </a:buClr>
               <a:buSzPts val="2400"/>
               <a:buFont typeface="Arial"/>
               <a:buNone/>
               <a:defRPr sz="2400" b="1" cap="none">
                 <a:solidFill>
-                  <a:srgbClr val="DA4C4C"/>
+                  <a:srgbClr val="CA5651"/>
                 </a:solidFill>
                 <a:latin typeface="Arial"/>
                 <a:ea typeface="Arial"/>
@@ -15295,7 +15804,12 @@
               </a:spcAft>
               <a:buSzPts val="1400"/>
               <a:buNone/>
-              <a:defRPr/>
+              <a:defRPr sz="2400" b="1">
+                <a:latin typeface="Arial"/>
+                <a:solidFill>
+                  <a:srgbClr val="CA5651"/>
+                </a:solidFill>
+              </a:defRPr>
             </a:lvl2pPr>
             <a:lvl3pPr lvl="2" algn="l">
               <a:lnSpc>
@@ -15309,7 +15823,12 @@
               </a:spcAft>
               <a:buSzPts val="1400"/>
               <a:buNone/>
-              <a:defRPr/>
+              <a:defRPr sz="2400" b="1">
+                <a:latin typeface="Arial"/>
+                <a:solidFill>
+                  <a:srgbClr val="CA5651"/>
+                </a:solidFill>
+              </a:defRPr>
             </a:lvl3pPr>
             <a:lvl4pPr lvl="3" algn="l">
               <a:lnSpc>
@@ -15323,7 +15842,12 @@
               </a:spcAft>
               <a:buSzPts val="1400"/>
               <a:buNone/>
-              <a:defRPr/>
+              <a:defRPr sz="2400" b="1">
+                <a:latin typeface="Arial"/>
+                <a:solidFill>
+                  <a:srgbClr val="CA5651"/>
+                </a:solidFill>
+              </a:defRPr>
             </a:lvl4pPr>
             <a:lvl5pPr lvl="4" algn="l">
               <a:lnSpc>
@@ -15337,7 +15861,12 @@
               </a:spcAft>
               <a:buSzPts val="1400"/>
               <a:buNone/>
-              <a:defRPr/>
+              <a:defRPr sz="2400" b="1">
+                <a:latin typeface="Arial"/>
+                <a:solidFill>
+                  <a:srgbClr val="CA5651"/>
+                </a:solidFill>
+              </a:defRPr>
             </a:lvl5pPr>
             <a:lvl6pPr lvl="5" algn="l">
               <a:lnSpc>
@@ -15351,7 +15880,12 @@
               </a:spcAft>
               <a:buSzPts val="1400"/>
               <a:buNone/>
-              <a:defRPr/>
+              <a:defRPr sz="2400" b="1">
+                <a:latin typeface="Arial"/>
+                <a:solidFill>
+                  <a:srgbClr val="CA5651"/>
+                </a:solidFill>
+              </a:defRPr>
             </a:lvl6pPr>
             <a:lvl7pPr lvl="6" algn="l">
               <a:lnSpc>
@@ -15365,7 +15899,12 @@
               </a:spcAft>
               <a:buSzPts val="1400"/>
               <a:buNone/>
-              <a:defRPr/>
+              <a:defRPr sz="2400" b="1">
+                <a:latin typeface="Arial"/>
+                <a:solidFill>
+                  <a:srgbClr val="CA5651"/>
+                </a:solidFill>
+              </a:defRPr>
             </a:lvl7pPr>
             <a:lvl8pPr lvl="7" algn="l">
               <a:lnSpc>
@@ -15379,7 +15918,12 @@
               </a:spcAft>
               <a:buSzPts val="1400"/>
               <a:buNone/>
-              <a:defRPr/>
+              <a:defRPr sz="2400" b="1">
+                <a:latin typeface="Arial"/>
+                <a:solidFill>
+                  <a:srgbClr val="CA5651"/>
+                </a:solidFill>
+              </a:defRPr>
             </a:lvl8pPr>
             <a:lvl9pPr lvl="8" algn="l">
               <a:lnSpc>
@@ -15393,15 +15937,30 @@
               </a:spcAft>
               <a:buSzPts val="1400"/>
               <a:buNone/>
-              <a:defRPr/>
+              <a:defRPr sz="2400" b="1">
+                <a:latin typeface="Arial"/>
+                <a:solidFill>
+                  <a:srgbClr val="CA5651"/>
+                </a:solidFill>
+              </a:defRPr>
             </a:lvl9pPr>
           </a:lstStyle>
           <a:p>
             <a:r>
-              <a:rPr lang="es-MX"/>
+              <a:rPr lang="es-MX" sz="2400" b="1">
+                <a:latin typeface="Arial"/>
+                <a:solidFill>
+                  <a:srgbClr val="CA5651"/>
+                </a:solidFill>
+              </a:rPr>
               <a:t>Haz clic para modificar el estilo de título del patrón</a:t>
             </a:r>
-            <a:endParaRPr dirty="0"/>
+            <a:endParaRPr dirty="0" sz="2400" b="1">
+              <a:latin typeface="Arial"/>
+              <a:solidFill>
+                <a:srgbClr val="CA5651"/>
+              </a:solidFill>
+            </a:endParaRPr>
           </a:p>
         </p:txBody>
       </p:sp>
@@ -15410,7 +15969,7 @@
           <p:cNvPr id="6" name="Picture Placeholder 5">
             <a:extLst>
               <a:ext uri="{FF2B5EF4-FFF2-40B4-BE49-F238E27FC236}">
-                <a16:creationId xmlns:a16="http://schemas.microsoft.com/office/drawing/2014/main" id="{EB977788-EA90-94F5-A207-15EBBD7FEAB5}"/>
+                <ns3:creationId id="{EB977788-EA90-94F5-A207-15EBBD7FEAB5}"/>
               </a:ext>
             </a:extLst>
           </p:cNvPr>
@@ -15443,7 +16002,7 @@
           <p:cNvPr id="7" name="Picture Placeholder 5">
             <a:extLst>
               <a:ext uri="{FF2B5EF4-FFF2-40B4-BE49-F238E27FC236}">
-                <a16:creationId xmlns:a16="http://schemas.microsoft.com/office/drawing/2014/main" id="{0519FE1F-4FD7-A2A0-81FB-8DCD6F26C4FB}"/>
+                <ns3:creationId id="{0519FE1F-4FD7-A2A0-81FB-8DCD6F26C4FB}"/>
               </a:ext>
             </a:extLst>
           </p:cNvPr>
@@ -15473,7 +16032,7 @@
           <p:cNvPr id="8" name="Picture Placeholder 5">
             <a:extLst>
               <a:ext uri="{FF2B5EF4-FFF2-40B4-BE49-F238E27FC236}">
-                <a16:creationId xmlns:a16="http://schemas.microsoft.com/office/drawing/2014/main" id="{358A77CA-4946-E677-D51B-A8CE149E91B8}"/>
+                <ns3:creationId id="{358A77CA-4946-E677-D51B-A8CE149E91B8}"/>
               </a:ext>
             </a:extLst>
           </p:cNvPr>
@@ -15506,7 +16065,7 @@
           <p:cNvPr id="9" name="Picture Placeholder 5">
             <a:extLst>
               <a:ext uri="{FF2B5EF4-FFF2-40B4-BE49-F238E27FC236}">
-                <a16:creationId xmlns:a16="http://schemas.microsoft.com/office/drawing/2014/main" id="{BCB5FD43-B8F1-2FB4-7780-90EF06D911E6}"/>
+                <ns3:creationId id="{BCB5FD43-B8F1-2FB4-7780-90EF06D911E6}"/>
               </a:ext>
             </a:extLst>
           </p:cNvPr>
@@ -15536,7 +16095,7 @@
           <p:cNvPr id="2" name="Text Placeholder 9">
             <a:extLst>
               <a:ext uri="{FF2B5EF4-FFF2-40B4-BE49-F238E27FC236}">
-                <a16:creationId xmlns:a16="http://schemas.microsoft.com/office/drawing/2014/main" id="{0C929747-7B86-54B8-A590-1398C659B7EC}"/>
+                <ns3:creationId id="{0C929747-7B86-54B8-A590-1398C659B7EC}"/>
               </a:ext>
             </a:extLst>
           </p:cNvPr>
@@ -15617,7 +16176,7 @@
           <p:cNvPr id="3" name="Picture Placeholder 5">
             <a:extLst>
               <a:ext uri="{FF2B5EF4-FFF2-40B4-BE49-F238E27FC236}">
-                <a16:creationId xmlns:a16="http://schemas.microsoft.com/office/drawing/2014/main" id="{FF13B1B5-6F5F-20EC-604A-862023AA30E4}"/>
+                <ns3:creationId id="{FF13B1B5-6F5F-20EC-604A-862023AA30E4}"/>
               </a:ext>
             </a:extLst>
           </p:cNvPr>
@@ -15650,7 +16209,7 @@
           <p:cNvPr id="5" name="Picture Placeholder 5">
             <a:extLst>
               <a:ext uri="{FF2B5EF4-FFF2-40B4-BE49-F238E27FC236}">
-                <a16:creationId xmlns:a16="http://schemas.microsoft.com/office/drawing/2014/main" id="{A7FD9B9D-2056-3C8B-7D67-BE465E5460ED}"/>
+                <ns3:creationId id="{A7FD9B9D-2056-3C8B-7D67-BE465E5460ED}"/>
               </a:ext>
             </a:extLst>
           </p:cNvPr>
@@ -15683,7 +16242,7 @@
           <p:cNvPr id="10" name="Content Placeholder 5">
             <a:extLst>
               <a:ext uri="{FF2B5EF4-FFF2-40B4-BE49-F238E27FC236}">
-                <a16:creationId xmlns:a16="http://schemas.microsoft.com/office/drawing/2014/main" id="{B8FEC6FD-D71E-66DB-2E66-38C3CF383E38}"/>
+                <ns3:creationId id="{B8FEC6FD-D71E-66DB-2E66-38C3CF383E38}"/>
               </a:ext>
             </a:extLst>
           </p:cNvPr>
@@ -15744,7 +16303,7 @@
     </p:spTree>
     <p:extLst>
       <p:ext uri="{BB962C8B-B14F-4D97-AF65-F5344CB8AC3E}">
-        <p14:creationId xmlns:p14="http://schemas.microsoft.com/office/powerpoint/2010/main" val="4015789953"/>
+        <p14:creationId val="4015789953"/>
       </p:ext>
     </p:extLst>
   </p:cSld>
@@ -15753,15 +16312,15 @@
   </p:clrMapOvr>
   <p:extLst>
     <p:ext uri="{DCECCB84-F9BA-43D5-87BE-67443E8EF086}">
-      <p15:sldGuideLst xmlns:p15="http://schemas.microsoft.com/office/powerpoint/2012/main">
+      <p15:sldGuideLst>
         <p15:guide id="1" orient="horz" pos="4088">
           <p15:clr>
-            <a:srgbClr val="FBAE40"/>
+            <a:srgbClr val="E4A34C"/>
           </p15:clr>
         </p15:guide>
         <p15:guide id="2" pos="7446">
           <p15:clr>
-            <a:srgbClr val="FBAE40"/>
+            <a:srgbClr val="E4A34C"/>
           </p15:clr>
         </p15:guide>
       </p15:sldGuideLst>
@@ -15771,7 +16330,7 @@
 </file>
 
 <file path=ppt/slideLayouts/slideLayout23.xml><?xml version="1.0" encoding="utf-8"?>
-<p:sldLayout xmlns:a="http://schemas.openxmlformats.org/drawingml/2006/main" xmlns:r="http://schemas.openxmlformats.org/officeDocument/2006/relationships" xmlns:p="http://schemas.openxmlformats.org/presentationml/2006/main" matchingName="Título y objetos" preserve="1" userDrawn="1">
+<p:sldLayout xmlns:a="http://schemas.openxmlformats.org/drawingml/2006/main" xmlns:ns2="http://schemas.microsoft.com/office/drawing/2014/main" xmlns:p="http://schemas.openxmlformats.org/presentationml/2006/main" xmlns:p14="http://schemas.microsoft.com/office/powerpoint/2010/main" xmlns:p15="http://schemas.microsoft.com/office/powerpoint/2012/main" xmlns:r="http://schemas.openxmlformats.org/officeDocument/2006/relationships" matchingName="Título y objetos" preserve="1" userDrawn="1">
   <p:cSld name="Title and Content">
     <p:bg>
       <p:bgPr>
@@ -15800,7 +16359,7 @@
           <p:cNvPr id="3" name="Marcador de contenido 2">
             <a:extLst>
               <a:ext uri="{FF2B5EF4-FFF2-40B4-BE49-F238E27FC236}">
-                <a16:creationId xmlns:a16="http://schemas.microsoft.com/office/drawing/2014/main" id="{7CE752F9-9952-5C4B-CCA0-CF40BD420B8F}"/>
+                <ns2:creationId id="{7CE752F9-9952-5C4B-CCA0-CF40BD420B8F}"/>
               </a:ext>
             </a:extLst>
           </p:cNvPr>
@@ -15841,9 +16400,9 @@
               <a:buFont typeface="Arial"/>
               <a:buNone/>
               <a:tabLst/>
-              <a:defRPr lang="es-MX" sz="1800" b="1" i="0" u="none" strike="noStrike" cap="none" dirty="0" smtClean="0">
+              <a:defRPr lang="es-MX" sz="1400" b="0" i="0" u="none" strike="noStrike" cap="none" dirty="0" smtClean="0">
                 <a:solidFill>
-                  <a:srgbClr val="002060"/>
+                  <a:srgbClr val="081F5C"/>
                 </a:solidFill>
                 <a:latin typeface="Arial"/>
                 <a:ea typeface="Arial"/>
@@ -15867,9 +16426,9 @@
               <a:buFont typeface="Arial"/>
               <a:buNone/>
               <a:tabLst/>
-              <a:defRPr lang="es-MX" sz="1600" b="0" i="1" u="none" strike="noStrike" cap="none" dirty="0" smtClean="0">
+              <a:defRPr lang="es-MX" sz="1400" b="0" i="1" u="none" strike="noStrike" cap="none" dirty="0" smtClean="0">
                 <a:solidFill>
-                  <a:srgbClr val="002060"/>
+                  <a:srgbClr val="081F5C"/>
                 </a:solidFill>
                 <a:latin typeface="Arial"/>
                 <a:ea typeface="Arial"/>
@@ -15895,7 +16454,7 @@
               <a:tabLst/>
               <a:defRPr lang="es-MX" sz="1400" b="0" i="1" u="none" strike="noStrike" cap="none" dirty="0" smtClean="0">
                 <a:solidFill>
-                  <a:srgbClr val="002060"/>
+                  <a:srgbClr val="081F5C"/>
                 </a:solidFill>
                 <a:latin typeface="Arial"/>
                 <a:ea typeface="Arial"/>
@@ -15919,9 +16478,9 @@
               <a:buFont typeface="Arial"/>
               <a:buNone/>
               <a:tabLst/>
-              <a:defRPr lang="es-MX" sz="1200" b="0" i="1" u="none" strike="noStrike" cap="none" dirty="0" smtClean="0">
+              <a:defRPr lang="es-MX" sz="1400" b="0" i="1" u="none" strike="noStrike" cap="none" dirty="0" smtClean="0">
                 <a:solidFill>
-                  <a:srgbClr val="002060"/>
+                  <a:srgbClr val="081F5C"/>
                 </a:solidFill>
                 <a:latin typeface="Arial"/>
                 <a:ea typeface="Arial"/>
@@ -15945,9 +16504,9 @@
               <a:buFont typeface="Arial"/>
               <a:buNone/>
               <a:tabLst/>
-              <a:defRPr lang="es-PE" sz="1200" b="0" i="1" u="none" strike="noStrike" cap="none" dirty="0">
+              <a:defRPr lang="es-PE" sz="1400" b="0" i="1" u="none" strike="noStrike" cap="none" dirty="0">
                 <a:solidFill>
-                  <a:srgbClr val="002060"/>
+                  <a:srgbClr val="081F5C"/>
                 </a:solidFill>
                 <a:latin typeface="Arial"/>
                 <a:ea typeface="Arial"/>
@@ -15957,40 +16516,90 @@
             </a:lvl5pPr>
           </a:lstStyle>
           <a:p>
-            <a:pPr lvl="0"/>
-            <a:r>
-              <a:rPr lang="es-MX" dirty="0"/>
+            <a:pPr lvl="0" algn="just">
+              <a:lnSpc>
+                <a:spcPct val="100000"/>
+              </a:lnSpc>
+            </a:pPr>
+            <a:r>
+              <a:rPr lang="es-MX" dirty="0" sz="1400" b="0">
+                <a:latin typeface="Arial"/>
+                <a:solidFill>
+                  <a:srgbClr val="081F5C"/>
+                </a:solidFill>
+              </a:rPr>
               <a:t>Haga clic para modificar los estilos de texto del patrón</a:t>
             </a:r>
           </a:p>
           <a:p>
-            <a:pPr lvl="1"/>
-            <a:r>
-              <a:rPr lang="es-MX" dirty="0"/>
+            <a:pPr lvl="1" algn="just">
+              <a:lnSpc>
+                <a:spcPct val="100000"/>
+              </a:lnSpc>
+            </a:pPr>
+            <a:r>
+              <a:rPr lang="es-MX" dirty="0" sz="1400" b="0">
+                <a:latin typeface="Arial"/>
+                <a:solidFill>
+                  <a:srgbClr val="081F5C"/>
+                </a:solidFill>
+              </a:rPr>
               <a:t>Segundo nivel</a:t>
             </a:r>
           </a:p>
           <a:p>
-            <a:pPr lvl="2"/>
-            <a:r>
-              <a:rPr lang="es-MX" dirty="0"/>
+            <a:pPr lvl="2" algn="just">
+              <a:lnSpc>
+                <a:spcPct val="100000"/>
+              </a:lnSpc>
+            </a:pPr>
+            <a:r>
+              <a:rPr lang="es-MX" dirty="0" sz="1400" b="0">
+                <a:latin typeface="Arial"/>
+                <a:solidFill>
+                  <a:srgbClr val="081F5C"/>
+                </a:solidFill>
+              </a:rPr>
               <a:t>Tercer nivel</a:t>
             </a:r>
           </a:p>
           <a:p>
-            <a:pPr lvl="3"/>
-            <a:r>
-              <a:rPr lang="es-MX" dirty="0"/>
+            <a:pPr lvl="3" algn="just">
+              <a:lnSpc>
+                <a:spcPct val="100000"/>
+              </a:lnSpc>
+            </a:pPr>
+            <a:r>
+              <a:rPr lang="es-MX" dirty="0" sz="1400" b="0">
+                <a:latin typeface="Arial"/>
+                <a:solidFill>
+                  <a:srgbClr val="081F5C"/>
+                </a:solidFill>
+              </a:rPr>
               <a:t>Cuarto nivel</a:t>
             </a:r>
           </a:p>
           <a:p>
-            <a:pPr lvl="4"/>
-            <a:r>
-              <a:rPr lang="es-MX" dirty="0"/>
+            <a:pPr lvl="4" algn="just">
+              <a:lnSpc>
+                <a:spcPct val="100000"/>
+              </a:lnSpc>
+            </a:pPr>
+            <a:r>
+              <a:rPr lang="es-MX" dirty="0" sz="1400" b="0">
+                <a:latin typeface="Arial"/>
+                <a:solidFill>
+                  <a:srgbClr val="081F5C"/>
+                </a:solidFill>
+              </a:rPr>
               <a:t>Quinto nivel</a:t>
             </a:r>
-            <a:endParaRPr lang="es-PE" dirty="0"/>
+            <a:endParaRPr lang="es-PE" dirty="0" sz="1400" b="0">
+              <a:latin typeface="Arial"/>
+              <a:solidFill>
+                <a:srgbClr val="081F5C"/>
+              </a:solidFill>
+            </a:endParaRPr>
           </a:p>
         </p:txBody>
       </p:sp>
@@ -16033,14 +16642,14 @@
                 <a:spcPts val="0"/>
               </a:spcAft>
               <a:buClr>
-                <a:srgbClr val="DA4C4C"/>
+                <a:srgbClr val="CA5651"/>
               </a:buClr>
               <a:buSzPts val="2400"/>
               <a:buFont typeface="Arial"/>
               <a:buNone/>
               <a:defRPr sz="2400" b="1" cap="none">
                 <a:solidFill>
-                  <a:srgbClr val="DA4C4C"/>
+                  <a:srgbClr val="CA5651"/>
                 </a:solidFill>
                 <a:latin typeface="Arial"/>
                 <a:ea typeface="Arial"/>
@@ -16060,7 +16669,12 @@
               </a:spcAft>
               <a:buSzPts val="1400"/>
               <a:buNone/>
-              <a:defRPr/>
+              <a:defRPr sz="2400" b="1">
+                <a:latin typeface="Arial"/>
+                <a:solidFill>
+                  <a:srgbClr val="CA5651"/>
+                </a:solidFill>
+              </a:defRPr>
             </a:lvl2pPr>
             <a:lvl3pPr lvl="2" algn="l">
               <a:lnSpc>
@@ -16074,7 +16688,12 @@
               </a:spcAft>
               <a:buSzPts val="1400"/>
               <a:buNone/>
-              <a:defRPr/>
+              <a:defRPr sz="2400" b="1">
+                <a:latin typeface="Arial"/>
+                <a:solidFill>
+                  <a:srgbClr val="CA5651"/>
+                </a:solidFill>
+              </a:defRPr>
             </a:lvl3pPr>
             <a:lvl4pPr lvl="3" algn="l">
               <a:lnSpc>
@@ -16088,7 +16707,12 @@
               </a:spcAft>
               <a:buSzPts val="1400"/>
               <a:buNone/>
-              <a:defRPr/>
+              <a:defRPr sz="2400" b="1">
+                <a:latin typeface="Arial"/>
+                <a:solidFill>
+                  <a:srgbClr val="CA5651"/>
+                </a:solidFill>
+              </a:defRPr>
             </a:lvl4pPr>
             <a:lvl5pPr lvl="4" algn="l">
               <a:lnSpc>
@@ -16102,7 +16726,12 @@
               </a:spcAft>
               <a:buSzPts val="1400"/>
               <a:buNone/>
-              <a:defRPr/>
+              <a:defRPr sz="2400" b="1">
+                <a:latin typeface="Arial"/>
+                <a:solidFill>
+                  <a:srgbClr val="CA5651"/>
+                </a:solidFill>
+              </a:defRPr>
             </a:lvl5pPr>
             <a:lvl6pPr lvl="5" algn="l">
               <a:lnSpc>
@@ -16116,7 +16745,12 @@
               </a:spcAft>
               <a:buSzPts val="1400"/>
               <a:buNone/>
-              <a:defRPr/>
+              <a:defRPr sz="2400" b="1">
+                <a:latin typeface="Arial"/>
+                <a:solidFill>
+                  <a:srgbClr val="CA5651"/>
+                </a:solidFill>
+              </a:defRPr>
             </a:lvl6pPr>
             <a:lvl7pPr lvl="6" algn="l">
               <a:lnSpc>
@@ -16130,7 +16764,12 @@
               </a:spcAft>
               <a:buSzPts val="1400"/>
               <a:buNone/>
-              <a:defRPr/>
+              <a:defRPr sz="2400" b="1">
+                <a:latin typeface="Arial"/>
+                <a:solidFill>
+                  <a:srgbClr val="CA5651"/>
+                </a:solidFill>
+              </a:defRPr>
             </a:lvl7pPr>
             <a:lvl8pPr lvl="7" algn="l">
               <a:lnSpc>
@@ -16144,7 +16783,12 @@
               </a:spcAft>
               <a:buSzPts val="1400"/>
               <a:buNone/>
-              <a:defRPr/>
+              <a:defRPr sz="2400" b="1">
+                <a:latin typeface="Arial"/>
+                <a:solidFill>
+                  <a:srgbClr val="CA5651"/>
+                </a:solidFill>
+              </a:defRPr>
             </a:lvl8pPr>
             <a:lvl9pPr lvl="8" algn="l">
               <a:lnSpc>
@@ -16158,15 +16802,30 @@
               </a:spcAft>
               <a:buSzPts val="1400"/>
               <a:buNone/>
-              <a:defRPr/>
+              <a:defRPr sz="2400" b="1">
+                <a:latin typeface="Arial"/>
+                <a:solidFill>
+                  <a:srgbClr val="CA5651"/>
+                </a:solidFill>
+              </a:defRPr>
             </a:lvl9pPr>
           </a:lstStyle>
           <a:p>
             <a:r>
-              <a:rPr lang="es-MX" dirty="0"/>
+              <a:rPr lang="es-MX" dirty="0" sz="2400" b="1">
+                <a:latin typeface="Arial"/>
+                <a:solidFill>
+                  <a:srgbClr val="CA5651"/>
+                </a:solidFill>
+              </a:rPr>
               <a:t>Haz clic para modificar el estilo de título del patrón</a:t>
             </a:r>
-            <a:endParaRPr dirty="0"/>
+            <a:endParaRPr dirty="0" sz="2400" b="1">
+              <a:latin typeface="Arial"/>
+              <a:solidFill>
+                <a:srgbClr val="CA5651"/>
+              </a:solidFill>
+            </a:endParaRPr>
           </a:p>
         </p:txBody>
       </p:sp>
@@ -16200,7 +16859,7 @@
     </p:spTree>
     <p:extLst>
       <p:ext uri="{BB962C8B-B14F-4D97-AF65-F5344CB8AC3E}">
-        <p14:creationId xmlns:p14="http://schemas.microsoft.com/office/powerpoint/2010/main" val="1735362092"/>
+        <p14:creationId val="1735362092"/>
       </p:ext>
     </p:extLst>
   </p:cSld>
@@ -16209,15 +16868,15 @@
   </p:clrMapOvr>
   <p:extLst>
     <p:ext uri="{DCECCB84-F9BA-43D5-87BE-67443E8EF086}">
-      <p15:sldGuideLst xmlns:p15="http://schemas.microsoft.com/office/powerpoint/2012/main">
+      <p15:sldGuideLst>
         <p15:guide id="1" orient="horz" pos="4088">
           <p15:clr>
-            <a:srgbClr val="FBAE40"/>
+            <a:srgbClr val="E4A34C"/>
           </p15:clr>
         </p15:guide>
         <p15:guide id="2" pos="7446">
           <p15:clr>
-            <a:srgbClr val="FBAE40"/>
+            <a:srgbClr val="E4A34C"/>
           </p15:clr>
         </p15:guide>
       </p15:sldGuideLst>
@@ -16227,7 +16886,7 @@
 </file>
 
 <file path=ppt/slideLayouts/slideLayout24.xml><?xml version="1.0" encoding="utf-8"?>
-<p:sldLayout xmlns:a="http://schemas.openxmlformats.org/drawingml/2006/main" xmlns:r="http://schemas.openxmlformats.org/officeDocument/2006/relationships" xmlns:p="http://schemas.openxmlformats.org/presentationml/2006/main" matchingName="ubicacion1" preserve="1" userDrawn="1">
+<p:sldLayout xmlns:a="http://schemas.openxmlformats.org/drawingml/2006/main" xmlns:ns3="http://schemas.microsoft.com/office/drawing/2014/main" xmlns:p="http://schemas.openxmlformats.org/presentationml/2006/main" xmlns:p14="http://schemas.microsoft.com/office/powerpoint/2010/main" xmlns:p15="http://schemas.microsoft.com/office/powerpoint/2012/main" xmlns:r="http://schemas.openxmlformats.org/officeDocument/2006/relationships" matchingName="ubicacion1" preserve="1" userDrawn="1">
   <p:cSld name="1_ubicacion1">
     <p:spTree>
       <p:nvGrpSpPr>
@@ -16611,7 +17270,7 @@
           <p:cNvPr id="7" name="Título 6">
             <a:extLst>
               <a:ext uri="{FF2B5EF4-FFF2-40B4-BE49-F238E27FC236}">
-                <a16:creationId xmlns:a16="http://schemas.microsoft.com/office/drawing/2014/main" id="{F48C24AF-2D41-9463-C6C1-CF976E6FC072}"/>
+                <ns3:creationId id="{F48C24AF-2D41-9463-C6C1-CF976E6FC072}"/>
               </a:ext>
             </a:extLst>
           </p:cNvPr>
@@ -16628,17 +17287,27 @@
           <a:lstStyle/>
           <a:p>
             <a:r>
-              <a:rPr lang="es-MX"/>
+              <a:rPr lang="es-MX" sz="2400" b="1">
+                <a:latin typeface="Arial"/>
+                <a:solidFill>
+                  <a:srgbClr val="CA5651"/>
+                </a:solidFill>
+              </a:rPr>
               <a:t>Haz clic para modificar el estilo de título del patrón</a:t>
             </a:r>
-            <a:endParaRPr lang="es-PE"/>
+            <a:endParaRPr lang="es-PE" sz="2400" b="1">
+              <a:latin typeface="Arial"/>
+              <a:solidFill>
+                <a:srgbClr val="CA5651"/>
+              </a:solidFill>
+            </a:endParaRPr>
           </a:p>
         </p:txBody>
       </p:sp>
     </p:spTree>
     <p:extLst>
       <p:ext uri="{BB962C8B-B14F-4D97-AF65-F5344CB8AC3E}">
-        <p14:creationId xmlns:p14="http://schemas.microsoft.com/office/powerpoint/2010/main" val="304183648"/>
+        <p14:creationId val="304183648"/>
       </p:ext>
     </p:extLst>
   </p:cSld>
@@ -16647,15 +17316,15 @@
   </p:clrMapOvr>
   <p:extLst>
     <p:ext uri="{DCECCB84-F9BA-43D5-87BE-67443E8EF086}">
-      <p15:sldGuideLst xmlns:p15="http://schemas.microsoft.com/office/powerpoint/2012/main">
+      <p15:sldGuideLst>
         <p15:guide id="1" orient="horz" pos="2160" userDrawn="1">
           <p15:clr>
-            <a:srgbClr val="FBAE40"/>
+            <a:srgbClr val="E4A34C"/>
           </p15:clr>
         </p15:guide>
         <p15:guide id="2" pos="3840" userDrawn="1">
           <p15:clr>
-            <a:srgbClr val="FBAE40"/>
+            <a:srgbClr val="E4A34C"/>
           </p15:clr>
         </p15:guide>
       </p15:sldGuideLst>
@@ -16665,7 +17334,7 @@
 </file>
 
 <file path=ppt/slideLayouts/slideLayout3.xml><?xml version="1.0" encoding="utf-8"?>
-<p:sldLayout xmlns:a="http://schemas.openxmlformats.org/drawingml/2006/main" xmlns:r="http://schemas.openxmlformats.org/officeDocument/2006/relationships" xmlns:p="http://schemas.openxmlformats.org/presentationml/2006/main" preserve="1" userDrawn="1">
+<p:sldLayout xmlns:a="http://schemas.openxmlformats.org/drawingml/2006/main" xmlns:ns2="http://schemas.microsoft.com/office/drawing/2014/main" xmlns:p="http://schemas.openxmlformats.org/presentationml/2006/main" xmlns:p14="http://schemas.microsoft.com/office/powerpoint/2010/main" xmlns:r="http://schemas.openxmlformats.org/officeDocument/2006/relationships" preserve="1" userDrawn="1">
   <p:cSld name="Graficos">
     <p:spTree>
       <p:nvGrpSpPr>
@@ -16686,7 +17355,7 @@
           <p:cNvPr id="7" name="Picture Placeholder 6">
             <a:extLst>
               <a:ext uri="{FF2B5EF4-FFF2-40B4-BE49-F238E27FC236}">
-                <a16:creationId xmlns:a16="http://schemas.microsoft.com/office/drawing/2014/main" id="{E427CC29-905D-BA98-A5A4-B7B9F878F0D2}"/>
+                <ns2:creationId id="{E427CC29-905D-BA98-A5A4-B7B9F878F0D2}"/>
               </a:ext>
             </a:extLst>
           </p:cNvPr>
@@ -16716,7 +17385,7 @@
           <p:cNvPr id="8" name="Google Shape;66;p47">
             <a:extLst>
               <a:ext uri="{FF2B5EF4-FFF2-40B4-BE49-F238E27FC236}">
-                <a16:creationId xmlns:a16="http://schemas.microsoft.com/office/drawing/2014/main" id="{8BCEE9CF-906A-83B1-E504-307DBA50FFE8}"/>
+                <ns2:creationId id="{8BCEE9CF-906A-83B1-E504-307DBA50FFE8}"/>
               </a:ext>
             </a:extLst>
           </p:cNvPr>
@@ -16749,7 +17418,7 @@
           <p:cNvPr id="2" name="Title 1">
             <a:extLst>
               <a:ext uri="{FF2B5EF4-FFF2-40B4-BE49-F238E27FC236}">
-                <a16:creationId xmlns:a16="http://schemas.microsoft.com/office/drawing/2014/main" id="{4171F0F9-C2A2-7009-053C-1D072BFEE8B5}"/>
+                <ns2:creationId id="{4171F0F9-C2A2-7009-053C-1D072BFEE8B5}"/>
               </a:ext>
             </a:extLst>
           </p:cNvPr>
@@ -16771,10 +17440,20 @@
           <a:lstStyle/>
           <a:p>
             <a:r>
-              <a:rPr lang="en-US" dirty="0"/>
+              <a:rPr lang="en-US" dirty="0" sz="2400" b="1">
+                <a:latin typeface="Arial"/>
+                <a:solidFill>
+                  <a:srgbClr val="CA5651"/>
+                </a:solidFill>
+              </a:rPr>
               <a:t>Click to edit Master title style</a:t>
             </a:r>
-            <a:endParaRPr lang="en-PE" dirty="0"/>
+            <a:endParaRPr lang="en-PE" dirty="0" sz="2400" b="1">
+              <a:latin typeface="Arial"/>
+              <a:solidFill>
+                <a:srgbClr val="CA5651"/>
+              </a:solidFill>
+            </a:endParaRPr>
           </a:p>
         </p:txBody>
       </p:sp>
@@ -16783,7 +17462,7 @@
           <p:cNvPr id="4" name="Text Placeholder 3">
             <a:extLst>
               <a:ext uri="{FF2B5EF4-FFF2-40B4-BE49-F238E27FC236}">
-                <a16:creationId xmlns:a16="http://schemas.microsoft.com/office/drawing/2014/main" id="{7F88E7A4-05C3-50CF-1083-330AAF17F153}"/>
+                <ns2:creationId id="{7F88E7A4-05C3-50CF-1083-330AAF17F153}"/>
               </a:ext>
             </a:extLst>
           </p:cNvPr>
@@ -16823,7 +17502,7 @@
           <p:cNvPr id="5" name="Text Placeholder 3">
             <a:extLst>
               <a:ext uri="{FF2B5EF4-FFF2-40B4-BE49-F238E27FC236}">
-                <a16:creationId xmlns:a16="http://schemas.microsoft.com/office/drawing/2014/main" id="{3D5B4322-3F63-D11D-E929-B96FF27027F4}"/>
+                <ns2:creationId id="{3D5B4322-3F63-D11D-E929-B96FF27027F4}"/>
               </a:ext>
             </a:extLst>
           </p:cNvPr>
@@ -16861,7 +17540,7 @@
     </p:spTree>
     <p:extLst>
       <p:ext uri="{BB962C8B-B14F-4D97-AF65-F5344CB8AC3E}">
-        <p14:creationId xmlns:p14="http://schemas.microsoft.com/office/powerpoint/2010/main" val="956569257"/>
+        <p14:creationId val="956569257"/>
       </p:ext>
     </p:extLst>
   </p:cSld>
@@ -16872,7 +17551,7 @@
 </file>
 
 <file path=ppt/slideLayouts/slideLayout4.xml><?xml version="1.0" encoding="utf-8"?>
-<p:sldLayout xmlns:a="http://schemas.openxmlformats.org/drawingml/2006/main" xmlns:r="http://schemas.openxmlformats.org/officeDocument/2006/relationships" xmlns:p="http://schemas.openxmlformats.org/presentationml/2006/main" preserve="1" userDrawn="1">
+<p:sldLayout xmlns:a="http://schemas.openxmlformats.org/drawingml/2006/main" xmlns:ns2="http://schemas.microsoft.com/office/drawing/2014/main" xmlns:p="http://schemas.openxmlformats.org/presentationml/2006/main" xmlns:p14="http://schemas.microsoft.com/office/powerpoint/2010/main" xmlns:r="http://schemas.openxmlformats.org/officeDocument/2006/relationships" preserve="1" userDrawn="1">
   <p:cSld name="Graficos2">
     <p:spTree>
       <p:nvGrpSpPr>
@@ -16893,7 +17572,7 @@
           <p:cNvPr id="2" name="Title 1">
             <a:extLst>
               <a:ext uri="{FF2B5EF4-FFF2-40B4-BE49-F238E27FC236}">
-                <a16:creationId xmlns:a16="http://schemas.microsoft.com/office/drawing/2014/main" id="{E161B1F1-83C7-C3F7-BF29-A7102FCCB32B}"/>
+                <ns2:creationId id="{E161B1F1-83C7-C3F7-BF29-A7102FCCB32B}"/>
               </a:ext>
             </a:extLst>
           </p:cNvPr>
@@ -16915,10 +17594,20 @@
           <a:lstStyle/>
           <a:p>
             <a:r>
-              <a:rPr lang="en-US" dirty="0"/>
+              <a:rPr lang="en-US" dirty="0" sz="2400" b="1">
+                <a:latin typeface="Arial"/>
+                <a:solidFill>
+                  <a:srgbClr val="CA5651"/>
+                </a:solidFill>
+              </a:rPr>
               <a:t>Click to edit Master title style</a:t>
             </a:r>
-            <a:endParaRPr lang="en-PE" dirty="0"/>
+            <a:endParaRPr lang="en-PE" dirty="0" sz="2400" b="1">
+              <a:latin typeface="Arial"/>
+              <a:solidFill>
+                <a:srgbClr val="CA5651"/>
+              </a:solidFill>
+            </a:endParaRPr>
           </a:p>
         </p:txBody>
       </p:sp>
@@ -16927,7 +17616,7 @@
           <p:cNvPr id="6" name="Google Shape;66;p47">
             <a:extLst>
               <a:ext uri="{FF2B5EF4-FFF2-40B4-BE49-F238E27FC236}">
-                <a16:creationId xmlns:a16="http://schemas.microsoft.com/office/drawing/2014/main" id="{323E205B-F311-E78C-D6A8-0122851FE66D}"/>
+                <ns2:creationId id="{323E205B-F311-E78C-D6A8-0122851FE66D}"/>
               </a:ext>
             </a:extLst>
           </p:cNvPr>
@@ -16960,7 +17649,7 @@
           <p:cNvPr id="8" name="Picture Placeholder 7">
             <a:extLst>
               <a:ext uri="{FF2B5EF4-FFF2-40B4-BE49-F238E27FC236}">
-                <a16:creationId xmlns:a16="http://schemas.microsoft.com/office/drawing/2014/main" id="{0FB415E7-8491-13B2-0A7D-52BF25F1EA60}"/>
+                <ns2:creationId id="{0FB415E7-8491-13B2-0A7D-52BF25F1EA60}"/>
               </a:ext>
             </a:extLst>
           </p:cNvPr>
@@ -16990,7 +17679,7 @@
           <p:cNvPr id="10" name="Text Placeholder 9">
             <a:extLst>
               <a:ext uri="{FF2B5EF4-FFF2-40B4-BE49-F238E27FC236}">
-                <a16:creationId xmlns:a16="http://schemas.microsoft.com/office/drawing/2014/main" id="{F97A4842-2728-8D6A-D2DE-B6E2062C5B64}"/>
+                <ns2:creationId id="{F97A4842-2728-8D6A-D2DE-B6E2062C5B64}"/>
               </a:ext>
             </a:extLst>
           </p:cNvPr>
@@ -17071,7 +17760,7 @@
           <p:cNvPr id="11" name="Text Placeholder 9">
             <a:extLst>
               <a:ext uri="{FF2B5EF4-FFF2-40B4-BE49-F238E27FC236}">
-                <a16:creationId xmlns:a16="http://schemas.microsoft.com/office/drawing/2014/main" id="{6C0D5753-3F06-573C-2A52-4C7432C384AB}"/>
+                <ns2:creationId id="{6C0D5753-3F06-573C-2A52-4C7432C384AB}"/>
               </a:ext>
             </a:extLst>
           </p:cNvPr>
@@ -17150,7 +17839,7 @@
     </p:spTree>
     <p:extLst>
       <p:ext uri="{BB962C8B-B14F-4D97-AF65-F5344CB8AC3E}">
-        <p14:creationId xmlns:p14="http://schemas.microsoft.com/office/powerpoint/2010/main" val="3015644538"/>
+        <p14:creationId val="3015644538"/>
       </p:ext>
     </p:extLst>
   </p:cSld>
@@ -17161,7 +17850,7 @@
 </file>
 
 <file path=ppt/slideLayouts/slideLayout5.xml><?xml version="1.0" encoding="utf-8"?>
-<p:sldLayout xmlns:a="http://schemas.openxmlformats.org/drawingml/2006/main" xmlns:r="http://schemas.openxmlformats.org/officeDocument/2006/relationships" xmlns:p="http://schemas.openxmlformats.org/presentationml/2006/main" preserve="1" userDrawn="1">
+<p:sldLayout xmlns:a="http://schemas.openxmlformats.org/drawingml/2006/main" xmlns:ns2="http://schemas.microsoft.com/office/drawing/2014/main" xmlns:p="http://schemas.openxmlformats.org/presentationml/2006/main" xmlns:p14="http://schemas.microsoft.com/office/powerpoint/2010/main" xmlns:r="http://schemas.openxmlformats.org/officeDocument/2006/relationships" preserve="1" userDrawn="1">
   <p:cSld name="Graficos_unabarra">
     <p:spTree>
       <p:nvGrpSpPr>
@@ -17182,7 +17871,7 @@
           <p:cNvPr id="2" name="Title 1">
             <a:extLst>
               <a:ext uri="{FF2B5EF4-FFF2-40B4-BE49-F238E27FC236}">
-                <a16:creationId xmlns:a16="http://schemas.microsoft.com/office/drawing/2014/main" id="{E161B1F1-83C7-C3F7-BF29-A7102FCCB32B}"/>
+                <ns2:creationId id="{E161B1F1-83C7-C3F7-BF29-A7102FCCB32B}"/>
               </a:ext>
             </a:extLst>
           </p:cNvPr>
@@ -17204,10 +17893,20 @@
           <a:lstStyle/>
           <a:p>
             <a:r>
-              <a:rPr lang="en-US" dirty="0"/>
+              <a:rPr lang="en-US" dirty="0" sz="2400" b="1">
+                <a:latin typeface="Arial"/>
+                <a:solidFill>
+                  <a:srgbClr val="CA5651"/>
+                </a:solidFill>
+              </a:rPr>
               <a:t>Click to edit Master title style</a:t>
             </a:r>
-            <a:endParaRPr lang="en-PE" dirty="0"/>
+            <a:endParaRPr lang="en-PE" dirty="0" sz="2400" b="1">
+              <a:latin typeface="Arial"/>
+              <a:solidFill>
+                <a:srgbClr val="CA5651"/>
+              </a:solidFill>
+            </a:endParaRPr>
           </a:p>
         </p:txBody>
       </p:sp>
@@ -17216,7 +17915,7 @@
           <p:cNvPr id="6" name="Google Shape;66;p47">
             <a:extLst>
               <a:ext uri="{FF2B5EF4-FFF2-40B4-BE49-F238E27FC236}">
-                <a16:creationId xmlns:a16="http://schemas.microsoft.com/office/drawing/2014/main" id="{323E205B-F311-E78C-D6A8-0122851FE66D}"/>
+                <ns2:creationId id="{323E205B-F311-E78C-D6A8-0122851FE66D}"/>
               </a:ext>
             </a:extLst>
           </p:cNvPr>
@@ -17249,7 +17948,7 @@
           <p:cNvPr id="8" name="Picture Placeholder 7">
             <a:extLst>
               <a:ext uri="{FF2B5EF4-FFF2-40B4-BE49-F238E27FC236}">
-                <a16:creationId xmlns:a16="http://schemas.microsoft.com/office/drawing/2014/main" id="{0FB415E7-8491-13B2-0A7D-52BF25F1EA60}"/>
+                <ns2:creationId id="{0FB415E7-8491-13B2-0A7D-52BF25F1EA60}"/>
               </a:ext>
             </a:extLst>
           </p:cNvPr>
@@ -17279,7 +17978,7 @@
           <p:cNvPr id="10" name="Text Placeholder 9">
             <a:extLst>
               <a:ext uri="{FF2B5EF4-FFF2-40B4-BE49-F238E27FC236}">
-                <a16:creationId xmlns:a16="http://schemas.microsoft.com/office/drawing/2014/main" id="{F97A4842-2728-8D6A-D2DE-B6E2062C5B64}"/>
+                <ns2:creationId id="{F97A4842-2728-8D6A-D2DE-B6E2062C5B64}"/>
               </a:ext>
             </a:extLst>
           </p:cNvPr>
@@ -17360,7 +18059,7 @@
           <p:cNvPr id="11" name="Text Placeholder 9">
             <a:extLst>
               <a:ext uri="{FF2B5EF4-FFF2-40B4-BE49-F238E27FC236}">
-                <a16:creationId xmlns:a16="http://schemas.microsoft.com/office/drawing/2014/main" id="{6C0D5753-3F06-573C-2A52-4C7432C384AB}"/>
+                <ns2:creationId id="{6C0D5753-3F06-573C-2A52-4C7432C384AB}"/>
               </a:ext>
             </a:extLst>
           </p:cNvPr>
@@ -17439,7 +18138,7 @@
     </p:spTree>
     <p:extLst>
       <p:ext uri="{BB962C8B-B14F-4D97-AF65-F5344CB8AC3E}">
-        <p14:creationId xmlns:p14="http://schemas.microsoft.com/office/powerpoint/2010/main" val="311544014"/>
+        <p14:creationId val="311544014"/>
       </p:ext>
     </p:extLst>
   </p:cSld>
@@ -17450,7 +18149,7 @@
 </file>
 
 <file path=ppt/slideLayouts/slideLayout6.xml><?xml version="1.0" encoding="utf-8"?>
-<p:sldLayout xmlns:a="http://schemas.openxmlformats.org/drawingml/2006/main" xmlns:r="http://schemas.openxmlformats.org/officeDocument/2006/relationships" xmlns:p="http://schemas.openxmlformats.org/presentationml/2006/main" preserve="1" userDrawn="1">
+<p:sldLayout xmlns:a="http://schemas.openxmlformats.org/drawingml/2006/main" xmlns:ns2="http://schemas.microsoft.com/office/drawing/2014/main" xmlns:p="http://schemas.openxmlformats.org/presentationml/2006/main" xmlns:p14="http://schemas.microsoft.com/office/powerpoint/2010/main" xmlns:r="http://schemas.openxmlformats.org/officeDocument/2006/relationships" preserve="1" userDrawn="1">
   <p:cSld name="Graficos_2columnas">
     <p:spTree>
       <p:nvGrpSpPr>
@@ -17471,7 +18170,7 @@
           <p:cNvPr id="2" name="Title 1">
             <a:extLst>
               <a:ext uri="{FF2B5EF4-FFF2-40B4-BE49-F238E27FC236}">
-                <a16:creationId xmlns:a16="http://schemas.microsoft.com/office/drawing/2014/main" id="{E161B1F1-83C7-C3F7-BF29-A7102FCCB32B}"/>
+                <ns2:creationId id="{E161B1F1-83C7-C3F7-BF29-A7102FCCB32B}"/>
               </a:ext>
             </a:extLst>
           </p:cNvPr>
@@ -17493,10 +18192,20 @@
           <a:lstStyle/>
           <a:p>
             <a:r>
-              <a:rPr lang="en-US" dirty="0"/>
+              <a:rPr lang="en-US" dirty="0" sz="2400" b="1">
+                <a:latin typeface="Arial"/>
+                <a:solidFill>
+                  <a:srgbClr val="CA5651"/>
+                </a:solidFill>
+              </a:rPr>
               <a:t>Click to edit Master title style</a:t>
             </a:r>
-            <a:endParaRPr lang="en-PE" dirty="0"/>
+            <a:endParaRPr lang="en-PE" dirty="0" sz="2400" b="1">
+              <a:latin typeface="Arial"/>
+              <a:solidFill>
+                <a:srgbClr val="CA5651"/>
+              </a:solidFill>
+            </a:endParaRPr>
           </a:p>
         </p:txBody>
       </p:sp>
@@ -17505,7 +18214,7 @@
           <p:cNvPr id="6" name="Google Shape;66;p47">
             <a:extLst>
               <a:ext uri="{FF2B5EF4-FFF2-40B4-BE49-F238E27FC236}">
-                <a16:creationId xmlns:a16="http://schemas.microsoft.com/office/drawing/2014/main" id="{323E205B-F311-E78C-D6A8-0122851FE66D}"/>
+                <ns2:creationId id="{323E205B-F311-E78C-D6A8-0122851FE66D}"/>
               </a:ext>
             </a:extLst>
           </p:cNvPr>
@@ -17538,7 +18247,7 @@
           <p:cNvPr id="8" name="Picture Placeholder 7">
             <a:extLst>
               <a:ext uri="{FF2B5EF4-FFF2-40B4-BE49-F238E27FC236}">
-                <a16:creationId xmlns:a16="http://schemas.microsoft.com/office/drawing/2014/main" id="{0FB415E7-8491-13B2-0A7D-52BF25F1EA60}"/>
+                <ns2:creationId id="{0FB415E7-8491-13B2-0A7D-52BF25F1EA60}"/>
               </a:ext>
             </a:extLst>
           </p:cNvPr>
@@ -17568,7 +18277,7 @@
           <p:cNvPr id="10" name="Text Placeholder 9">
             <a:extLst>
               <a:ext uri="{FF2B5EF4-FFF2-40B4-BE49-F238E27FC236}">
-                <a16:creationId xmlns:a16="http://schemas.microsoft.com/office/drawing/2014/main" id="{F97A4842-2728-8D6A-D2DE-B6E2062C5B64}"/>
+                <ns2:creationId id="{F97A4842-2728-8D6A-D2DE-B6E2062C5B64}"/>
               </a:ext>
             </a:extLst>
           </p:cNvPr>
@@ -17649,7 +18358,7 @@
           <p:cNvPr id="11" name="Text Placeholder 9">
             <a:extLst>
               <a:ext uri="{FF2B5EF4-FFF2-40B4-BE49-F238E27FC236}">
-                <a16:creationId xmlns:a16="http://schemas.microsoft.com/office/drawing/2014/main" id="{6C0D5753-3F06-573C-2A52-4C7432C384AB}"/>
+                <ns2:creationId id="{6C0D5753-3F06-573C-2A52-4C7432C384AB}"/>
               </a:ext>
             </a:extLst>
           </p:cNvPr>
@@ -17730,7 +18439,7 @@
           <p:cNvPr id="3" name="Picture Placeholder 7">
             <a:extLst>
               <a:ext uri="{FF2B5EF4-FFF2-40B4-BE49-F238E27FC236}">
-                <a16:creationId xmlns:a16="http://schemas.microsoft.com/office/drawing/2014/main" id="{20E02211-8E49-B661-C872-8E183915B04C}"/>
+                <ns2:creationId id="{20E02211-8E49-B661-C872-8E183915B04C}"/>
               </a:ext>
             </a:extLst>
           </p:cNvPr>
@@ -17758,7 +18467,7 @@
     </p:spTree>
     <p:extLst>
       <p:ext uri="{BB962C8B-B14F-4D97-AF65-F5344CB8AC3E}">
-        <p14:creationId xmlns:p14="http://schemas.microsoft.com/office/powerpoint/2010/main" val="54144204"/>
+        <p14:creationId val="54144204"/>
       </p:ext>
     </p:extLst>
   </p:cSld>
@@ -17769,7 +18478,7 @@
 </file>
 
 <file path=ppt/slideLayouts/slideLayout7.xml><?xml version="1.0" encoding="utf-8"?>
-<p:sldLayout xmlns:a="http://schemas.openxmlformats.org/drawingml/2006/main" xmlns:r="http://schemas.openxmlformats.org/officeDocument/2006/relationships" xmlns:p="http://schemas.openxmlformats.org/presentationml/2006/main" preserve="1" userDrawn="1">
+<p:sldLayout xmlns:a="http://schemas.openxmlformats.org/drawingml/2006/main" xmlns:ns2="http://schemas.microsoft.com/office/drawing/2014/main" xmlns:p="http://schemas.openxmlformats.org/presentationml/2006/main" xmlns:p14="http://schemas.microsoft.com/office/powerpoint/2010/main" xmlns:r="http://schemas.openxmlformats.org/officeDocument/2006/relationships" preserve="1" userDrawn="1">
   <p:cSld name="4_paneles">
     <p:spTree>
       <p:nvGrpSpPr>
@@ -17790,7 +18499,7 @@
           <p:cNvPr id="2" name="Title 1">
             <a:extLst>
               <a:ext uri="{FF2B5EF4-FFF2-40B4-BE49-F238E27FC236}">
-                <a16:creationId xmlns:a16="http://schemas.microsoft.com/office/drawing/2014/main" id="{E161B1F1-83C7-C3F7-BF29-A7102FCCB32B}"/>
+                <ns2:creationId id="{E161B1F1-83C7-C3F7-BF29-A7102FCCB32B}"/>
               </a:ext>
             </a:extLst>
           </p:cNvPr>
@@ -17812,10 +18521,20 @@
           <a:lstStyle/>
           <a:p>
             <a:r>
-              <a:rPr lang="en-US" dirty="0"/>
+              <a:rPr lang="en-US" dirty="0" sz="2400" b="1">
+                <a:latin typeface="Arial"/>
+                <a:solidFill>
+                  <a:srgbClr val="CA5651"/>
+                </a:solidFill>
+              </a:rPr>
               <a:t>Click to edit Master title style</a:t>
             </a:r>
-            <a:endParaRPr lang="en-PE" dirty="0"/>
+            <a:endParaRPr lang="en-PE" dirty="0" sz="2400" b="1">
+              <a:latin typeface="Arial"/>
+              <a:solidFill>
+                <a:srgbClr val="CA5651"/>
+              </a:solidFill>
+            </a:endParaRPr>
           </a:p>
         </p:txBody>
       </p:sp>
@@ -17824,7 +18543,7 @@
           <p:cNvPr id="6" name="Google Shape;66;p47">
             <a:extLst>
               <a:ext uri="{FF2B5EF4-FFF2-40B4-BE49-F238E27FC236}">
-                <a16:creationId xmlns:a16="http://schemas.microsoft.com/office/drawing/2014/main" id="{323E205B-F311-E78C-D6A8-0122851FE66D}"/>
+                <ns2:creationId id="{323E205B-F311-E78C-D6A8-0122851FE66D}"/>
               </a:ext>
             </a:extLst>
           </p:cNvPr>
@@ -17857,7 +18576,7 @@
           <p:cNvPr id="8" name="Picture Placeholder 7">
             <a:extLst>
               <a:ext uri="{FF2B5EF4-FFF2-40B4-BE49-F238E27FC236}">
-                <a16:creationId xmlns:a16="http://schemas.microsoft.com/office/drawing/2014/main" id="{0FB415E7-8491-13B2-0A7D-52BF25F1EA60}"/>
+                <ns2:creationId id="{0FB415E7-8491-13B2-0A7D-52BF25F1EA60}"/>
               </a:ext>
             </a:extLst>
           </p:cNvPr>
@@ -17887,7 +18606,7 @@
           <p:cNvPr id="10" name="Text Placeholder 9">
             <a:extLst>
               <a:ext uri="{FF2B5EF4-FFF2-40B4-BE49-F238E27FC236}">
-                <a16:creationId xmlns:a16="http://schemas.microsoft.com/office/drawing/2014/main" id="{F97A4842-2728-8D6A-D2DE-B6E2062C5B64}"/>
+                <ns2:creationId id="{F97A4842-2728-8D6A-D2DE-B6E2062C5B64}"/>
               </a:ext>
             </a:extLst>
           </p:cNvPr>
@@ -17968,7 +18687,7 @@
           <p:cNvPr id="11" name="Text Placeholder 9">
             <a:extLst>
               <a:ext uri="{FF2B5EF4-FFF2-40B4-BE49-F238E27FC236}">
-                <a16:creationId xmlns:a16="http://schemas.microsoft.com/office/drawing/2014/main" id="{6C0D5753-3F06-573C-2A52-4C7432C384AB}"/>
+                <ns2:creationId id="{6C0D5753-3F06-573C-2A52-4C7432C384AB}"/>
               </a:ext>
             </a:extLst>
           </p:cNvPr>
@@ -18049,7 +18768,7 @@
           <p:cNvPr id="3" name="Picture Placeholder 7">
             <a:extLst>
               <a:ext uri="{FF2B5EF4-FFF2-40B4-BE49-F238E27FC236}">
-                <a16:creationId xmlns:a16="http://schemas.microsoft.com/office/drawing/2014/main" id="{20E02211-8E49-B661-C872-8E183915B04C}"/>
+                <ns2:creationId id="{20E02211-8E49-B661-C872-8E183915B04C}"/>
               </a:ext>
             </a:extLst>
           </p:cNvPr>
@@ -18079,7 +18798,7 @@
           <p:cNvPr id="4" name="Picture Placeholder 7">
             <a:extLst>
               <a:ext uri="{FF2B5EF4-FFF2-40B4-BE49-F238E27FC236}">
-                <a16:creationId xmlns:a16="http://schemas.microsoft.com/office/drawing/2014/main" id="{0E7618E8-58EE-9156-FDF0-B54A424681FA}"/>
+                <ns2:creationId id="{0E7618E8-58EE-9156-FDF0-B54A424681FA}"/>
               </a:ext>
             </a:extLst>
           </p:cNvPr>
@@ -18109,7 +18828,7 @@
           <p:cNvPr id="5" name="Picture Placeholder 7">
             <a:extLst>
               <a:ext uri="{FF2B5EF4-FFF2-40B4-BE49-F238E27FC236}">
-                <a16:creationId xmlns:a16="http://schemas.microsoft.com/office/drawing/2014/main" id="{38CBF1DD-784B-51FC-9DCA-E12D257356C6}"/>
+                <ns2:creationId id="{38CBF1DD-784B-51FC-9DCA-E12D257356C6}"/>
               </a:ext>
             </a:extLst>
           </p:cNvPr>
@@ -18137,7 +18856,7 @@
     </p:spTree>
     <p:extLst>
       <p:ext uri="{BB962C8B-B14F-4D97-AF65-F5344CB8AC3E}">
-        <p14:creationId xmlns:p14="http://schemas.microsoft.com/office/powerpoint/2010/main" val="2230652750"/>
+        <p14:creationId val="2230652750"/>
       </p:ext>
     </p:extLst>
   </p:cSld>
@@ -18148,7 +18867,7 @@
 </file>
 
 <file path=ppt/slideLayouts/slideLayout8.xml><?xml version="1.0" encoding="utf-8"?>
-<p:sldLayout xmlns:a="http://schemas.openxmlformats.org/drawingml/2006/main" xmlns:r="http://schemas.openxmlformats.org/officeDocument/2006/relationships" xmlns:p="http://schemas.openxmlformats.org/presentationml/2006/main" preserve="1" userDrawn="1">
+<p:sldLayout xmlns:a="http://schemas.openxmlformats.org/drawingml/2006/main" xmlns:ns2="http://schemas.microsoft.com/office/drawing/2014/main" xmlns:p="http://schemas.openxmlformats.org/presentationml/2006/main" xmlns:p14="http://schemas.microsoft.com/office/powerpoint/2010/main" xmlns:r="http://schemas.openxmlformats.org/officeDocument/2006/relationships" preserve="1" userDrawn="1">
   <p:cSld name="1_Graficos_2columnas_narrativo">
     <p:spTree>
       <p:nvGrpSpPr>
@@ -18169,7 +18888,7 @@
           <p:cNvPr id="2" name="Title 1">
             <a:extLst>
               <a:ext uri="{FF2B5EF4-FFF2-40B4-BE49-F238E27FC236}">
-                <a16:creationId xmlns:a16="http://schemas.microsoft.com/office/drawing/2014/main" id="{E161B1F1-83C7-C3F7-BF29-A7102FCCB32B}"/>
+                <ns2:creationId id="{E161B1F1-83C7-C3F7-BF29-A7102FCCB32B}"/>
               </a:ext>
             </a:extLst>
           </p:cNvPr>
@@ -18191,10 +18910,20 @@
           <a:lstStyle/>
           <a:p>
             <a:r>
-              <a:rPr lang="en-US" dirty="0"/>
+              <a:rPr lang="en-US" dirty="0" sz="2400" b="1">
+                <a:latin typeface="Arial"/>
+                <a:solidFill>
+                  <a:srgbClr val="CA5651"/>
+                </a:solidFill>
+              </a:rPr>
               <a:t>Click to edit Master title style</a:t>
             </a:r>
-            <a:endParaRPr lang="en-PE" dirty="0"/>
+            <a:endParaRPr lang="en-PE" dirty="0" sz="2400" b="1">
+              <a:latin typeface="Arial"/>
+              <a:solidFill>
+                <a:srgbClr val="CA5651"/>
+              </a:solidFill>
+            </a:endParaRPr>
           </a:p>
         </p:txBody>
       </p:sp>
@@ -18203,7 +18932,7 @@
           <p:cNvPr id="6" name="Google Shape;66;p47">
             <a:extLst>
               <a:ext uri="{FF2B5EF4-FFF2-40B4-BE49-F238E27FC236}">
-                <a16:creationId xmlns:a16="http://schemas.microsoft.com/office/drawing/2014/main" id="{323E205B-F311-E78C-D6A8-0122851FE66D}"/>
+                <ns2:creationId id="{323E205B-F311-E78C-D6A8-0122851FE66D}"/>
               </a:ext>
             </a:extLst>
           </p:cNvPr>
@@ -18236,7 +18965,7 @@
           <p:cNvPr id="8" name="Picture Placeholder 7">
             <a:extLst>
               <a:ext uri="{FF2B5EF4-FFF2-40B4-BE49-F238E27FC236}">
-                <a16:creationId xmlns:a16="http://schemas.microsoft.com/office/drawing/2014/main" id="{0FB415E7-8491-13B2-0A7D-52BF25F1EA60}"/>
+                <ns2:creationId id="{0FB415E7-8491-13B2-0A7D-52BF25F1EA60}"/>
               </a:ext>
             </a:extLst>
           </p:cNvPr>
@@ -18266,7 +18995,7 @@
           <p:cNvPr id="10" name="Text Placeholder 9">
             <a:extLst>
               <a:ext uri="{FF2B5EF4-FFF2-40B4-BE49-F238E27FC236}">
-                <a16:creationId xmlns:a16="http://schemas.microsoft.com/office/drawing/2014/main" id="{F97A4842-2728-8D6A-D2DE-B6E2062C5B64}"/>
+                <ns2:creationId id="{F97A4842-2728-8D6A-D2DE-B6E2062C5B64}"/>
               </a:ext>
             </a:extLst>
           </p:cNvPr>
@@ -18347,7 +19076,7 @@
           <p:cNvPr id="11" name="Text Placeholder 9">
             <a:extLst>
               <a:ext uri="{FF2B5EF4-FFF2-40B4-BE49-F238E27FC236}">
-                <a16:creationId xmlns:a16="http://schemas.microsoft.com/office/drawing/2014/main" id="{6C0D5753-3F06-573C-2A52-4C7432C384AB}"/>
+                <ns2:creationId id="{6C0D5753-3F06-573C-2A52-4C7432C384AB}"/>
               </a:ext>
             </a:extLst>
           </p:cNvPr>
@@ -18428,7 +19157,7 @@
           <p:cNvPr id="3" name="Picture Placeholder 7">
             <a:extLst>
               <a:ext uri="{FF2B5EF4-FFF2-40B4-BE49-F238E27FC236}">
-                <a16:creationId xmlns:a16="http://schemas.microsoft.com/office/drawing/2014/main" id="{20E02211-8E49-B661-C872-8E183915B04C}"/>
+                <ns2:creationId id="{20E02211-8E49-B661-C872-8E183915B04C}"/>
               </a:ext>
             </a:extLst>
           </p:cNvPr>
@@ -18458,7 +19187,7 @@
           <p:cNvPr id="4" name="Text Placeholder 9">
             <a:extLst>
               <a:ext uri="{FF2B5EF4-FFF2-40B4-BE49-F238E27FC236}">
-                <a16:creationId xmlns:a16="http://schemas.microsoft.com/office/drawing/2014/main" id="{61A9EDCB-A616-0C04-CD06-97F151584548}"/>
+                <ns2:creationId id="{61A9EDCB-A616-0C04-CD06-97F151584548}"/>
               </a:ext>
             </a:extLst>
           </p:cNvPr>
@@ -18537,7 +19266,7 @@
     </p:spTree>
     <p:extLst>
       <p:ext uri="{BB962C8B-B14F-4D97-AF65-F5344CB8AC3E}">
-        <p14:creationId xmlns:p14="http://schemas.microsoft.com/office/powerpoint/2010/main" val="361089075"/>
+        <p14:creationId val="361089075"/>
       </p:ext>
     </p:extLst>
   </p:cSld>
@@ -18548,7 +19277,7 @@
 </file>
 
 <file path=ppt/slideLayouts/slideLayout9.xml><?xml version="1.0" encoding="utf-8"?>
-<p:sldLayout xmlns:a="http://schemas.openxmlformats.org/drawingml/2006/main" xmlns:r="http://schemas.openxmlformats.org/officeDocument/2006/relationships" xmlns:p="http://schemas.openxmlformats.org/presentationml/2006/main" preserve="1" userDrawn="1">
+<p:sldLayout xmlns:a="http://schemas.openxmlformats.org/drawingml/2006/main" xmlns:ns2="http://schemas.microsoft.com/office/drawing/2014/main" xmlns:p="http://schemas.openxmlformats.org/presentationml/2006/main" xmlns:p14="http://schemas.microsoft.com/office/powerpoint/2010/main" xmlns:r="http://schemas.openxmlformats.org/officeDocument/2006/relationships" preserve="1" userDrawn="1">
   <p:cSld name="1_Grafico_narrativo">
     <p:spTree>
       <p:nvGrpSpPr>
@@ -18569,7 +19298,7 @@
           <p:cNvPr id="2" name="Title 1">
             <a:extLst>
               <a:ext uri="{FF2B5EF4-FFF2-40B4-BE49-F238E27FC236}">
-                <a16:creationId xmlns:a16="http://schemas.microsoft.com/office/drawing/2014/main" id="{E161B1F1-83C7-C3F7-BF29-A7102FCCB32B}"/>
+                <ns2:creationId id="{E161B1F1-83C7-C3F7-BF29-A7102FCCB32B}"/>
               </a:ext>
             </a:extLst>
           </p:cNvPr>
@@ -18591,10 +19320,20 @@
           <a:lstStyle/>
           <a:p>
             <a:r>
-              <a:rPr lang="en-US" dirty="0"/>
+              <a:rPr lang="en-US" dirty="0" sz="2400" b="1">
+                <a:latin typeface="Arial"/>
+                <a:solidFill>
+                  <a:srgbClr val="CA5651"/>
+                </a:solidFill>
+              </a:rPr>
               <a:t>Click to edit Master title style</a:t>
             </a:r>
-            <a:endParaRPr lang="en-PE" dirty="0"/>
+            <a:endParaRPr lang="en-PE" dirty="0" sz="2400" b="1">
+              <a:latin typeface="Arial"/>
+              <a:solidFill>
+                <a:srgbClr val="CA5651"/>
+              </a:solidFill>
+            </a:endParaRPr>
           </a:p>
         </p:txBody>
       </p:sp>
@@ -18603,7 +19342,7 @@
           <p:cNvPr id="6" name="Google Shape;66;p47">
             <a:extLst>
               <a:ext uri="{FF2B5EF4-FFF2-40B4-BE49-F238E27FC236}">
-                <a16:creationId xmlns:a16="http://schemas.microsoft.com/office/drawing/2014/main" id="{323E205B-F311-E78C-D6A8-0122851FE66D}"/>
+                <ns2:creationId id="{323E205B-F311-E78C-D6A8-0122851FE66D}"/>
               </a:ext>
             </a:extLst>
           </p:cNvPr>
@@ -18636,7 +19375,7 @@
           <p:cNvPr id="8" name="Picture Placeholder 7">
             <a:extLst>
               <a:ext uri="{FF2B5EF4-FFF2-40B4-BE49-F238E27FC236}">
-                <a16:creationId xmlns:a16="http://schemas.microsoft.com/office/drawing/2014/main" id="{0FB415E7-8491-13B2-0A7D-52BF25F1EA60}"/>
+                <ns2:creationId id="{0FB415E7-8491-13B2-0A7D-52BF25F1EA60}"/>
               </a:ext>
             </a:extLst>
           </p:cNvPr>
@@ -18666,7 +19405,7 @@
           <p:cNvPr id="10" name="Text Placeholder 9">
             <a:extLst>
               <a:ext uri="{FF2B5EF4-FFF2-40B4-BE49-F238E27FC236}">
-                <a16:creationId xmlns:a16="http://schemas.microsoft.com/office/drawing/2014/main" id="{F97A4842-2728-8D6A-D2DE-B6E2062C5B64}"/>
+                <ns2:creationId id="{F97A4842-2728-8D6A-D2DE-B6E2062C5B64}"/>
               </a:ext>
             </a:extLst>
           </p:cNvPr>
@@ -18747,7 +19486,7 @@
           <p:cNvPr id="11" name="Text Placeholder 9">
             <a:extLst>
               <a:ext uri="{FF2B5EF4-FFF2-40B4-BE49-F238E27FC236}">
-                <a16:creationId xmlns:a16="http://schemas.microsoft.com/office/drawing/2014/main" id="{6C0D5753-3F06-573C-2A52-4C7432C384AB}"/>
+                <ns2:creationId id="{6C0D5753-3F06-573C-2A52-4C7432C384AB}"/>
               </a:ext>
             </a:extLst>
           </p:cNvPr>
@@ -18828,7 +19567,7 @@
           <p:cNvPr id="4" name="Text Placeholder 9">
             <a:extLst>
               <a:ext uri="{FF2B5EF4-FFF2-40B4-BE49-F238E27FC236}">
-                <a16:creationId xmlns:a16="http://schemas.microsoft.com/office/drawing/2014/main" id="{61A9EDCB-A616-0C04-CD06-97F151584548}"/>
+                <ns2:creationId id="{61A9EDCB-A616-0C04-CD06-97F151584548}"/>
               </a:ext>
             </a:extLst>
           </p:cNvPr>
@@ -18907,7 +19646,7 @@
     </p:spTree>
     <p:extLst>
       <p:ext uri="{BB962C8B-B14F-4D97-AF65-F5344CB8AC3E}">
-        <p14:creationId xmlns:p14="http://schemas.microsoft.com/office/powerpoint/2010/main" val="184226006"/>
+        <p14:creationId val="184226006"/>
       </p:ext>
     </p:extLst>
   </p:cSld>
@@ -18918,7 +19657,7 @@
 </file>
 
 <file path=ppt/slideMasters/slideMaster1.xml><?xml version="1.0" encoding="utf-8"?>
-<p:sldMaster xmlns:a="http://schemas.openxmlformats.org/drawingml/2006/main" xmlns:r="http://schemas.openxmlformats.org/officeDocument/2006/relationships" xmlns:p="http://schemas.openxmlformats.org/presentationml/2006/main">
+<p:sldMaster xmlns:a="http://schemas.openxmlformats.org/drawingml/2006/main" xmlns:p="http://schemas.openxmlformats.org/presentationml/2006/main" xmlns:p14="http://schemas.microsoft.com/office/powerpoint/2010/main" xmlns:p15="http://schemas.microsoft.com/office/powerpoint/2012/main" xmlns:r="http://schemas.openxmlformats.org/officeDocument/2006/relationships">
   <p:cSld>
     <p:bg>
       <p:bgPr>
@@ -18976,7 +19715,7 @@
                 <a:spcPct val="90000"/>
               </a:lnSpc>
               <a:buClr>
-                <a:srgbClr val="DA4C4C"/>
+                <a:srgbClr val="CA5651"/>
               </a:buClr>
               <a:buSzPts val="2400"/>
               <a:buNone/>
@@ -19847,7 +20586,7 @@
     </p:spTree>
     <p:extLst>
       <p:ext uri="{BB962C8B-B14F-4D97-AF65-F5344CB8AC3E}">
-        <p14:creationId xmlns:p14="http://schemas.microsoft.com/office/powerpoint/2010/main" val="2406847821"/>
+        <p14:creationId val="2406847821"/>
       </p:ext>
     </p:extLst>
   </p:cSld>
@@ -19907,7 +20646,7 @@
         <a:buFont typeface="Arial"/>
         <a:defRPr sz="2400" b="1" i="0" u="none" strike="noStrike" cap="none">
           <a:solidFill>
-            <a:srgbClr val="DA4C4C"/>
+            <a:srgbClr val="CA5651"/>
           </a:solidFill>
           <a:latin typeface="Arial"/>
           <a:ea typeface="Arial"/>
@@ -20134,9 +20873,9 @@
           <a:srgbClr val="000000"/>
         </a:buClr>
         <a:buFont typeface="Arial"/>
-        <a:defRPr sz="1800" b="1" i="0" u="none" strike="noStrike" cap="none">
+        <a:defRPr sz="1400" b="0" i="0" u="none" strike="noStrike" cap="none">
           <a:solidFill>
-            <a:srgbClr val="002060"/>
+            <a:srgbClr val="081F5C"/>
           </a:solidFill>
           <a:latin typeface="Arial"/>
           <a:ea typeface="Arial"/>
@@ -20158,9 +20897,9 @@
           <a:srgbClr val="000000"/>
         </a:buClr>
         <a:buFont typeface="Arial"/>
-        <a:defRPr sz="1400" b="0" i="0" u="none" strike="noStrike" cap="none">
+        <a:defRPr sz="1200" b="0" i="0" u="none" strike="noStrike" cap="none">
           <a:solidFill>
-            <a:srgbClr val="000000"/>
+            <a:srgbClr val="081F5C"/>
           </a:solidFill>
           <a:latin typeface="Arial"/>
           <a:ea typeface="Arial"/>
@@ -20182,9 +20921,9 @@
           <a:srgbClr val="000000"/>
         </a:buClr>
         <a:buFont typeface="Arial"/>
-        <a:defRPr sz="1400" b="0" i="0" u="none" strike="noStrike" cap="none">
+        <a:defRPr sz="1200" b="0" i="0" u="none" strike="noStrike" cap="none">
           <a:solidFill>
-            <a:srgbClr val="000000"/>
+            <a:srgbClr val="081F5C"/>
           </a:solidFill>
           <a:latin typeface="Arial"/>
           <a:ea typeface="Arial"/>
@@ -20206,9 +20945,9 @@
           <a:srgbClr val="000000"/>
         </a:buClr>
         <a:buFont typeface="Arial"/>
-        <a:defRPr sz="1400" b="0" i="0" u="none" strike="noStrike" cap="none">
+        <a:defRPr sz="1200" b="0" i="0" u="none" strike="noStrike" cap="none">
           <a:solidFill>
-            <a:srgbClr val="000000"/>
+            <a:srgbClr val="081F5C"/>
           </a:solidFill>
           <a:latin typeface="Arial"/>
           <a:ea typeface="Arial"/>
@@ -20230,9 +20969,9 @@
           <a:srgbClr val="000000"/>
         </a:buClr>
         <a:buFont typeface="Arial"/>
-        <a:defRPr sz="1400" b="0" i="0" u="none" strike="noStrike" cap="none">
+        <a:defRPr sz="1200" b="0" i="0" u="none" strike="noStrike" cap="none">
           <a:solidFill>
-            <a:srgbClr val="000000"/>
+            <a:srgbClr val="081F5C"/>
           </a:solidFill>
           <a:latin typeface="Arial"/>
           <a:ea typeface="Arial"/>
@@ -20254,9 +20993,9 @@
           <a:srgbClr val="000000"/>
         </a:buClr>
         <a:buFont typeface="Arial"/>
-        <a:defRPr sz="1400" b="0" i="0" u="none" strike="noStrike" cap="none">
+        <a:defRPr sz="1200" b="0" i="0" u="none" strike="noStrike" cap="none">
           <a:solidFill>
-            <a:srgbClr val="000000"/>
+            <a:srgbClr val="081F5C"/>
           </a:solidFill>
           <a:latin typeface="Arial"/>
           <a:ea typeface="Arial"/>
@@ -20278,9 +21017,9 @@
           <a:srgbClr val="000000"/>
         </a:buClr>
         <a:buFont typeface="Arial"/>
-        <a:defRPr sz="1400" b="0" i="0" u="none" strike="noStrike" cap="none">
+        <a:defRPr sz="1200" b="0" i="0" u="none" strike="noStrike" cap="none">
           <a:solidFill>
-            <a:srgbClr val="000000"/>
+            <a:srgbClr val="081F5C"/>
           </a:solidFill>
           <a:latin typeface="Arial"/>
           <a:ea typeface="Arial"/>
@@ -20302,9 +21041,9 @@
           <a:srgbClr val="000000"/>
         </a:buClr>
         <a:buFont typeface="Arial"/>
-        <a:defRPr sz="1400" b="0" i="0" u="none" strike="noStrike" cap="none">
+        <a:defRPr sz="1200" b="0" i="0" u="none" strike="noStrike" cap="none">
           <a:solidFill>
-            <a:srgbClr val="000000"/>
+            <a:srgbClr val="081F5C"/>
           </a:solidFill>
           <a:latin typeface="Arial"/>
           <a:ea typeface="Arial"/>
@@ -20326,9 +21065,9 @@
           <a:srgbClr val="000000"/>
         </a:buClr>
         <a:buFont typeface="Arial"/>
-        <a:defRPr sz="1400" b="0" i="0" u="none" strike="noStrike" cap="none">
+        <a:defRPr sz="1200" b="0" i="0" u="none" strike="noStrike" cap="none">
           <a:solidFill>
-            <a:srgbClr val="000000"/>
+            <a:srgbClr val="081F5C"/>
           </a:solidFill>
           <a:latin typeface="Arial"/>
           <a:ea typeface="Arial"/>
@@ -20363,9 +21102,9 @@
           <a:srgbClr val="000000"/>
         </a:buClr>
         <a:buFont typeface="Arial"/>
-        <a:defRPr sz="1400" b="0" i="0" u="none" strike="noStrike" cap="none">
+        <a:defRPr sz="1100" b="0" i="0" u="none" strike="noStrike" cap="none">
           <a:solidFill>
-            <a:srgbClr val="000000"/>
+            <a:srgbClr val="081F5C"/>
           </a:solidFill>
           <a:latin typeface="Arial"/>
           <a:ea typeface="Arial"/>
@@ -20387,9 +21126,9 @@
           <a:srgbClr val="000000"/>
         </a:buClr>
         <a:buFont typeface="Arial"/>
-        <a:defRPr sz="1400" b="0" i="0" u="none" strike="noStrike" cap="none">
+        <a:defRPr sz="1100" b="0" i="0" u="none" strike="noStrike" cap="none">
           <a:solidFill>
-            <a:srgbClr val="000000"/>
+            <a:srgbClr val="081F5C"/>
           </a:solidFill>
           <a:latin typeface="Arial"/>
           <a:ea typeface="Arial"/>
@@ -20411,9 +21150,9 @@
           <a:srgbClr val="000000"/>
         </a:buClr>
         <a:buFont typeface="Arial"/>
-        <a:defRPr sz="1400" b="0" i="0" u="none" strike="noStrike" cap="none">
+        <a:defRPr sz="1100" b="0" i="0" u="none" strike="noStrike" cap="none">
           <a:solidFill>
-            <a:srgbClr val="000000"/>
+            <a:srgbClr val="081F5C"/>
           </a:solidFill>
           <a:latin typeface="Arial"/>
           <a:ea typeface="Arial"/>
@@ -20435,9 +21174,9 @@
           <a:srgbClr val="000000"/>
         </a:buClr>
         <a:buFont typeface="Arial"/>
-        <a:defRPr sz="1400" b="0" i="0" u="none" strike="noStrike" cap="none">
+        <a:defRPr sz="1100" b="0" i="0" u="none" strike="noStrike" cap="none">
           <a:solidFill>
-            <a:srgbClr val="000000"/>
+            <a:srgbClr val="081F5C"/>
           </a:solidFill>
           <a:latin typeface="Arial"/>
           <a:ea typeface="Arial"/>
@@ -20459,9 +21198,9 @@
           <a:srgbClr val="000000"/>
         </a:buClr>
         <a:buFont typeface="Arial"/>
-        <a:defRPr sz="1400" b="0" i="0" u="none" strike="noStrike" cap="none">
+        <a:defRPr sz="1100" b="0" i="0" u="none" strike="noStrike" cap="none">
           <a:solidFill>
-            <a:srgbClr val="000000"/>
+            <a:srgbClr val="081F5C"/>
           </a:solidFill>
           <a:latin typeface="Arial"/>
           <a:ea typeface="Arial"/>
@@ -20483,9 +21222,9 @@
           <a:srgbClr val="000000"/>
         </a:buClr>
         <a:buFont typeface="Arial"/>
-        <a:defRPr sz="1400" b="0" i="0" u="none" strike="noStrike" cap="none">
+        <a:defRPr sz="1100" b="0" i="0" u="none" strike="noStrike" cap="none">
           <a:solidFill>
-            <a:srgbClr val="000000"/>
+            <a:srgbClr val="081F5C"/>
           </a:solidFill>
           <a:latin typeface="Arial"/>
           <a:ea typeface="Arial"/>
@@ -20507,9 +21246,9 @@
           <a:srgbClr val="000000"/>
         </a:buClr>
         <a:buFont typeface="Arial"/>
-        <a:defRPr sz="1400" b="0" i="0" u="none" strike="noStrike" cap="none">
+        <a:defRPr sz="1100" b="0" i="0" u="none" strike="noStrike" cap="none">
           <a:solidFill>
-            <a:srgbClr val="000000"/>
+            <a:srgbClr val="081F5C"/>
           </a:solidFill>
           <a:latin typeface="Arial"/>
           <a:ea typeface="Arial"/>
@@ -20531,9 +21270,9 @@
           <a:srgbClr val="000000"/>
         </a:buClr>
         <a:buFont typeface="Arial"/>
-        <a:defRPr sz="1400" b="0" i="0" u="none" strike="noStrike" cap="none">
+        <a:defRPr sz="1100" b="0" i="0" u="none" strike="noStrike" cap="none">
           <a:solidFill>
-            <a:srgbClr val="000000"/>
+            <a:srgbClr val="081F5C"/>
           </a:solidFill>
           <a:latin typeface="Arial"/>
           <a:ea typeface="Arial"/>
@@ -20555,9 +21294,9 @@
           <a:srgbClr val="000000"/>
         </a:buClr>
         <a:buFont typeface="Arial"/>
-        <a:defRPr sz="1400" b="0" i="0" u="none" strike="noStrike" cap="none">
+        <a:defRPr sz="1100" b="0" i="0" u="none" strike="noStrike" cap="none">
           <a:solidFill>
-            <a:srgbClr val="000000"/>
+            <a:srgbClr val="081F5C"/>
           </a:solidFill>
           <a:latin typeface="Arial"/>
           <a:ea typeface="Arial"/>
@@ -20569,7 +21308,7 @@
   </p:txStyles>
   <p:extLst>
     <p:ext uri="{27BBF7A9-308A-43DC-89C8-2F10F3537804}">
-      <p15:sldGuideLst xmlns:p15="http://schemas.microsoft.com/office/powerpoint/2012/main">
+      <p15:sldGuideLst>
         <p15:guide id="1" orient="horz" pos="2160" userDrawn="1">
           <p15:clr>
             <a:srgbClr val="F26B43"/>
@@ -20587,44 +21326,44 @@
 </file>
 
 <file path=ppt/theme/theme1.xml><?xml version="1.0" encoding="utf-8"?>
-<a:theme xmlns:a="http://schemas.openxmlformats.org/drawingml/2006/main" name="Office Theme">
+<a:theme xmlns:a="http://schemas.openxmlformats.org/drawingml/2006/main" xmlns:ns1="http://schemas.microsoft.com/office/thememl/2012/main" name="Office Theme">
   <a:themeElements>
     <a:clrScheme name="Office">
       <a:dk1>
-        <a:srgbClr val="000000"/>
+        <a:srgbClr val="081F5C"/>
       </a:dk1>
       <a:lt1>
         <a:srgbClr val="FFFFFF"/>
       </a:lt1>
       <a:dk2>
-        <a:srgbClr val="44546A"/>
+        <a:srgbClr val="081F5C"/>
       </a:dk2>
       <a:lt2>
-        <a:srgbClr val="E7E6E6"/>
+        <a:srgbClr val="F2F2F2"/>
       </a:lt2>
       <a:accent1>
-        <a:srgbClr val="5B9BD5"/>
+        <a:srgbClr val="081F5C"/>
       </a:accent1>
       <a:accent2>
-        <a:srgbClr val="ED7D31"/>
+        <a:srgbClr val="CA5651"/>
       </a:accent2>
       <a:accent3>
-        <a:srgbClr val="A5A5A5"/>
+        <a:srgbClr val="85BB85"/>
       </a:accent3>
       <a:accent4>
-        <a:srgbClr val="FFC000"/>
+        <a:srgbClr val="EFD25E"/>
       </a:accent4>
       <a:accent5>
-        <a:srgbClr val="4472C4"/>
+        <a:srgbClr val="BFBFBF"/>
       </a:accent5>
       <a:accent6>
-        <a:srgbClr val="70AD47"/>
+        <a:srgbClr val="E4A34C"/>
       </a:accent6>
       <a:hlink>
-        <a:srgbClr val="0563C1"/>
+        <a:srgbClr val="7594CC"/>
       </a:hlink>
       <a:folHlink>
-        <a:srgbClr val="954F72"/>
+        <a:srgbClr val="9688D3"/>
       </a:folHlink>
     </a:clrScheme>
     <a:fontScheme name="Office">
@@ -20874,7 +21613,7 @@
         <a:defPPr algn="l">
           <a:defRPr sz="1800" b="1" i="0" u="none" strike="noStrike" dirty="0" smtClean="0">
             <a:solidFill>
-              <a:srgbClr val="002060"/>
+              <a:srgbClr val="081F5C"/>
             </a:solidFill>
             <a:effectLst/>
             <a:latin typeface="Arial" panose="020B0604020202020204" pitchFamily="34" charset="0"/>
@@ -20887,7 +21626,7 @@
   <a:extraClrSchemeLst/>
   <a:extLst>
     <a:ext uri="{05A4C25C-085E-4340-85A3-A5531E510DB2}">
-      <thm15:themeFamily xmlns:thm15="http://schemas.microsoft.com/office/thememl/2012/main" name="Presentación1" id="{B1CB6F6B-24A1-6F49-B872-82DD1AF8E1E6}" vid="{DD329C6C-F619-234E-8D9B-2B4F242E03AD}"/>
+      <ns1:themeFamily name="Presentación1" id="{B1CB6F6B-24A1-6F49-B872-82DD1AF8E1E6}" vid="{DD329C6C-F619-234E-8D9B-2B4F242E03AD}"/>
     </a:ext>
   </a:extLst>
 </a:theme>

</xml_diff>

<commit_message>
fix(plantillas): ids de layout duplicados hacian que PowerPoint reparara todo mazo
</commit_message>
<xml_diff>
--- a/api/inst/plantillas/plantilla_16_9.pptx
+++ b/api/inst/plantillas/plantilla_16_9.pptx
@@ -26165,8 +26165,8 @@
     <p:sldLayoutId id="2147483688" r:id="rId23"/>
     <p:sldLayoutId id="2147483703" r:id="rId24"/>
     <p:sldLayoutId id="2147483625" r:id="rId26"/>
-    <p:sldLayoutId id="2147483726" r:id="rId27"/>
-    <p:sldLayoutId id="2147483727" r:id="rId28"/>
+    <p:sldLayoutId id="2147483736" r:id="rId27"/>
+    <p:sldLayoutId id="2147483737" r:id="rId28"/>
     <p:sldLayoutId id="2147483728" r:id="rId29"/>
     <p:sldLayoutId id="2147483729" r:id="rId30"/>
     <p:sldLayoutId id="2147483730" r:id="rId31"/>

</xml_diff>